<commit_message>
Restructure deck around a Challenge-Response-Payoff-Advantage storyline
Give each use case a consistent narrative arc: a challenge framing sets the
tension, the pipeline shows how the signal responds, KPIs state the payoff,
and the feedback loop frames the compounding advantage. Sharpen both titles
to assert the answer.

Co-Authored-By: Claude Opus 4.8 <noreply@anthropic.com>
Claude-Session: https://claude.ai/code/session_01GCTqGNdEESpSQWeDYc3Jjg
</commit_message>
<xml_diff>
--- a/Liberty_Mutual_AI_Signals.pptx
+++ b/Liberty_Mutual_AI_Signals.pptx
@@ -972,7 +972,7 @@
         </p:nvSpPr>
         <p:spPr>
           <a:xfrm>
-            <a:off x="457200" y="384048"/>
+            <a:off x="457200" y="365760"/>
             <a:ext cx="7315200" cy="274320"/>
           </a:xfrm>
           <a:prstGeom prst="rect">
@@ -1011,7 +1011,7 @@
         </p:nvSpPr>
         <p:spPr>
           <a:xfrm>
-            <a:off x="457200" y="658368"/>
+            <a:off x="457200" y="640080"/>
             <a:ext cx="11247120" cy="566928"/>
           </a:xfrm>
           <a:prstGeom prst="rect">
@@ -1031,7 +1031,7 @@
               <a:buNone/>
             </a:pPr>
             <a:r>
-              <a:rPr lang="en-US" sz="2700" b="1" dirty="0">
+              <a:rPr lang="en-US" sz="2600" b="1" dirty="0">
                 <a:solidFill>
                   <a:srgbClr val="1A2333"/>
                 </a:solidFill>
@@ -1039,108 +1039,30 @@
                 <a:ea typeface="Cambria" pitchFamily="34" charset="-122"/>
                 <a:cs typeface="Cambria" pitchFamily="34" charset="-120"/>
               </a:rPr>
-              <a:t>Renewal Improvement: turning at-risk policies into retained premium</a:t>
-            </a:r>
-            <a:endParaRPr lang="en-US" sz="2700" dirty="0"/>
-          </a:p>
-        </p:txBody>
-      </p:sp>
-      <p:sp>
-        <p:nvSpPr>
-          <p:cNvPr id="4" name="Text 2"/>
-          <p:cNvSpPr/>
-          <p:nvPr/>
-        </p:nvSpPr>
-        <p:spPr>
-          <a:xfrm>
-            <a:off x="457200" y="1280160"/>
-            <a:ext cx="11247120" cy="365760"/>
-          </a:xfrm>
-          <a:prstGeom prst="rect">
-            <a:avLst/>
-          </a:prstGeom>
-          <a:noFill/>
-          <a:ln/>
-        </p:spPr>
-        <p:txBody>
-          <a:bodyPr wrap="square" lIns="0" tIns="0" rIns="0" bIns="0" rtlCol="0" anchor="ctr"/>
-          <a:lstStyle/>
-          <a:p>
-            <a:pPr indent="0" marL="0">
-              <a:buNone/>
-            </a:pPr>
-            <a:r>
-              <a:rPr lang="en-US" sz="1350" i="1" dirty="0">
-                <a:solidFill>
-                  <a:srgbClr val="2E6FB5"/>
-                </a:solidFill>
-                <a:latin typeface="Calibri" pitchFamily="34" charset="0"/>
-                <a:ea typeface="Calibri" pitchFamily="34" charset="-122"/>
-                <a:cs typeface="Calibri" pitchFamily="34" charset="-120"/>
-              </a:rPr>
-              <a:t>A daily churn signal flags renewal risk 60–90 days out and drives the right retention action on the policies where it changes the outcome.</a:t>
-            </a:r>
-            <a:endParaRPr lang="en-US" sz="1350" dirty="0"/>
-          </a:p>
-        </p:txBody>
-      </p:sp>
-      <p:sp>
-        <p:nvSpPr>
-          <p:cNvPr id="5" name="Text 3"/>
-          <p:cNvSpPr/>
-          <p:nvPr/>
-        </p:nvSpPr>
-        <p:spPr>
-          <a:xfrm>
-            <a:off x="457200" y="1755648"/>
-            <a:ext cx="5486400" cy="256032"/>
-          </a:xfrm>
-          <a:prstGeom prst="rect">
-            <a:avLst/>
-          </a:prstGeom>
-          <a:noFill/>
-          <a:ln/>
-        </p:spPr>
-        <p:txBody>
-          <a:bodyPr wrap="square" lIns="0" tIns="0" rIns="0" bIns="0" rtlCol="0" anchor="ctr"/>
-          <a:lstStyle/>
-          <a:p>
-            <a:pPr indent="0" marL="0">
-              <a:buNone/>
-            </a:pPr>
-            <a:r>
-              <a:rPr lang="en-US" sz="1100" b="1" spc="200" kern="0" dirty="0">
-                <a:solidFill>
-                  <a:srgbClr val="12315B"/>
-                </a:solidFill>
-                <a:latin typeface="Calibri" pitchFamily="34" charset="0"/>
-                <a:ea typeface="Calibri" pitchFamily="34" charset="-122"/>
-                <a:cs typeface="Calibri" pitchFamily="34" charset="-120"/>
-              </a:rPr>
-              <a:t>END-TO-END JOURNEY</a:t>
-            </a:r>
-            <a:endParaRPr lang="en-US" sz="1100" dirty="0"/>
-          </a:p>
-        </p:txBody>
-      </p:sp>
-      <p:sp>
-        <p:nvSpPr>
-          <p:cNvPr id="6" name="Shape 4"/>
-          <p:cNvSpPr/>
-          <p:nvPr/>
-        </p:nvSpPr>
-        <p:spPr>
-          <a:xfrm>
-            <a:off x="457200" y="2084832"/>
-            <a:ext cx="2044598" cy="2286000"/>
+              <a:t>Renewal Improvement: a churn signal that protects premium before customers walk</a:t>
+            </a:r>
+            <a:endParaRPr lang="en-US" sz="2600" dirty="0"/>
+          </a:p>
+        </p:txBody>
+      </p:sp>
+      <p:sp>
+        <p:nvSpPr>
+          <p:cNvPr id="4" name="Shape 2"/>
+          <p:cNvSpPr/>
+          <p:nvPr/>
+        </p:nvSpPr>
+        <p:spPr>
+          <a:xfrm>
+            <a:off x="457200" y="1298448"/>
+            <a:ext cx="11247120" cy="512064"/>
           </a:xfrm>
           <a:prstGeom prst="roundRect">
             <a:avLst>
-              <a:gd name="adj" fmla="val 2236"/>
+              <a:gd name="adj" fmla="val 8929"/>
             </a:avLst>
           </a:prstGeom>
           <a:solidFill>
-            <a:srgbClr val="FFFFFF"/>
+            <a:srgbClr val="EAF1FA"/>
           </a:solidFill>
           <a:ln w="12700">
             <a:solidFill>
@@ -1152,13 +1074,132 @@
       </p:sp>
       <p:sp>
         <p:nvSpPr>
+          <p:cNvPr id="5" name="Text 3"/>
+          <p:cNvSpPr/>
+          <p:nvPr/>
+        </p:nvSpPr>
+        <p:spPr>
+          <a:xfrm>
+            <a:off x="685800" y="1298448"/>
+            <a:ext cx="10789920" cy="512064"/>
+          </a:xfrm>
+          <a:prstGeom prst="rect">
+            <a:avLst/>
+          </a:prstGeom>
+          <a:noFill/>
+          <a:ln/>
+        </p:spPr>
+        <p:txBody>
+          <a:bodyPr wrap="square" lIns="0" tIns="0" rIns="0" bIns="0" rtlCol="0" anchor="ctr"/>
+          <a:lstStyle/>
+          <a:p>
+            <a:pPr indent="0" marL="0">
+              <a:buNone/>
+            </a:pPr>
+            <a:r>
+              <a:rPr lang="en-US" sz="1100" b="1" spc="100" kern="0" dirty="0">
+                <a:solidFill>
+                  <a:srgbClr val="12315B"/>
+                </a:solidFill>
+                <a:latin typeface="Calibri" pitchFamily="34" charset="0"/>
+                <a:ea typeface="Calibri" pitchFamily="34" charset="-122"/>
+                <a:cs typeface="Calibri" pitchFamily="34" charset="-120"/>
+              </a:rPr>
+              <a:t>THE CHALLENGE    </a:t>
+            </a:r>
+            <a:pPr indent="0" marL="0">
+              <a:buNone/>
+            </a:pPr>
+            <a:r>
+              <a:rPr lang="en-US" sz="1250" i="1" dirty="0">
+                <a:solidFill>
+                  <a:srgbClr val="1A2333"/>
+                </a:solidFill>
+                <a:latin typeface="Calibri" pitchFamily="34" charset="0"/>
+                <a:ea typeface="Calibri" pitchFamily="34" charset="-122"/>
+                <a:cs typeface="Calibri" pitchFamily="34" charset="-120"/>
+              </a:rPr>
+              <a:t>Most lapses are predictable and preventable — yet retention effort is spread evenly, spent late, and aimed at the wrong policies.</a:t>
+            </a:r>
+            <a:endParaRPr lang="en-US" sz="1100" dirty="0"/>
+          </a:p>
+        </p:txBody>
+      </p:sp>
+      <p:sp>
+        <p:nvSpPr>
+          <p:cNvPr id="6" name="Text 4"/>
+          <p:cNvSpPr/>
+          <p:nvPr/>
+        </p:nvSpPr>
+        <p:spPr>
+          <a:xfrm>
+            <a:off x="457200" y="1938528"/>
+            <a:ext cx="5486400" cy="256032"/>
+          </a:xfrm>
+          <a:prstGeom prst="rect">
+            <a:avLst/>
+          </a:prstGeom>
+          <a:noFill/>
+          <a:ln/>
+        </p:spPr>
+        <p:txBody>
+          <a:bodyPr wrap="square" lIns="0" tIns="0" rIns="0" bIns="0" rtlCol="0" anchor="ctr"/>
+          <a:lstStyle/>
+          <a:p>
+            <a:pPr indent="0" marL="0">
+              <a:buNone/>
+            </a:pPr>
+            <a:r>
+              <a:rPr lang="en-US" sz="1100" b="1" spc="200" kern="0" dirty="0">
+                <a:solidFill>
+                  <a:srgbClr val="12315B"/>
+                </a:solidFill>
+                <a:latin typeface="Calibri" pitchFamily="34" charset="0"/>
+                <a:ea typeface="Calibri" pitchFamily="34" charset="-122"/>
+                <a:cs typeface="Calibri" pitchFamily="34" charset="-120"/>
+              </a:rPr>
+              <a:t>HOW THE SIGNAL RESPONDS</a:t>
+            </a:r>
+            <a:endParaRPr lang="en-US" sz="1100" dirty="0"/>
+          </a:p>
+        </p:txBody>
+      </p:sp>
+      <p:sp>
+        <p:nvSpPr>
           <p:cNvPr id="7" name="Shape 5"/>
           <p:cNvSpPr/>
           <p:nvPr/>
         </p:nvSpPr>
         <p:spPr>
           <a:xfrm>
-            <a:off x="603504" y="2231136"/>
+            <a:off x="457200" y="2249424"/>
+            <a:ext cx="2044598" cy="2103120"/>
+          </a:xfrm>
+          <a:prstGeom prst="roundRect">
+            <a:avLst>
+              <a:gd name="adj" fmla="val 2236"/>
+            </a:avLst>
+          </a:prstGeom>
+          <a:solidFill>
+            <a:srgbClr val="FFFFFF"/>
+          </a:solidFill>
+          <a:ln w="12700">
+            <a:solidFill>
+              <a:srgbClr val="D3DCEA"/>
+            </a:solidFill>
+            <a:prstDash val="solid"/>
+          </a:ln>
+        </p:spPr>
+      </p:sp>
+      <p:sp>
+        <p:nvSpPr>
+          <p:cNvPr id="8" name="Shape 6"/>
+          <p:cNvSpPr/>
+          <p:nvPr/>
+        </p:nvSpPr>
+        <p:spPr>
+          <a:xfrm>
+            <a:off x="603504" y="2395728"/>
             <a:ext cx="365760" cy="365760"/>
           </a:xfrm>
           <a:prstGeom prst="roundRect">
@@ -1174,13 +1215,13 @@
       </p:sp>
       <p:sp>
         <p:nvSpPr>
-          <p:cNvPr id="8" name="Text 6"/>
-          <p:cNvSpPr/>
-          <p:nvPr/>
-        </p:nvSpPr>
-        <p:spPr>
-          <a:xfrm>
-            <a:off x="603504" y="2231136"/>
+          <p:cNvPr id="9" name="Text 7"/>
+          <p:cNvSpPr/>
+          <p:nvPr/>
+        </p:nvSpPr>
+        <p:spPr>
+          <a:xfrm>
+            <a:off x="603504" y="2395728"/>
             <a:ext cx="365760" cy="365760"/>
           </a:xfrm>
           <a:prstGeom prst="rect">
@@ -1213,13 +1254,13 @@
       </p:sp>
       <p:sp>
         <p:nvSpPr>
-          <p:cNvPr id="9" name="Text 7"/>
-          <p:cNvSpPr/>
-          <p:nvPr/>
-        </p:nvSpPr>
-        <p:spPr>
-          <a:xfrm>
-            <a:off x="1060704" y="2212848"/>
+          <p:cNvPr id="10" name="Text 8"/>
+          <p:cNvSpPr/>
+          <p:nvPr/>
+        </p:nvSpPr>
+        <p:spPr>
+          <a:xfrm>
+            <a:off x="1060704" y="2377440"/>
             <a:ext cx="1313078" cy="640080"/>
           </a:xfrm>
           <a:prstGeom prst="rect">
@@ -1255,13 +1296,13 @@
       </p:sp>
       <p:sp>
         <p:nvSpPr>
-          <p:cNvPr id="10" name="Shape 8"/>
-          <p:cNvSpPr/>
-          <p:nvPr/>
-        </p:nvSpPr>
-        <p:spPr>
-          <a:xfrm>
-            <a:off x="640080" y="3008376"/>
+          <p:cNvPr id="11" name="Shape 9"/>
+          <p:cNvSpPr/>
+          <p:nvPr/>
+        </p:nvSpPr>
+        <p:spPr>
+          <a:xfrm>
+            <a:off x="640080" y="3172968"/>
             <a:ext cx="73152" cy="73152"/>
           </a:xfrm>
           <a:prstGeom prst="rect">
@@ -1275,14 +1316,14 @@
       </p:sp>
       <p:sp>
         <p:nvSpPr>
-          <p:cNvPr id="11" name="Text 9"/>
-          <p:cNvSpPr/>
-          <p:nvPr/>
-        </p:nvSpPr>
-        <p:spPr>
-          <a:xfrm>
-            <a:off x="804672" y="2926080"/>
-            <a:ext cx="1532534" cy="566928"/>
+          <p:cNvPr id="12" name="Text 10"/>
+          <p:cNvSpPr/>
+          <p:nvPr/>
+        </p:nvSpPr>
+        <p:spPr>
+          <a:xfrm>
+            <a:off x="804672" y="3090672"/>
+            <a:ext cx="1532534" cy="548640"/>
           </a:xfrm>
           <a:prstGeom prst="rect">
             <a:avLst/>
@@ -1317,13 +1358,13 @@
       </p:sp>
       <p:sp>
         <p:nvSpPr>
-          <p:cNvPr id="12" name="Shape 10"/>
-          <p:cNvSpPr/>
-          <p:nvPr/>
-        </p:nvSpPr>
-        <p:spPr>
-          <a:xfrm>
-            <a:off x="640080" y="3611880"/>
+          <p:cNvPr id="13" name="Shape 11"/>
+          <p:cNvSpPr/>
+          <p:nvPr/>
+        </p:nvSpPr>
+        <p:spPr>
+          <a:xfrm>
+            <a:off x="640080" y="3758184"/>
             <a:ext cx="73152" cy="73152"/>
           </a:xfrm>
           <a:prstGeom prst="rect">
@@ -1337,14 +1378,14 @@
       </p:sp>
       <p:sp>
         <p:nvSpPr>
-          <p:cNvPr id="13" name="Text 11"/>
-          <p:cNvSpPr/>
-          <p:nvPr/>
-        </p:nvSpPr>
-        <p:spPr>
-          <a:xfrm>
-            <a:off x="804672" y="3529584"/>
-            <a:ext cx="1532534" cy="566928"/>
+          <p:cNvPr id="14" name="Text 12"/>
+          <p:cNvSpPr/>
+          <p:nvPr/>
+        </p:nvSpPr>
+        <p:spPr>
+          <a:xfrm>
+            <a:off x="804672" y="3675888"/>
+            <a:ext cx="1532534" cy="548640"/>
           </a:xfrm>
           <a:prstGeom prst="rect">
             <a:avLst/>
@@ -1379,13 +1420,13 @@
       </p:sp>
       <p:sp>
         <p:nvSpPr>
-          <p:cNvPr id="14" name="Shape 12"/>
-          <p:cNvSpPr/>
-          <p:nvPr/>
-        </p:nvSpPr>
-        <p:spPr>
-          <a:xfrm>
-            <a:off x="2483510" y="3099816"/>
+          <p:cNvPr id="15" name="Shape 13"/>
+          <p:cNvSpPr/>
+          <p:nvPr/>
+        </p:nvSpPr>
+        <p:spPr>
+          <a:xfrm>
+            <a:off x="2483510" y="3172968"/>
             <a:ext cx="292608" cy="256032"/>
           </a:xfrm>
           <a:prstGeom prst="chevron">
@@ -1404,14 +1445,14 @@
       </p:sp>
       <p:sp>
         <p:nvSpPr>
-          <p:cNvPr id="15" name="Shape 13"/>
-          <p:cNvSpPr/>
-          <p:nvPr/>
-        </p:nvSpPr>
-        <p:spPr>
-          <a:xfrm>
-            <a:off x="2757830" y="2084832"/>
-            <a:ext cx="2044598" cy="2286000"/>
+          <p:cNvPr id="16" name="Shape 14"/>
+          <p:cNvSpPr/>
+          <p:nvPr/>
+        </p:nvSpPr>
+        <p:spPr>
+          <a:xfrm>
+            <a:off x="2757830" y="2249424"/>
+            <a:ext cx="2044598" cy="2103120"/>
           </a:xfrm>
           <a:prstGeom prst="roundRect">
             <a:avLst>
@@ -1431,13 +1472,13 @@
       </p:sp>
       <p:sp>
         <p:nvSpPr>
-          <p:cNvPr id="16" name="Shape 14"/>
-          <p:cNvSpPr/>
-          <p:nvPr/>
-        </p:nvSpPr>
-        <p:spPr>
-          <a:xfrm>
-            <a:off x="2904134" y="2231136"/>
+          <p:cNvPr id="17" name="Shape 15"/>
+          <p:cNvSpPr/>
+          <p:nvPr/>
+        </p:nvSpPr>
+        <p:spPr>
+          <a:xfrm>
+            <a:off x="2904134" y="2395728"/>
             <a:ext cx="365760" cy="365760"/>
           </a:xfrm>
           <a:prstGeom prst="roundRect">
@@ -1453,13 +1494,13 @@
       </p:sp>
       <p:sp>
         <p:nvSpPr>
-          <p:cNvPr id="17" name="Text 15"/>
-          <p:cNvSpPr/>
-          <p:nvPr/>
-        </p:nvSpPr>
-        <p:spPr>
-          <a:xfrm>
-            <a:off x="2904134" y="2231136"/>
+          <p:cNvPr id="18" name="Text 16"/>
+          <p:cNvSpPr/>
+          <p:nvPr/>
+        </p:nvSpPr>
+        <p:spPr>
+          <a:xfrm>
+            <a:off x="2904134" y="2395728"/>
             <a:ext cx="365760" cy="365760"/>
           </a:xfrm>
           <a:prstGeom prst="rect">
@@ -1492,13 +1533,13 @@
       </p:sp>
       <p:sp>
         <p:nvSpPr>
-          <p:cNvPr id="18" name="Text 16"/>
-          <p:cNvSpPr/>
-          <p:nvPr/>
-        </p:nvSpPr>
-        <p:spPr>
-          <a:xfrm>
-            <a:off x="3361334" y="2212848"/>
+          <p:cNvPr id="19" name="Text 17"/>
+          <p:cNvSpPr/>
+          <p:nvPr/>
+        </p:nvSpPr>
+        <p:spPr>
+          <a:xfrm>
+            <a:off x="3361334" y="2377440"/>
             <a:ext cx="1313078" cy="640080"/>
           </a:xfrm>
           <a:prstGeom prst="rect">
@@ -1534,13 +1575,13 @@
       </p:sp>
       <p:sp>
         <p:nvSpPr>
-          <p:cNvPr id="19" name="Shape 17"/>
-          <p:cNvSpPr/>
-          <p:nvPr/>
-        </p:nvSpPr>
-        <p:spPr>
-          <a:xfrm>
-            <a:off x="2940710" y="3008376"/>
+          <p:cNvPr id="20" name="Shape 18"/>
+          <p:cNvSpPr/>
+          <p:nvPr/>
+        </p:nvSpPr>
+        <p:spPr>
+          <a:xfrm>
+            <a:off x="2940710" y="3172968"/>
             <a:ext cx="73152" cy="73152"/>
           </a:xfrm>
           <a:prstGeom prst="rect">
@@ -1554,14 +1595,14 @@
       </p:sp>
       <p:sp>
         <p:nvSpPr>
-          <p:cNvPr id="20" name="Text 18"/>
-          <p:cNvSpPr/>
-          <p:nvPr/>
-        </p:nvSpPr>
-        <p:spPr>
-          <a:xfrm>
-            <a:off x="3105302" y="2926080"/>
-            <a:ext cx="1532534" cy="566928"/>
+          <p:cNvPr id="21" name="Text 19"/>
+          <p:cNvSpPr/>
+          <p:nvPr/>
+        </p:nvSpPr>
+        <p:spPr>
+          <a:xfrm>
+            <a:off x="3105302" y="3090672"/>
+            <a:ext cx="1532534" cy="548640"/>
           </a:xfrm>
           <a:prstGeom prst="rect">
             <a:avLst/>
@@ -1596,13 +1637,13 @@
       </p:sp>
       <p:sp>
         <p:nvSpPr>
-          <p:cNvPr id="21" name="Shape 19"/>
-          <p:cNvSpPr/>
-          <p:nvPr/>
-        </p:nvSpPr>
-        <p:spPr>
-          <a:xfrm>
-            <a:off x="2940710" y="3611880"/>
+          <p:cNvPr id="22" name="Shape 20"/>
+          <p:cNvSpPr/>
+          <p:nvPr/>
+        </p:nvSpPr>
+        <p:spPr>
+          <a:xfrm>
+            <a:off x="2940710" y="3758184"/>
             <a:ext cx="73152" cy="73152"/>
           </a:xfrm>
           <a:prstGeom prst="rect">
@@ -1616,14 +1657,14 @@
       </p:sp>
       <p:sp>
         <p:nvSpPr>
-          <p:cNvPr id="22" name="Text 20"/>
-          <p:cNvSpPr/>
-          <p:nvPr/>
-        </p:nvSpPr>
-        <p:spPr>
-          <a:xfrm>
-            <a:off x="3105302" y="3529584"/>
-            <a:ext cx="1532534" cy="566928"/>
+          <p:cNvPr id="23" name="Text 21"/>
+          <p:cNvSpPr/>
+          <p:nvPr/>
+        </p:nvSpPr>
+        <p:spPr>
+          <a:xfrm>
+            <a:off x="3105302" y="3675888"/>
+            <a:ext cx="1532534" cy="548640"/>
           </a:xfrm>
           <a:prstGeom prst="rect">
             <a:avLst/>
@@ -1658,13 +1699,13 @@
       </p:sp>
       <p:sp>
         <p:nvSpPr>
-          <p:cNvPr id="23" name="Shape 21"/>
-          <p:cNvSpPr/>
-          <p:nvPr/>
-        </p:nvSpPr>
-        <p:spPr>
-          <a:xfrm>
-            <a:off x="4784141" y="3099816"/>
+          <p:cNvPr id="24" name="Shape 22"/>
+          <p:cNvSpPr/>
+          <p:nvPr/>
+        </p:nvSpPr>
+        <p:spPr>
+          <a:xfrm>
+            <a:off x="4784141" y="3172968"/>
             <a:ext cx="292608" cy="256032"/>
           </a:xfrm>
           <a:prstGeom prst="chevron">
@@ -1683,14 +1724,14 @@
       </p:sp>
       <p:sp>
         <p:nvSpPr>
-          <p:cNvPr id="24" name="Shape 22"/>
-          <p:cNvSpPr/>
-          <p:nvPr/>
-        </p:nvSpPr>
-        <p:spPr>
-          <a:xfrm>
-            <a:off x="5058461" y="2084832"/>
-            <a:ext cx="2044598" cy="2286000"/>
+          <p:cNvPr id="25" name="Shape 23"/>
+          <p:cNvSpPr/>
+          <p:nvPr/>
+        </p:nvSpPr>
+        <p:spPr>
+          <a:xfrm>
+            <a:off x="5058461" y="2249424"/>
+            <a:ext cx="2044598" cy="2103120"/>
           </a:xfrm>
           <a:prstGeom prst="roundRect">
             <a:avLst>
@@ -1710,13 +1751,13 @@
       </p:sp>
       <p:sp>
         <p:nvSpPr>
-          <p:cNvPr id="25" name="Shape 23"/>
-          <p:cNvSpPr/>
-          <p:nvPr/>
-        </p:nvSpPr>
-        <p:spPr>
-          <a:xfrm>
-            <a:off x="5204765" y="2231136"/>
+          <p:cNvPr id="26" name="Shape 24"/>
+          <p:cNvSpPr/>
+          <p:nvPr/>
+        </p:nvSpPr>
+        <p:spPr>
+          <a:xfrm>
+            <a:off x="5204765" y="2395728"/>
             <a:ext cx="365760" cy="365760"/>
           </a:xfrm>
           <a:prstGeom prst="roundRect">
@@ -1732,13 +1773,13 @@
       </p:sp>
       <p:sp>
         <p:nvSpPr>
-          <p:cNvPr id="26" name="Text 24"/>
-          <p:cNvSpPr/>
-          <p:nvPr/>
-        </p:nvSpPr>
-        <p:spPr>
-          <a:xfrm>
-            <a:off x="5204765" y="2231136"/>
+          <p:cNvPr id="27" name="Text 25"/>
+          <p:cNvSpPr/>
+          <p:nvPr/>
+        </p:nvSpPr>
+        <p:spPr>
+          <a:xfrm>
+            <a:off x="5204765" y="2395728"/>
             <a:ext cx="365760" cy="365760"/>
           </a:xfrm>
           <a:prstGeom prst="rect">
@@ -1771,13 +1812,13 @@
       </p:sp>
       <p:sp>
         <p:nvSpPr>
-          <p:cNvPr id="27" name="Text 25"/>
-          <p:cNvSpPr/>
-          <p:nvPr/>
-        </p:nvSpPr>
-        <p:spPr>
-          <a:xfrm>
-            <a:off x="5661965" y="2212848"/>
+          <p:cNvPr id="28" name="Text 26"/>
+          <p:cNvSpPr/>
+          <p:nvPr/>
+        </p:nvSpPr>
+        <p:spPr>
+          <a:xfrm>
+            <a:off x="5661965" y="2377440"/>
             <a:ext cx="1313078" cy="640080"/>
           </a:xfrm>
           <a:prstGeom prst="rect">
@@ -1813,13 +1854,13 @@
       </p:sp>
       <p:sp>
         <p:nvSpPr>
-          <p:cNvPr id="28" name="Shape 26"/>
-          <p:cNvSpPr/>
-          <p:nvPr/>
-        </p:nvSpPr>
-        <p:spPr>
-          <a:xfrm>
-            <a:off x="5241341" y="3008376"/>
+          <p:cNvPr id="29" name="Shape 27"/>
+          <p:cNvSpPr/>
+          <p:nvPr/>
+        </p:nvSpPr>
+        <p:spPr>
+          <a:xfrm>
+            <a:off x="5241341" y="3172968"/>
             <a:ext cx="73152" cy="73152"/>
           </a:xfrm>
           <a:prstGeom prst="rect">
@@ -1833,14 +1874,14 @@
       </p:sp>
       <p:sp>
         <p:nvSpPr>
-          <p:cNvPr id="29" name="Text 27"/>
-          <p:cNvSpPr/>
-          <p:nvPr/>
-        </p:nvSpPr>
-        <p:spPr>
-          <a:xfrm>
-            <a:off x="5405933" y="2926080"/>
-            <a:ext cx="1532534" cy="566928"/>
+          <p:cNvPr id="30" name="Text 28"/>
+          <p:cNvSpPr/>
+          <p:nvPr/>
+        </p:nvSpPr>
+        <p:spPr>
+          <a:xfrm>
+            <a:off x="5405933" y="3090672"/>
+            <a:ext cx="1532534" cy="548640"/>
           </a:xfrm>
           <a:prstGeom prst="rect">
             <a:avLst/>
@@ -1875,13 +1916,13 @@
       </p:sp>
       <p:sp>
         <p:nvSpPr>
-          <p:cNvPr id="30" name="Shape 28"/>
-          <p:cNvSpPr/>
-          <p:nvPr/>
-        </p:nvSpPr>
-        <p:spPr>
-          <a:xfrm>
-            <a:off x="5241341" y="3611880"/>
+          <p:cNvPr id="31" name="Shape 29"/>
+          <p:cNvSpPr/>
+          <p:nvPr/>
+        </p:nvSpPr>
+        <p:spPr>
+          <a:xfrm>
+            <a:off x="5241341" y="3758184"/>
             <a:ext cx="73152" cy="73152"/>
           </a:xfrm>
           <a:prstGeom prst="rect">
@@ -1895,14 +1936,14 @@
       </p:sp>
       <p:sp>
         <p:nvSpPr>
-          <p:cNvPr id="31" name="Text 29"/>
-          <p:cNvSpPr/>
-          <p:nvPr/>
-        </p:nvSpPr>
-        <p:spPr>
-          <a:xfrm>
-            <a:off x="5405933" y="3529584"/>
-            <a:ext cx="1532534" cy="566928"/>
+          <p:cNvPr id="32" name="Text 30"/>
+          <p:cNvSpPr/>
+          <p:nvPr/>
+        </p:nvSpPr>
+        <p:spPr>
+          <a:xfrm>
+            <a:off x="5405933" y="3675888"/>
+            <a:ext cx="1532534" cy="548640"/>
           </a:xfrm>
           <a:prstGeom prst="rect">
             <a:avLst/>
@@ -1937,13 +1978,13 @@
       </p:sp>
       <p:sp>
         <p:nvSpPr>
-          <p:cNvPr id="32" name="Shape 30"/>
-          <p:cNvSpPr/>
-          <p:nvPr/>
-        </p:nvSpPr>
-        <p:spPr>
-          <a:xfrm>
-            <a:off x="7084771" y="3099816"/>
+          <p:cNvPr id="33" name="Shape 31"/>
+          <p:cNvSpPr/>
+          <p:nvPr/>
+        </p:nvSpPr>
+        <p:spPr>
+          <a:xfrm>
+            <a:off x="7084771" y="3172968"/>
             <a:ext cx="292608" cy="256032"/>
           </a:xfrm>
           <a:prstGeom prst="chevron">
@@ -1962,14 +2003,14 @@
       </p:sp>
       <p:sp>
         <p:nvSpPr>
-          <p:cNvPr id="33" name="Shape 31"/>
-          <p:cNvSpPr/>
-          <p:nvPr/>
-        </p:nvSpPr>
-        <p:spPr>
-          <a:xfrm>
-            <a:off x="7359091" y="2084832"/>
-            <a:ext cx="2044598" cy="2286000"/>
+          <p:cNvPr id="34" name="Shape 32"/>
+          <p:cNvSpPr/>
+          <p:nvPr/>
+        </p:nvSpPr>
+        <p:spPr>
+          <a:xfrm>
+            <a:off x="7359091" y="2249424"/>
+            <a:ext cx="2044598" cy="2103120"/>
           </a:xfrm>
           <a:prstGeom prst="roundRect">
             <a:avLst>
@@ -1989,13 +2030,13 @@
       </p:sp>
       <p:sp>
         <p:nvSpPr>
-          <p:cNvPr id="34" name="Shape 32"/>
-          <p:cNvSpPr/>
-          <p:nvPr/>
-        </p:nvSpPr>
-        <p:spPr>
-          <a:xfrm>
-            <a:off x="7505395" y="2231136"/>
+          <p:cNvPr id="35" name="Shape 33"/>
+          <p:cNvSpPr/>
+          <p:nvPr/>
+        </p:nvSpPr>
+        <p:spPr>
+          <a:xfrm>
+            <a:off x="7505395" y="2395728"/>
             <a:ext cx="365760" cy="365760"/>
           </a:xfrm>
           <a:prstGeom prst="roundRect">
@@ -2011,13 +2052,13 @@
       </p:sp>
       <p:sp>
         <p:nvSpPr>
-          <p:cNvPr id="35" name="Text 33"/>
-          <p:cNvSpPr/>
-          <p:nvPr/>
-        </p:nvSpPr>
-        <p:spPr>
-          <a:xfrm>
-            <a:off x="7505395" y="2231136"/>
+          <p:cNvPr id="36" name="Text 34"/>
+          <p:cNvSpPr/>
+          <p:nvPr/>
+        </p:nvSpPr>
+        <p:spPr>
+          <a:xfrm>
+            <a:off x="7505395" y="2395728"/>
             <a:ext cx="365760" cy="365760"/>
           </a:xfrm>
           <a:prstGeom prst="rect">
@@ -2050,13 +2091,13 @@
       </p:sp>
       <p:sp>
         <p:nvSpPr>
-          <p:cNvPr id="36" name="Text 34"/>
-          <p:cNvSpPr/>
-          <p:nvPr/>
-        </p:nvSpPr>
-        <p:spPr>
-          <a:xfrm>
-            <a:off x="7962595" y="2212848"/>
+          <p:cNvPr id="37" name="Text 35"/>
+          <p:cNvSpPr/>
+          <p:nvPr/>
+        </p:nvSpPr>
+        <p:spPr>
+          <a:xfrm>
+            <a:off x="7962595" y="2377440"/>
             <a:ext cx="1313078" cy="640080"/>
           </a:xfrm>
           <a:prstGeom prst="rect">
@@ -2092,13 +2133,13 @@
       </p:sp>
       <p:sp>
         <p:nvSpPr>
-          <p:cNvPr id="37" name="Shape 35"/>
-          <p:cNvSpPr/>
-          <p:nvPr/>
-        </p:nvSpPr>
-        <p:spPr>
-          <a:xfrm>
-            <a:off x="7541971" y="3008376"/>
+          <p:cNvPr id="38" name="Shape 36"/>
+          <p:cNvSpPr/>
+          <p:nvPr/>
+        </p:nvSpPr>
+        <p:spPr>
+          <a:xfrm>
+            <a:off x="7541971" y="3172968"/>
             <a:ext cx="73152" cy="73152"/>
           </a:xfrm>
           <a:prstGeom prst="rect">
@@ -2112,14 +2153,14 @@
       </p:sp>
       <p:sp>
         <p:nvSpPr>
-          <p:cNvPr id="38" name="Text 36"/>
-          <p:cNvSpPr/>
-          <p:nvPr/>
-        </p:nvSpPr>
-        <p:spPr>
-          <a:xfrm>
-            <a:off x="7706563" y="2926080"/>
-            <a:ext cx="1532534" cy="566928"/>
+          <p:cNvPr id="39" name="Text 37"/>
+          <p:cNvSpPr/>
+          <p:nvPr/>
+        </p:nvSpPr>
+        <p:spPr>
+          <a:xfrm>
+            <a:off x="7706563" y="3090672"/>
+            <a:ext cx="1532534" cy="548640"/>
           </a:xfrm>
           <a:prstGeom prst="rect">
             <a:avLst/>
@@ -2154,13 +2195,13 @@
       </p:sp>
       <p:sp>
         <p:nvSpPr>
-          <p:cNvPr id="39" name="Shape 37"/>
-          <p:cNvSpPr/>
-          <p:nvPr/>
-        </p:nvSpPr>
-        <p:spPr>
-          <a:xfrm>
-            <a:off x="7541971" y="3611880"/>
+          <p:cNvPr id="40" name="Shape 38"/>
+          <p:cNvSpPr/>
+          <p:nvPr/>
+        </p:nvSpPr>
+        <p:spPr>
+          <a:xfrm>
+            <a:off x="7541971" y="3758184"/>
             <a:ext cx="73152" cy="73152"/>
           </a:xfrm>
           <a:prstGeom prst="rect">
@@ -2174,14 +2215,14 @@
       </p:sp>
       <p:sp>
         <p:nvSpPr>
-          <p:cNvPr id="40" name="Text 38"/>
-          <p:cNvSpPr/>
-          <p:nvPr/>
-        </p:nvSpPr>
-        <p:spPr>
-          <a:xfrm>
-            <a:off x="7706563" y="3529584"/>
-            <a:ext cx="1532534" cy="566928"/>
+          <p:cNvPr id="41" name="Text 39"/>
+          <p:cNvSpPr/>
+          <p:nvPr/>
+        </p:nvSpPr>
+        <p:spPr>
+          <a:xfrm>
+            <a:off x="7706563" y="3675888"/>
+            <a:ext cx="1532534" cy="548640"/>
           </a:xfrm>
           <a:prstGeom prst="rect">
             <a:avLst/>
@@ -2216,13 +2257,13 @@
       </p:sp>
       <p:sp>
         <p:nvSpPr>
-          <p:cNvPr id="41" name="Shape 39"/>
-          <p:cNvSpPr/>
-          <p:nvPr/>
-        </p:nvSpPr>
-        <p:spPr>
-          <a:xfrm>
-            <a:off x="9385402" y="3099816"/>
+          <p:cNvPr id="42" name="Shape 40"/>
+          <p:cNvSpPr/>
+          <p:nvPr/>
+        </p:nvSpPr>
+        <p:spPr>
+          <a:xfrm>
+            <a:off x="9385402" y="3172968"/>
             <a:ext cx="292608" cy="256032"/>
           </a:xfrm>
           <a:prstGeom prst="chevron">
@@ -2241,14 +2282,14 @@
       </p:sp>
       <p:sp>
         <p:nvSpPr>
-          <p:cNvPr id="42" name="Shape 40"/>
-          <p:cNvSpPr/>
-          <p:nvPr/>
-        </p:nvSpPr>
-        <p:spPr>
-          <a:xfrm>
-            <a:off x="9659722" y="2084832"/>
-            <a:ext cx="2044598" cy="2286000"/>
+          <p:cNvPr id="43" name="Shape 41"/>
+          <p:cNvSpPr/>
+          <p:nvPr/>
+        </p:nvSpPr>
+        <p:spPr>
+          <a:xfrm>
+            <a:off x="9659722" y="2249424"/>
+            <a:ext cx="2044598" cy="2103120"/>
           </a:xfrm>
           <a:prstGeom prst="roundRect">
             <a:avLst>
@@ -2268,13 +2309,13 @@
       </p:sp>
       <p:sp>
         <p:nvSpPr>
-          <p:cNvPr id="43" name="Shape 41"/>
-          <p:cNvSpPr/>
-          <p:nvPr/>
-        </p:nvSpPr>
-        <p:spPr>
-          <a:xfrm>
-            <a:off x="9806026" y="2231136"/>
+          <p:cNvPr id="44" name="Shape 42"/>
+          <p:cNvSpPr/>
+          <p:nvPr/>
+        </p:nvSpPr>
+        <p:spPr>
+          <a:xfrm>
+            <a:off x="9806026" y="2395728"/>
             <a:ext cx="365760" cy="365760"/>
           </a:xfrm>
           <a:prstGeom prst="roundRect">
@@ -2290,13 +2331,13 @@
       </p:sp>
       <p:sp>
         <p:nvSpPr>
-          <p:cNvPr id="44" name="Text 42"/>
-          <p:cNvSpPr/>
-          <p:nvPr/>
-        </p:nvSpPr>
-        <p:spPr>
-          <a:xfrm>
-            <a:off x="9806026" y="2231136"/>
+          <p:cNvPr id="45" name="Text 43"/>
+          <p:cNvSpPr/>
+          <p:nvPr/>
+        </p:nvSpPr>
+        <p:spPr>
+          <a:xfrm>
+            <a:off x="9806026" y="2395728"/>
             <a:ext cx="365760" cy="365760"/>
           </a:xfrm>
           <a:prstGeom prst="rect">
@@ -2329,13 +2370,13 @@
       </p:sp>
       <p:sp>
         <p:nvSpPr>
-          <p:cNvPr id="45" name="Text 43"/>
-          <p:cNvSpPr/>
-          <p:nvPr/>
-        </p:nvSpPr>
-        <p:spPr>
-          <a:xfrm>
-            <a:off x="10263226" y="2212848"/>
+          <p:cNvPr id="46" name="Text 44"/>
+          <p:cNvSpPr/>
+          <p:nvPr/>
+        </p:nvSpPr>
+        <p:spPr>
+          <a:xfrm>
+            <a:off x="10263226" y="2377440"/>
             <a:ext cx="1313078" cy="640080"/>
           </a:xfrm>
           <a:prstGeom prst="rect">
@@ -2371,13 +2412,13 @@
       </p:sp>
       <p:sp>
         <p:nvSpPr>
-          <p:cNvPr id="46" name="Shape 44"/>
-          <p:cNvSpPr/>
-          <p:nvPr/>
-        </p:nvSpPr>
-        <p:spPr>
-          <a:xfrm>
-            <a:off x="9842602" y="3008376"/>
+          <p:cNvPr id="47" name="Shape 45"/>
+          <p:cNvSpPr/>
+          <p:nvPr/>
+        </p:nvSpPr>
+        <p:spPr>
+          <a:xfrm>
+            <a:off x="9842602" y="3172968"/>
             <a:ext cx="73152" cy="73152"/>
           </a:xfrm>
           <a:prstGeom prst="rect">
@@ -2391,14 +2432,14 @@
       </p:sp>
       <p:sp>
         <p:nvSpPr>
-          <p:cNvPr id="47" name="Text 45"/>
-          <p:cNvSpPr/>
-          <p:nvPr/>
-        </p:nvSpPr>
-        <p:spPr>
-          <a:xfrm>
-            <a:off x="10007194" y="2926080"/>
-            <a:ext cx="1532534" cy="566928"/>
+          <p:cNvPr id="48" name="Text 46"/>
+          <p:cNvSpPr/>
+          <p:nvPr/>
+        </p:nvSpPr>
+        <p:spPr>
+          <a:xfrm>
+            <a:off x="10007194" y="3090672"/>
+            <a:ext cx="1532534" cy="548640"/>
           </a:xfrm>
           <a:prstGeom prst="rect">
             <a:avLst/>
@@ -2433,13 +2474,13 @@
       </p:sp>
       <p:sp>
         <p:nvSpPr>
-          <p:cNvPr id="48" name="Shape 46"/>
-          <p:cNvSpPr/>
-          <p:nvPr/>
-        </p:nvSpPr>
-        <p:spPr>
-          <a:xfrm>
-            <a:off x="9842602" y="3611880"/>
+          <p:cNvPr id="49" name="Shape 47"/>
+          <p:cNvSpPr/>
+          <p:nvPr/>
+        </p:nvSpPr>
+        <p:spPr>
+          <a:xfrm>
+            <a:off x="9842602" y="3758184"/>
             <a:ext cx="73152" cy="73152"/>
           </a:xfrm>
           <a:prstGeom prst="rect">
@@ -2453,14 +2494,14 @@
       </p:sp>
       <p:sp>
         <p:nvSpPr>
-          <p:cNvPr id="49" name="Text 47"/>
-          <p:cNvSpPr/>
-          <p:nvPr/>
-        </p:nvSpPr>
-        <p:spPr>
-          <a:xfrm>
-            <a:off x="10007194" y="3529584"/>
-            <a:ext cx="1532534" cy="566928"/>
+          <p:cNvPr id="50" name="Text 48"/>
+          <p:cNvSpPr/>
+          <p:nvPr/>
+        </p:nvSpPr>
+        <p:spPr>
+          <a:xfrm>
+            <a:off x="10007194" y="3675888"/>
+            <a:ext cx="1532534" cy="548640"/>
           </a:xfrm>
           <a:prstGeom prst="rect">
             <a:avLst/>
@@ -2495,14 +2536,14 @@
       </p:sp>
       <p:sp>
         <p:nvSpPr>
-          <p:cNvPr id="50" name="Text 48"/>
-          <p:cNvSpPr/>
-          <p:nvPr/>
-        </p:nvSpPr>
-        <p:spPr>
-          <a:xfrm>
-            <a:off x="457200" y="4498848"/>
-            <a:ext cx="11247120" cy="292608"/>
+          <p:cNvPr id="51" name="Text 49"/>
+          <p:cNvSpPr/>
+          <p:nvPr/>
+        </p:nvSpPr>
+        <p:spPr>
+          <a:xfrm>
+            <a:off x="457200" y="4480560"/>
+            <a:ext cx="11247120" cy="274320"/>
           </a:xfrm>
           <a:prstGeom prst="rect">
             <a:avLst/>
@@ -2548,13 +2589,13 @@
       </p:sp>
       <p:sp>
         <p:nvSpPr>
-          <p:cNvPr id="51" name="Shape 49"/>
-          <p:cNvSpPr/>
-          <p:nvPr/>
-        </p:nvSpPr>
-        <p:spPr>
-          <a:xfrm>
-            <a:off x="457200" y="4864608"/>
+          <p:cNvPr id="52" name="Shape 50"/>
+          <p:cNvSpPr/>
+          <p:nvPr/>
+        </p:nvSpPr>
+        <p:spPr>
+          <a:xfrm>
+            <a:off x="457200" y="4828032"/>
             <a:ext cx="11247120" cy="0"/>
           </a:xfrm>
           <a:prstGeom prst="line">
@@ -2571,13 +2612,13 @@
       </p:sp>
       <p:sp>
         <p:nvSpPr>
-          <p:cNvPr id="52" name="Text 50"/>
-          <p:cNvSpPr/>
-          <p:nvPr/>
-        </p:nvSpPr>
-        <p:spPr>
-          <a:xfrm>
-            <a:off x="457200" y="4974336"/>
+          <p:cNvPr id="53" name="Text 51"/>
+          <p:cNvSpPr/>
+          <p:nvPr/>
+        </p:nvSpPr>
+        <p:spPr>
+          <a:xfrm>
+            <a:off x="457200" y="4937760"/>
             <a:ext cx="5486400" cy="256032"/>
           </a:xfrm>
           <a:prstGeom prst="rect">
@@ -2602,7 +2643,7 @@
                 <a:ea typeface="Calibri" pitchFamily="34" charset="-122"/>
                 <a:cs typeface="Calibri" pitchFamily="34" charset="-120"/>
               </a:rPr>
-              <a:t>PROOF OF VALUE</a:t>
+              <a:t>THE PAYOFF</a:t>
             </a:r>
             <a:endParaRPr lang="en-US" sz="1100" dirty="0"/>
           </a:p>
@@ -2610,18 +2651,18 @@
       </p:sp>
       <p:sp>
         <p:nvSpPr>
-          <p:cNvPr id="53" name="Shape 51"/>
-          <p:cNvSpPr/>
-          <p:nvPr/>
-        </p:nvSpPr>
-        <p:spPr>
-          <a:xfrm>
-            <a:off x="457200" y="5285232"/>
-            <a:ext cx="2103120" cy="1188720"/>
+          <p:cNvPr id="54" name="Shape 52"/>
+          <p:cNvSpPr/>
+          <p:nvPr/>
+        </p:nvSpPr>
+        <p:spPr>
+          <a:xfrm>
+            <a:off x="457200" y="5230368"/>
+            <a:ext cx="2103120" cy="1152144"/>
           </a:xfrm>
           <a:prstGeom prst="roundRect">
             <a:avLst>
-              <a:gd name="adj" fmla="val 4615"/>
+              <a:gd name="adj" fmla="val 4762"/>
             </a:avLst>
           </a:prstGeom>
           <a:solidFill>
@@ -2637,14 +2678,14 @@
       </p:sp>
       <p:sp>
         <p:nvSpPr>
-          <p:cNvPr id="54" name="Text 52"/>
-          <p:cNvSpPr/>
-          <p:nvPr/>
-        </p:nvSpPr>
-        <p:spPr>
-          <a:xfrm>
-            <a:off x="502920" y="5404104"/>
-            <a:ext cx="2011680" cy="457200"/>
+          <p:cNvPr id="55" name="Text 53"/>
+          <p:cNvSpPr/>
+          <p:nvPr/>
+        </p:nvSpPr>
+        <p:spPr>
+          <a:xfrm>
+            <a:off x="502920" y="5340096"/>
+            <a:ext cx="2011680" cy="438912"/>
           </a:xfrm>
           <a:prstGeom prst="rect">
             <a:avLst/>
@@ -2660,7 +2701,7 @@
               <a:buNone/>
             </a:pPr>
             <a:r>
-              <a:rPr lang="en-US" sz="2600" b="1" dirty="0">
+              <a:rPr lang="en-US" sz="2500" b="1" dirty="0">
                 <a:solidFill>
                   <a:srgbClr val="12315B"/>
                 </a:solidFill>
@@ -2684,20 +2725,20 @@
               </a:rPr>
               <a:t>pts</a:t>
             </a:r>
-            <a:endParaRPr lang="en-US" sz="2600" dirty="0"/>
-          </a:p>
-        </p:txBody>
-      </p:sp>
-      <p:sp>
-        <p:nvSpPr>
-          <p:cNvPr id="55" name="Text 53"/>
-          <p:cNvSpPr/>
-          <p:nvPr/>
-        </p:nvSpPr>
-        <p:spPr>
-          <a:xfrm>
-            <a:off x="548640" y="5907024"/>
-            <a:ext cx="1920240" cy="502920"/>
+            <a:endParaRPr lang="en-US" sz="2500" dirty="0"/>
+          </a:p>
+        </p:txBody>
+      </p:sp>
+      <p:sp>
+        <p:nvSpPr>
+          <p:cNvPr id="56" name="Text 54"/>
+          <p:cNvSpPr/>
+          <p:nvPr/>
+        </p:nvSpPr>
+        <p:spPr>
+          <a:xfrm>
+            <a:off x="548640" y="5815584"/>
+            <a:ext cx="1920240" cy="512064"/>
           </a:xfrm>
           <a:prstGeom prst="rect">
             <a:avLst/>
@@ -2732,18 +2773,18 @@
       </p:sp>
       <p:sp>
         <p:nvSpPr>
-          <p:cNvPr id="56" name="Shape 54"/>
-          <p:cNvSpPr/>
-          <p:nvPr/>
-        </p:nvSpPr>
-        <p:spPr>
-          <a:xfrm>
-            <a:off x="2743200" y="5285232"/>
-            <a:ext cx="2103120" cy="1188720"/>
+          <p:cNvPr id="57" name="Shape 55"/>
+          <p:cNvSpPr/>
+          <p:nvPr/>
+        </p:nvSpPr>
+        <p:spPr>
+          <a:xfrm>
+            <a:off x="2743200" y="5230368"/>
+            <a:ext cx="2103120" cy="1152144"/>
           </a:xfrm>
           <a:prstGeom prst="roundRect">
             <a:avLst>
-              <a:gd name="adj" fmla="val 4615"/>
+              <a:gd name="adj" fmla="val 4762"/>
             </a:avLst>
           </a:prstGeom>
           <a:solidFill>
@@ -2759,14 +2800,14 @@
       </p:sp>
       <p:sp>
         <p:nvSpPr>
-          <p:cNvPr id="57" name="Text 55"/>
-          <p:cNvSpPr/>
-          <p:nvPr/>
-        </p:nvSpPr>
-        <p:spPr>
-          <a:xfrm>
-            <a:off x="2788920" y="5404104"/>
-            <a:ext cx="2011680" cy="457200"/>
+          <p:cNvPr id="58" name="Text 56"/>
+          <p:cNvSpPr/>
+          <p:nvPr/>
+        </p:nvSpPr>
+        <p:spPr>
+          <a:xfrm>
+            <a:off x="2788920" y="5340096"/>
+            <a:ext cx="2011680" cy="438912"/>
           </a:xfrm>
           <a:prstGeom prst="rect">
             <a:avLst/>
@@ -2782,7 +2823,7 @@
               <a:buNone/>
             </a:pPr>
             <a:r>
-              <a:rPr lang="en-US" sz="2600" b="1" dirty="0">
+              <a:rPr lang="en-US" sz="2500" b="1" dirty="0">
                 <a:solidFill>
                   <a:srgbClr val="12315B"/>
                 </a:solidFill>
@@ -2795,20 +2836,20 @@
             <a:pPr algn="ctr" indent="0" marL="0">
               <a:buNone/>
             </a:pPr>
-            <a:endParaRPr lang="en-US" sz="2600" dirty="0"/>
-          </a:p>
-        </p:txBody>
-      </p:sp>
-      <p:sp>
-        <p:nvSpPr>
-          <p:cNvPr id="58" name="Text 56"/>
-          <p:cNvSpPr/>
-          <p:nvPr/>
-        </p:nvSpPr>
-        <p:spPr>
-          <a:xfrm>
-            <a:off x="2834640" y="5907024"/>
-            <a:ext cx="1920240" cy="502920"/>
+            <a:endParaRPr lang="en-US" sz="2500" dirty="0"/>
+          </a:p>
+        </p:txBody>
+      </p:sp>
+      <p:sp>
+        <p:nvSpPr>
+          <p:cNvPr id="59" name="Text 57"/>
+          <p:cNvSpPr/>
+          <p:nvPr/>
+        </p:nvSpPr>
+        <p:spPr>
+          <a:xfrm>
+            <a:off x="2834640" y="5815584"/>
+            <a:ext cx="1920240" cy="512064"/>
           </a:xfrm>
           <a:prstGeom prst="rect">
             <a:avLst/>
@@ -2843,18 +2884,18 @@
       </p:sp>
       <p:sp>
         <p:nvSpPr>
-          <p:cNvPr id="59" name="Shape 57"/>
-          <p:cNvSpPr/>
-          <p:nvPr/>
-        </p:nvSpPr>
-        <p:spPr>
-          <a:xfrm>
-            <a:off x="5029200" y="5285232"/>
-            <a:ext cx="2103120" cy="1188720"/>
+          <p:cNvPr id="60" name="Shape 58"/>
+          <p:cNvSpPr/>
+          <p:nvPr/>
+        </p:nvSpPr>
+        <p:spPr>
+          <a:xfrm>
+            <a:off x="5029200" y="5230368"/>
+            <a:ext cx="2103120" cy="1152144"/>
           </a:xfrm>
           <a:prstGeom prst="roundRect">
             <a:avLst>
-              <a:gd name="adj" fmla="val 4615"/>
+              <a:gd name="adj" fmla="val 4762"/>
             </a:avLst>
           </a:prstGeom>
           <a:solidFill>
@@ -2870,14 +2911,14 @@
       </p:sp>
       <p:sp>
         <p:nvSpPr>
-          <p:cNvPr id="60" name="Text 58"/>
-          <p:cNvSpPr/>
-          <p:nvPr/>
-        </p:nvSpPr>
-        <p:spPr>
-          <a:xfrm>
-            <a:off x="5074920" y="5404104"/>
-            <a:ext cx="2011680" cy="457200"/>
+          <p:cNvPr id="61" name="Text 59"/>
+          <p:cNvSpPr/>
+          <p:nvPr/>
+        </p:nvSpPr>
+        <p:spPr>
+          <a:xfrm>
+            <a:off x="5074920" y="5340096"/>
+            <a:ext cx="2011680" cy="438912"/>
           </a:xfrm>
           <a:prstGeom prst="rect">
             <a:avLst/>
@@ -2893,7 +2934,7 @@
               <a:buNone/>
             </a:pPr>
             <a:r>
-              <a:rPr lang="en-US" sz="2600" b="1" dirty="0">
+              <a:rPr lang="en-US" sz="2500" b="1" dirty="0">
                 <a:solidFill>
                   <a:srgbClr val="12315B"/>
                 </a:solidFill>
@@ -2917,20 +2958,20 @@
               </a:rPr>
               <a:t>d</a:t>
             </a:r>
-            <a:endParaRPr lang="en-US" sz="2600" dirty="0"/>
-          </a:p>
-        </p:txBody>
-      </p:sp>
-      <p:sp>
-        <p:nvSpPr>
-          <p:cNvPr id="61" name="Text 59"/>
-          <p:cNvSpPr/>
-          <p:nvPr/>
-        </p:nvSpPr>
-        <p:spPr>
-          <a:xfrm>
-            <a:off x="5120640" y="5907024"/>
-            <a:ext cx="1920240" cy="502920"/>
+            <a:endParaRPr lang="en-US" sz="2500" dirty="0"/>
+          </a:p>
+        </p:txBody>
+      </p:sp>
+      <p:sp>
+        <p:nvSpPr>
+          <p:cNvPr id="62" name="Text 60"/>
+          <p:cNvSpPr/>
+          <p:nvPr/>
+        </p:nvSpPr>
+        <p:spPr>
+          <a:xfrm>
+            <a:off x="5120640" y="5815584"/>
+            <a:ext cx="1920240" cy="512064"/>
           </a:xfrm>
           <a:prstGeom prst="rect">
             <a:avLst/>
@@ -2965,13 +3006,13 @@
       </p:sp>
       <p:sp>
         <p:nvSpPr>
-          <p:cNvPr id="62" name="Shape 60"/>
-          <p:cNvSpPr/>
-          <p:nvPr/>
-        </p:nvSpPr>
-        <p:spPr>
-          <a:xfrm>
-            <a:off x="7406640" y="4974336"/>
+          <p:cNvPr id="63" name="Shape 61"/>
+          <p:cNvSpPr/>
+          <p:nvPr/>
+        </p:nvSpPr>
+        <p:spPr>
+          <a:xfrm>
+            <a:off x="7406640" y="4937760"/>
             <a:ext cx="4297680" cy="1298448"/>
           </a:xfrm>
           <a:prstGeom prst="roundRect">
@@ -2987,13 +3028,13 @@
       </p:sp>
       <p:sp>
         <p:nvSpPr>
-          <p:cNvPr id="63" name="Text 61"/>
-          <p:cNvSpPr/>
-          <p:nvPr/>
-        </p:nvSpPr>
-        <p:spPr>
-          <a:xfrm>
-            <a:off x="7662672" y="5120640"/>
+          <p:cNvPr id="64" name="Text 62"/>
+          <p:cNvSpPr/>
+          <p:nvPr/>
+        </p:nvSpPr>
+        <p:spPr>
+          <a:xfrm>
+            <a:off x="7662672" y="5084064"/>
             <a:ext cx="3840480" cy="274320"/>
           </a:xfrm>
           <a:prstGeom prst="rect">
@@ -3018,7 +3059,7 @@
                 <a:ea typeface="Calibri" pitchFamily="34" charset="-122"/>
                 <a:cs typeface="Calibri" pitchFamily="34" charset="-120"/>
               </a:rPr>
-              <a:t>CONTINUOUS FEEDBACK LOOP</a:t>
+              <a:t>COMPOUNDING ADVANTAGE</a:t>
             </a:r>
             <a:endParaRPr lang="en-US" sz="1100" dirty="0"/>
           </a:p>
@@ -3026,13 +3067,13 @@
       </p:sp>
       <p:sp>
         <p:nvSpPr>
-          <p:cNvPr id="64" name="Text 62"/>
-          <p:cNvSpPr/>
-          <p:nvPr/>
-        </p:nvSpPr>
-        <p:spPr>
-          <a:xfrm>
-            <a:off x="7662672" y="5431536"/>
+          <p:cNvPr id="65" name="Text 63"/>
+          <p:cNvSpPr/>
+          <p:nvPr/>
+        </p:nvSpPr>
+        <p:spPr>
+          <a:xfrm>
+            <a:off x="7662672" y="5394960"/>
             <a:ext cx="3840480" cy="777240"/>
           </a:xfrm>
           <a:prstGeom prst="rect">
@@ -3068,7 +3109,7 @@
       </p:sp>
       <p:sp>
         <p:nvSpPr>
-          <p:cNvPr id="65" name="Shape 63"/>
+          <p:cNvPr id="66" name="Shape 64"/>
           <p:cNvSpPr/>
           <p:nvPr/>
         </p:nvSpPr>
@@ -3091,7 +3132,7 @@
       </p:sp>
       <p:sp>
         <p:nvSpPr>
-          <p:cNvPr id="66" name="Text 64"/>
+          <p:cNvPr id="67" name="Text 65"/>
           <p:cNvSpPr/>
           <p:nvPr/>
         </p:nvSpPr>
@@ -3130,7 +3171,7 @@
       </p:sp>
       <p:sp>
         <p:nvSpPr>
-          <p:cNvPr id="67" name="Text 65"/>
+          <p:cNvPr id="68" name="Text 66"/>
           <p:cNvSpPr/>
           <p:nvPr/>
         </p:nvSpPr>
@@ -3169,7 +3210,7 @@
       </p:sp>
       <p:sp>
         <p:nvSpPr>
-          <p:cNvPr id="68" name="Text 66"/>
+          <p:cNvPr id="69" name="Text 67"/>
           <p:cNvSpPr/>
           <p:nvPr/>
         </p:nvSpPr>
@@ -3246,7 +3287,7 @@
         </p:nvSpPr>
         <p:spPr>
           <a:xfrm>
-            <a:off x="457200" y="384048"/>
+            <a:off x="457200" y="365760"/>
             <a:ext cx="7315200" cy="274320"/>
           </a:xfrm>
           <a:prstGeom prst="rect">
@@ -3285,7 +3326,7 @@
         </p:nvSpPr>
         <p:spPr>
           <a:xfrm>
-            <a:off x="457200" y="658368"/>
+            <a:off x="457200" y="640080"/>
             <a:ext cx="11247120" cy="566928"/>
           </a:xfrm>
           <a:prstGeom prst="rect">
@@ -3305,7 +3346,7 @@
               <a:buNone/>
             </a:pPr>
             <a:r>
-              <a:rPr lang="en-US" sz="2700" b="1" dirty="0">
+              <a:rPr lang="en-US" sz="2600" b="1" dirty="0">
                 <a:solidFill>
                   <a:srgbClr val="1A2333"/>
                 </a:solidFill>
@@ -3313,108 +3354,30 @@
                 <a:ea typeface="Cambria" pitchFamily="34" charset="-122"/>
                 <a:cs typeface="Cambria" pitchFamily="34" charset="-120"/>
               </a:rPr>
-              <a:t>Underwriting of the Future: augmenting the underwriter, not replacing judgment</a:t>
-            </a:r>
-            <a:endParaRPr lang="en-US" sz="2700" dirty="0"/>
-          </a:p>
-        </p:txBody>
-      </p:sp>
-      <p:sp>
-        <p:nvSpPr>
-          <p:cNvPr id="4" name="Text 2"/>
-          <p:cNvSpPr/>
-          <p:nvPr/>
-        </p:nvSpPr>
-        <p:spPr>
-          <a:xfrm>
-            <a:off x="457200" y="1280160"/>
-            <a:ext cx="11247120" cy="365760"/>
-          </a:xfrm>
-          <a:prstGeom prst="rect">
-            <a:avLst/>
-          </a:prstGeom>
-          <a:noFill/>
-          <a:ln/>
-        </p:spPr>
-        <p:txBody>
-          <a:bodyPr wrap="square" lIns="0" tIns="0" rIns="0" bIns="0" rtlCol="0" anchor="ctr"/>
-          <a:lstStyle/>
-          <a:p>
-            <a:pPr indent="0" marL="0">
-              <a:buNone/>
-            </a:pPr>
-            <a:r>
-              <a:rPr lang="en-US" sz="1350" i="1" dirty="0">
-                <a:solidFill>
-                  <a:srgbClr val="2E6FB5"/>
-                </a:solidFill>
-                <a:latin typeface="Calibri" pitchFamily="34" charset="0"/>
-                <a:ea typeface="Calibri" pitchFamily="34" charset="-122"/>
-                <a:cs typeface="Calibri" pitchFamily="34" charset="-120"/>
-              </a:rPr>
-              <a:t>AI structures the submission, enriches the risk and pre-fills the decision — underwriters spend their time on the accounts that need a human.</a:t>
-            </a:r>
-            <a:endParaRPr lang="en-US" sz="1350" dirty="0"/>
-          </a:p>
-        </p:txBody>
-      </p:sp>
-      <p:sp>
-        <p:nvSpPr>
-          <p:cNvPr id="5" name="Text 3"/>
-          <p:cNvSpPr/>
-          <p:nvPr/>
-        </p:nvSpPr>
-        <p:spPr>
-          <a:xfrm>
-            <a:off x="457200" y="1755648"/>
-            <a:ext cx="5486400" cy="256032"/>
-          </a:xfrm>
-          <a:prstGeom prst="rect">
-            <a:avLst/>
-          </a:prstGeom>
-          <a:noFill/>
-          <a:ln/>
-        </p:spPr>
-        <p:txBody>
-          <a:bodyPr wrap="square" lIns="0" tIns="0" rIns="0" bIns="0" rtlCol="0" anchor="ctr"/>
-          <a:lstStyle/>
-          <a:p>
-            <a:pPr indent="0" marL="0">
-              <a:buNone/>
-            </a:pPr>
-            <a:r>
-              <a:rPr lang="en-US" sz="1100" b="1" spc="200" kern="0" dirty="0">
-                <a:solidFill>
-                  <a:srgbClr val="12315B"/>
-                </a:solidFill>
-                <a:latin typeface="Calibri" pitchFamily="34" charset="0"/>
-                <a:ea typeface="Calibri" pitchFamily="34" charset="-122"/>
-                <a:cs typeface="Calibri" pitchFamily="34" charset="-120"/>
-              </a:rPr>
-              <a:t>END-TO-END JOURNEY</a:t>
-            </a:r>
-            <a:endParaRPr lang="en-US" sz="1100" dirty="0"/>
-          </a:p>
-        </p:txBody>
-      </p:sp>
-      <p:sp>
-        <p:nvSpPr>
-          <p:cNvPr id="6" name="Shape 4"/>
-          <p:cNvSpPr/>
-          <p:nvPr/>
-        </p:nvSpPr>
-        <p:spPr>
-          <a:xfrm>
-            <a:off x="457200" y="2084832"/>
-            <a:ext cx="2044598" cy="2286000"/>
+              <a:t>Underwriting of the Future: write better risk faster by augmenting the underwriter</a:t>
+            </a:r>
+            <a:endParaRPr lang="en-US" sz="2600" dirty="0"/>
+          </a:p>
+        </p:txBody>
+      </p:sp>
+      <p:sp>
+        <p:nvSpPr>
+          <p:cNvPr id="4" name="Shape 2"/>
+          <p:cNvSpPr/>
+          <p:nvPr/>
+        </p:nvSpPr>
+        <p:spPr>
+          <a:xfrm>
+            <a:off x="457200" y="1298448"/>
+            <a:ext cx="11247120" cy="512064"/>
           </a:xfrm>
           <a:prstGeom prst="roundRect">
             <a:avLst>
-              <a:gd name="adj" fmla="val 2236"/>
+              <a:gd name="adj" fmla="val 8929"/>
             </a:avLst>
           </a:prstGeom>
           <a:solidFill>
-            <a:srgbClr val="FFFFFF"/>
+            <a:srgbClr val="EAF1FA"/>
           </a:solidFill>
           <a:ln w="12700">
             <a:solidFill>
@@ -3426,13 +3389,132 @@
       </p:sp>
       <p:sp>
         <p:nvSpPr>
+          <p:cNvPr id="5" name="Text 3"/>
+          <p:cNvSpPr/>
+          <p:nvPr/>
+        </p:nvSpPr>
+        <p:spPr>
+          <a:xfrm>
+            <a:off x="685800" y="1298448"/>
+            <a:ext cx="10789920" cy="512064"/>
+          </a:xfrm>
+          <a:prstGeom prst="rect">
+            <a:avLst/>
+          </a:prstGeom>
+          <a:noFill/>
+          <a:ln/>
+        </p:spPr>
+        <p:txBody>
+          <a:bodyPr wrap="square" lIns="0" tIns="0" rIns="0" bIns="0" rtlCol="0" anchor="ctr"/>
+          <a:lstStyle/>
+          <a:p>
+            <a:pPr indent="0" marL="0">
+              <a:buNone/>
+            </a:pPr>
+            <a:r>
+              <a:rPr lang="en-US" sz="1100" b="1" spc="100" kern="0" dirty="0">
+                <a:solidFill>
+                  <a:srgbClr val="12315B"/>
+                </a:solidFill>
+                <a:latin typeface="Calibri" pitchFamily="34" charset="0"/>
+                <a:ea typeface="Calibri" pitchFamily="34" charset="-122"/>
+                <a:cs typeface="Calibri" pitchFamily="34" charset="-120"/>
+              </a:rPr>
+              <a:t>THE CHALLENGE    </a:t>
+            </a:r>
+            <a:pPr indent="0" marL="0">
+              <a:buNone/>
+            </a:pPr>
+            <a:r>
+              <a:rPr lang="en-US" sz="1250" i="1" dirty="0">
+                <a:solidFill>
+                  <a:srgbClr val="1A2333"/>
+                </a:solidFill>
+                <a:latin typeface="Calibri" pitchFamily="34" charset="0"/>
+                <a:ea typeface="Calibri" pitchFamily="34" charset="-122"/>
+                <a:cs typeface="Calibri" pitchFamily="34" charset="-120"/>
+              </a:rPr>
+              <a:t>Manual intake and inconsistent risk selection slow quotes, drain underwriter capacity, and let mispriced accounts onto the book.</a:t>
+            </a:r>
+            <a:endParaRPr lang="en-US" sz="1100" dirty="0"/>
+          </a:p>
+        </p:txBody>
+      </p:sp>
+      <p:sp>
+        <p:nvSpPr>
+          <p:cNvPr id="6" name="Text 4"/>
+          <p:cNvSpPr/>
+          <p:nvPr/>
+        </p:nvSpPr>
+        <p:spPr>
+          <a:xfrm>
+            <a:off x="457200" y="1938528"/>
+            <a:ext cx="5486400" cy="256032"/>
+          </a:xfrm>
+          <a:prstGeom prst="rect">
+            <a:avLst/>
+          </a:prstGeom>
+          <a:noFill/>
+          <a:ln/>
+        </p:spPr>
+        <p:txBody>
+          <a:bodyPr wrap="square" lIns="0" tIns="0" rIns="0" bIns="0" rtlCol="0" anchor="ctr"/>
+          <a:lstStyle/>
+          <a:p>
+            <a:pPr indent="0" marL="0">
+              <a:buNone/>
+            </a:pPr>
+            <a:r>
+              <a:rPr lang="en-US" sz="1100" b="1" spc="200" kern="0" dirty="0">
+                <a:solidFill>
+                  <a:srgbClr val="12315B"/>
+                </a:solidFill>
+                <a:latin typeface="Calibri" pitchFamily="34" charset="0"/>
+                <a:ea typeface="Calibri" pitchFamily="34" charset="-122"/>
+                <a:cs typeface="Calibri" pitchFamily="34" charset="-120"/>
+              </a:rPr>
+              <a:t>HOW THE SIGNAL RESPONDS</a:t>
+            </a:r>
+            <a:endParaRPr lang="en-US" sz="1100" dirty="0"/>
+          </a:p>
+        </p:txBody>
+      </p:sp>
+      <p:sp>
+        <p:nvSpPr>
           <p:cNvPr id="7" name="Shape 5"/>
           <p:cNvSpPr/>
           <p:nvPr/>
         </p:nvSpPr>
         <p:spPr>
           <a:xfrm>
-            <a:off x="603504" y="2231136"/>
+            <a:off x="457200" y="2249424"/>
+            <a:ext cx="2044598" cy="2103120"/>
+          </a:xfrm>
+          <a:prstGeom prst="roundRect">
+            <a:avLst>
+              <a:gd name="adj" fmla="val 2236"/>
+            </a:avLst>
+          </a:prstGeom>
+          <a:solidFill>
+            <a:srgbClr val="FFFFFF"/>
+          </a:solidFill>
+          <a:ln w="12700">
+            <a:solidFill>
+              <a:srgbClr val="D3DCEA"/>
+            </a:solidFill>
+            <a:prstDash val="solid"/>
+          </a:ln>
+        </p:spPr>
+      </p:sp>
+      <p:sp>
+        <p:nvSpPr>
+          <p:cNvPr id="8" name="Shape 6"/>
+          <p:cNvSpPr/>
+          <p:nvPr/>
+        </p:nvSpPr>
+        <p:spPr>
+          <a:xfrm>
+            <a:off x="603504" y="2395728"/>
             <a:ext cx="365760" cy="365760"/>
           </a:xfrm>
           <a:prstGeom prst="roundRect">
@@ -3448,13 +3530,13 @@
       </p:sp>
       <p:sp>
         <p:nvSpPr>
-          <p:cNvPr id="8" name="Text 6"/>
-          <p:cNvSpPr/>
-          <p:nvPr/>
-        </p:nvSpPr>
-        <p:spPr>
-          <a:xfrm>
-            <a:off x="603504" y="2231136"/>
+          <p:cNvPr id="9" name="Text 7"/>
+          <p:cNvSpPr/>
+          <p:nvPr/>
+        </p:nvSpPr>
+        <p:spPr>
+          <a:xfrm>
+            <a:off x="603504" y="2395728"/>
             <a:ext cx="365760" cy="365760"/>
           </a:xfrm>
           <a:prstGeom prst="rect">
@@ -3487,13 +3569,13 @@
       </p:sp>
       <p:sp>
         <p:nvSpPr>
-          <p:cNvPr id="9" name="Text 7"/>
-          <p:cNvSpPr/>
-          <p:nvPr/>
-        </p:nvSpPr>
-        <p:spPr>
-          <a:xfrm>
-            <a:off x="1060704" y="2212848"/>
+          <p:cNvPr id="10" name="Text 8"/>
+          <p:cNvSpPr/>
+          <p:nvPr/>
+        </p:nvSpPr>
+        <p:spPr>
+          <a:xfrm>
+            <a:off x="1060704" y="2377440"/>
             <a:ext cx="1313078" cy="640080"/>
           </a:xfrm>
           <a:prstGeom prst="rect">
@@ -3529,13 +3611,13 @@
       </p:sp>
       <p:sp>
         <p:nvSpPr>
-          <p:cNvPr id="10" name="Shape 8"/>
-          <p:cNvSpPr/>
-          <p:nvPr/>
-        </p:nvSpPr>
-        <p:spPr>
-          <a:xfrm>
-            <a:off x="640080" y="3008376"/>
+          <p:cNvPr id="11" name="Shape 9"/>
+          <p:cNvSpPr/>
+          <p:nvPr/>
+        </p:nvSpPr>
+        <p:spPr>
+          <a:xfrm>
+            <a:off x="640080" y="3172968"/>
             <a:ext cx="73152" cy="73152"/>
           </a:xfrm>
           <a:prstGeom prst="rect">
@@ -3549,14 +3631,14 @@
       </p:sp>
       <p:sp>
         <p:nvSpPr>
-          <p:cNvPr id="11" name="Text 9"/>
-          <p:cNvSpPr/>
-          <p:nvPr/>
-        </p:nvSpPr>
-        <p:spPr>
-          <a:xfrm>
-            <a:off x="804672" y="2926080"/>
-            <a:ext cx="1532534" cy="566928"/>
+          <p:cNvPr id="12" name="Text 10"/>
+          <p:cNvSpPr/>
+          <p:nvPr/>
+        </p:nvSpPr>
+        <p:spPr>
+          <a:xfrm>
+            <a:off x="804672" y="3090672"/>
+            <a:ext cx="1532534" cy="548640"/>
           </a:xfrm>
           <a:prstGeom prst="rect">
             <a:avLst/>
@@ -3591,13 +3673,13 @@
       </p:sp>
       <p:sp>
         <p:nvSpPr>
-          <p:cNvPr id="12" name="Shape 10"/>
-          <p:cNvSpPr/>
-          <p:nvPr/>
-        </p:nvSpPr>
-        <p:spPr>
-          <a:xfrm>
-            <a:off x="640080" y="3611880"/>
+          <p:cNvPr id="13" name="Shape 11"/>
+          <p:cNvSpPr/>
+          <p:nvPr/>
+        </p:nvSpPr>
+        <p:spPr>
+          <a:xfrm>
+            <a:off x="640080" y="3758184"/>
             <a:ext cx="73152" cy="73152"/>
           </a:xfrm>
           <a:prstGeom prst="rect">
@@ -3611,14 +3693,14 @@
       </p:sp>
       <p:sp>
         <p:nvSpPr>
-          <p:cNvPr id="13" name="Text 11"/>
-          <p:cNvSpPr/>
-          <p:nvPr/>
-        </p:nvSpPr>
-        <p:spPr>
-          <a:xfrm>
-            <a:off x="804672" y="3529584"/>
-            <a:ext cx="1532534" cy="566928"/>
+          <p:cNvPr id="14" name="Text 12"/>
+          <p:cNvSpPr/>
+          <p:nvPr/>
+        </p:nvSpPr>
+        <p:spPr>
+          <a:xfrm>
+            <a:off x="804672" y="3675888"/>
+            <a:ext cx="1532534" cy="548640"/>
           </a:xfrm>
           <a:prstGeom prst="rect">
             <a:avLst/>
@@ -3653,13 +3735,13 @@
       </p:sp>
       <p:sp>
         <p:nvSpPr>
-          <p:cNvPr id="14" name="Shape 12"/>
-          <p:cNvSpPr/>
-          <p:nvPr/>
-        </p:nvSpPr>
-        <p:spPr>
-          <a:xfrm>
-            <a:off x="2483510" y="3099816"/>
+          <p:cNvPr id="15" name="Shape 13"/>
+          <p:cNvSpPr/>
+          <p:nvPr/>
+        </p:nvSpPr>
+        <p:spPr>
+          <a:xfrm>
+            <a:off x="2483510" y="3172968"/>
             <a:ext cx="292608" cy="256032"/>
           </a:xfrm>
           <a:prstGeom prst="chevron">
@@ -3678,14 +3760,14 @@
       </p:sp>
       <p:sp>
         <p:nvSpPr>
-          <p:cNvPr id="15" name="Shape 13"/>
-          <p:cNvSpPr/>
-          <p:nvPr/>
-        </p:nvSpPr>
-        <p:spPr>
-          <a:xfrm>
-            <a:off x="2757830" y="2084832"/>
-            <a:ext cx="2044598" cy="2286000"/>
+          <p:cNvPr id="16" name="Shape 14"/>
+          <p:cNvSpPr/>
+          <p:nvPr/>
+        </p:nvSpPr>
+        <p:spPr>
+          <a:xfrm>
+            <a:off x="2757830" y="2249424"/>
+            <a:ext cx="2044598" cy="2103120"/>
           </a:xfrm>
           <a:prstGeom prst="roundRect">
             <a:avLst>
@@ -3705,13 +3787,13 @@
       </p:sp>
       <p:sp>
         <p:nvSpPr>
-          <p:cNvPr id="16" name="Shape 14"/>
-          <p:cNvSpPr/>
-          <p:nvPr/>
-        </p:nvSpPr>
-        <p:spPr>
-          <a:xfrm>
-            <a:off x="2904134" y="2231136"/>
+          <p:cNvPr id="17" name="Shape 15"/>
+          <p:cNvSpPr/>
+          <p:nvPr/>
+        </p:nvSpPr>
+        <p:spPr>
+          <a:xfrm>
+            <a:off x="2904134" y="2395728"/>
             <a:ext cx="365760" cy="365760"/>
           </a:xfrm>
           <a:prstGeom prst="roundRect">
@@ -3727,13 +3809,13 @@
       </p:sp>
       <p:sp>
         <p:nvSpPr>
-          <p:cNvPr id="17" name="Text 15"/>
-          <p:cNvSpPr/>
-          <p:nvPr/>
-        </p:nvSpPr>
-        <p:spPr>
-          <a:xfrm>
-            <a:off x="2904134" y="2231136"/>
+          <p:cNvPr id="18" name="Text 16"/>
+          <p:cNvSpPr/>
+          <p:nvPr/>
+        </p:nvSpPr>
+        <p:spPr>
+          <a:xfrm>
+            <a:off x="2904134" y="2395728"/>
             <a:ext cx="365760" cy="365760"/>
           </a:xfrm>
           <a:prstGeom prst="rect">
@@ -3766,13 +3848,13 @@
       </p:sp>
       <p:sp>
         <p:nvSpPr>
-          <p:cNvPr id="18" name="Text 16"/>
-          <p:cNvSpPr/>
-          <p:nvPr/>
-        </p:nvSpPr>
-        <p:spPr>
-          <a:xfrm>
-            <a:off x="3361334" y="2212848"/>
+          <p:cNvPr id="19" name="Text 17"/>
+          <p:cNvSpPr/>
+          <p:nvPr/>
+        </p:nvSpPr>
+        <p:spPr>
+          <a:xfrm>
+            <a:off x="3361334" y="2377440"/>
             <a:ext cx="1313078" cy="640080"/>
           </a:xfrm>
           <a:prstGeom prst="rect">
@@ -3808,13 +3890,13 @@
       </p:sp>
       <p:sp>
         <p:nvSpPr>
-          <p:cNvPr id="19" name="Shape 17"/>
-          <p:cNvSpPr/>
-          <p:nvPr/>
-        </p:nvSpPr>
-        <p:spPr>
-          <a:xfrm>
-            <a:off x="2940710" y="3008376"/>
+          <p:cNvPr id="20" name="Shape 18"/>
+          <p:cNvSpPr/>
+          <p:nvPr/>
+        </p:nvSpPr>
+        <p:spPr>
+          <a:xfrm>
+            <a:off x="2940710" y="3172968"/>
             <a:ext cx="73152" cy="73152"/>
           </a:xfrm>
           <a:prstGeom prst="rect">
@@ -3828,14 +3910,14 @@
       </p:sp>
       <p:sp>
         <p:nvSpPr>
-          <p:cNvPr id="20" name="Text 18"/>
-          <p:cNvSpPr/>
-          <p:nvPr/>
-        </p:nvSpPr>
-        <p:spPr>
-          <a:xfrm>
-            <a:off x="3105302" y="2926080"/>
-            <a:ext cx="1532534" cy="566928"/>
+          <p:cNvPr id="21" name="Text 19"/>
+          <p:cNvSpPr/>
+          <p:nvPr/>
+        </p:nvSpPr>
+        <p:spPr>
+          <a:xfrm>
+            <a:off x="3105302" y="3090672"/>
+            <a:ext cx="1532534" cy="548640"/>
           </a:xfrm>
           <a:prstGeom prst="rect">
             <a:avLst/>
@@ -3870,13 +3952,13 @@
       </p:sp>
       <p:sp>
         <p:nvSpPr>
-          <p:cNvPr id="21" name="Shape 19"/>
-          <p:cNvSpPr/>
-          <p:nvPr/>
-        </p:nvSpPr>
-        <p:spPr>
-          <a:xfrm>
-            <a:off x="2940710" y="3611880"/>
+          <p:cNvPr id="22" name="Shape 20"/>
+          <p:cNvSpPr/>
+          <p:nvPr/>
+        </p:nvSpPr>
+        <p:spPr>
+          <a:xfrm>
+            <a:off x="2940710" y="3758184"/>
             <a:ext cx="73152" cy="73152"/>
           </a:xfrm>
           <a:prstGeom prst="rect">
@@ -3890,14 +3972,14 @@
       </p:sp>
       <p:sp>
         <p:nvSpPr>
-          <p:cNvPr id="22" name="Text 20"/>
-          <p:cNvSpPr/>
-          <p:nvPr/>
-        </p:nvSpPr>
-        <p:spPr>
-          <a:xfrm>
-            <a:off x="3105302" y="3529584"/>
-            <a:ext cx="1532534" cy="566928"/>
+          <p:cNvPr id="23" name="Text 21"/>
+          <p:cNvSpPr/>
+          <p:nvPr/>
+        </p:nvSpPr>
+        <p:spPr>
+          <a:xfrm>
+            <a:off x="3105302" y="3675888"/>
+            <a:ext cx="1532534" cy="548640"/>
           </a:xfrm>
           <a:prstGeom prst="rect">
             <a:avLst/>
@@ -3932,13 +4014,13 @@
       </p:sp>
       <p:sp>
         <p:nvSpPr>
-          <p:cNvPr id="23" name="Shape 21"/>
-          <p:cNvSpPr/>
-          <p:nvPr/>
-        </p:nvSpPr>
-        <p:spPr>
-          <a:xfrm>
-            <a:off x="4784141" y="3099816"/>
+          <p:cNvPr id="24" name="Shape 22"/>
+          <p:cNvSpPr/>
+          <p:nvPr/>
+        </p:nvSpPr>
+        <p:spPr>
+          <a:xfrm>
+            <a:off x="4784141" y="3172968"/>
             <a:ext cx="292608" cy="256032"/>
           </a:xfrm>
           <a:prstGeom prst="chevron">
@@ -3957,14 +4039,14 @@
       </p:sp>
       <p:sp>
         <p:nvSpPr>
-          <p:cNvPr id="24" name="Shape 22"/>
-          <p:cNvSpPr/>
-          <p:nvPr/>
-        </p:nvSpPr>
-        <p:spPr>
-          <a:xfrm>
-            <a:off x="5058461" y="2084832"/>
-            <a:ext cx="2044598" cy="2286000"/>
+          <p:cNvPr id="25" name="Shape 23"/>
+          <p:cNvSpPr/>
+          <p:nvPr/>
+        </p:nvSpPr>
+        <p:spPr>
+          <a:xfrm>
+            <a:off x="5058461" y="2249424"/>
+            <a:ext cx="2044598" cy="2103120"/>
           </a:xfrm>
           <a:prstGeom prst="roundRect">
             <a:avLst>
@@ -3984,13 +4066,13 @@
       </p:sp>
       <p:sp>
         <p:nvSpPr>
-          <p:cNvPr id="25" name="Shape 23"/>
-          <p:cNvSpPr/>
-          <p:nvPr/>
-        </p:nvSpPr>
-        <p:spPr>
-          <a:xfrm>
-            <a:off x="5204765" y="2231136"/>
+          <p:cNvPr id="26" name="Shape 24"/>
+          <p:cNvSpPr/>
+          <p:nvPr/>
+        </p:nvSpPr>
+        <p:spPr>
+          <a:xfrm>
+            <a:off x="5204765" y="2395728"/>
             <a:ext cx="365760" cy="365760"/>
           </a:xfrm>
           <a:prstGeom prst="roundRect">
@@ -4006,13 +4088,13 @@
       </p:sp>
       <p:sp>
         <p:nvSpPr>
-          <p:cNvPr id="26" name="Text 24"/>
-          <p:cNvSpPr/>
-          <p:nvPr/>
-        </p:nvSpPr>
-        <p:spPr>
-          <a:xfrm>
-            <a:off x="5204765" y="2231136"/>
+          <p:cNvPr id="27" name="Text 25"/>
+          <p:cNvSpPr/>
+          <p:nvPr/>
+        </p:nvSpPr>
+        <p:spPr>
+          <a:xfrm>
+            <a:off x="5204765" y="2395728"/>
             <a:ext cx="365760" cy="365760"/>
           </a:xfrm>
           <a:prstGeom prst="rect">
@@ -4045,13 +4127,13 @@
       </p:sp>
       <p:sp>
         <p:nvSpPr>
-          <p:cNvPr id="27" name="Text 25"/>
-          <p:cNvSpPr/>
-          <p:nvPr/>
-        </p:nvSpPr>
-        <p:spPr>
-          <a:xfrm>
-            <a:off x="5661965" y="2212848"/>
+          <p:cNvPr id="28" name="Text 26"/>
+          <p:cNvSpPr/>
+          <p:nvPr/>
+        </p:nvSpPr>
+        <p:spPr>
+          <a:xfrm>
+            <a:off x="5661965" y="2377440"/>
             <a:ext cx="1313078" cy="640080"/>
           </a:xfrm>
           <a:prstGeom prst="rect">
@@ -4087,13 +4169,13 @@
       </p:sp>
       <p:sp>
         <p:nvSpPr>
-          <p:cNvPr id="28" name="Shape 26"/>
-          <p:cNvSpPr/>
-          <p:nvPr/>
-        </p:nvSpPr>
-        <p:spPr>
-          <a:xfrm>
-            <a:off x="5241341" y="3008376"/>
+          <p:cNvPr id="29" name="Shape 27"/>
+          <p:cNvSpPr/>
+          <p:nvPr/>
+        </p:nvSpPr>
+        <p:spPr>
+          <a:xfrm>
+            <a:off x="5241341" y="3172968"/>
             <a:ext cx="73152" cy="73152"/>
           </a:xfrm>
           <a:prstGeom prst="rect">
@@ -4107,14 +4189,14 @@
       </p:sp>
       <p:sp>
         <p:nvSpPr>
-          <p:cNvPr id="29" name="Text 27"/>
-          <p:cNvSpPr/>
-          <p:nvPr/>
-        </p:nvSpPr>
-        <p:spPr>
-          <a:xfrm>
-            <a:off x="5405933" y="2926080"/>
-            <a:ext cx="1532534" cy="566928"/>
+          <p:cNvPr id="30" name="Text 28"/>
+          <p:cNvSpPr/>
+          <p:nvPr/>
+        </p:nvSpPr>
+        <p:spPr>
+          <a:xfrm>
+            <a:off x="5405933" y="3090672"/>
+            <a:ext cx="1532534" cy="548640"/>
           </a:xfrm>
           <a:prstGeom prst="rect">
             <a:avLst/>
@@ -4149,13 +4231,13 @@
       </p:sp>
       <p:sp>
         <p:nvSpPr>
-          <p:cNvPr id="30" name="Shape 28"/>
-          <p:cNvSpPr/>
-          <p:nvPr/>
-        </p:nvSpPr>
-        <p:spPr>
-          <a:xfrm>
-            <a:off x="5241341" y="3611880"/>
+          <p:cNvPr id="31" name="Shape 29"/>
+          <p:cNvSpPr/>
+          <p:nvPr/>
+        </p:nvSpPr>
+        <p:spPr>
+          <a:xfrm>
+            <a:off x="5241341" y="3758184"/>
             <a:ext cx="73152" cy="73152"/>
           </a:xfrm>
           <a:prstGeom prst="rect">
@@ -4169,14 +4251,14 @@
       </p:sp>
       <p:sp>
         <p:nvSpPr>
-          <p:cNvPr id="31" name="Text 29"/>
-          <p:cNvSpPr/>
-          <p:nvPr/>
-        </p:nvSpPr>
-        <p:spPr>
-          <a:xfrm>
-            <a:off x="5405933" y="3529584"/>
-            <a:ext cx="1532534" cy="566928"/>
+          <p:cNvPr id="32" name="Text 30"/>
+          <p:cNvSpPr/>
+          <p:nvPr/>
+        </p:nvSpPr>
+        <p:spPr>
+          <a:xfrm>
+            <a:off x="5405933" y="3675888"/>
+            <a:ext cx="1532534" cy="548640"/>
           </a:xfrm>
           <a:prstGeom prst="rect">
             <a:avLst/>
@@ -4211,13 +4293,13 @@
       </p:sp>
       <p:sp>
         <p:nvSpPr>
-          <p:cNvPr id="32" name="Shape 30"/>
-          <p:cNvSpPr/>
-          <p:nvPr/>
-        </p:nvSpPr>
-        <p:spPr>
-          <a:xfrm>
-            <a:off x="7084771" y="3099816"/>
+          <p:cNvPr id="33" name="Shape 31"/>
+          <p:cNvSpPr/>
+          <p:nvPr/>
+        </p:nvSpPr>
+        <p:spPr>
+          <a:xfrm>
+            <a:off x="7084771" y="3172968"/>
             <a:ext cx="292608" cy="256032"/>
           </a:xfrm>
           <a:prstGeom prst="chevron">
@@ -4236,14 +4318,14 @@
       </p:sp>
       <p:sp>
         <p:nvSpPr>
-          <p:cNvPr id="33" name="Shape 31"/>
-          <p:cNvSpPr/>
-          <p:nvPr/>
-        </p:nvSpPr>
-        <p:spPr>
-          <a:xfrm>
-            <a:off x="7359091" y="2084832"/>
-            <a:ext cx="2044598" cy="2286000"/>
+          <p:cNvPr id="34" name="Shape 32"/>
+          <p:cNvSpPr/>
+          <p:nvPr/>
+        </p:nvSpPr>
+        <p:spPr>
+          <a:xfrm>
+            <a:off x="7359091" y="2249424"/>
+            <a:ext cx="2044598" cy="2103120"/>
           </a:xfrm>
           <a:prstGeom prst="roundRect">
             <a:avLst>
@@ -4263,13 +4345,13 @@
       </p:sp>
       <p:sp>
         <p:nvSpPr>
-          <p:cNvPr id="34" name="Shape 32"/>
-          <p:cNvSpPr/>
-          <p:nvPr/>
-        </p:nvSpPr>
-        <p:spPr>
-          <a:xfrm>
-            <a:off x="7505395" y="2231136"/>
+          <p:cNvPr id="35" name="Shape 33"/>
+          <p:cNvSpPr/>
+          <p:nvPr/>
+        </p:nvSpPr>
+        <p:spPr>
+          <a:xfrm>
+            <a:off x="7505395" y="2395728"/>
             <a:ext cx="365760" cy="365760"/>
           </a:xfrm>
           <a:prstGeom prst="roundRect">
@@ -4285,13 +4367,13 @@
       </p:sp>
       <p:sp>
         <p:nvSpPr>
-          <p:cNvPr id="35" name="Text 33"/>
-          <p:cNvSpPr/>
-          <p:nvPr/>
-        </p:nvSpPr>
-        <p:spPr>
-          <a:xfrm>
-            <a:off x="7505395" y="2231136"/>
+          <p:cNvPr id="36" name="Text 34"/>
+          <p:cNvSpPr/>
+          <p:nvPr/>
+        </p:nvSpPr>
+        <p:spPr>
+          <a:xfrm>
+            <a:off x="7505395" y="2395728"/>
             <a:ext cx="365760" cy="365760"/>
           </a:xfrm>
           <a:prstGeom prst="rect">
@@ -4324,13 +4406,13 @@
       </p:sp>
       <p:sp>
         <p:nvSpPr>
-          <p:cNvPr id="36" name="Text 34"/>
-          <p:cNvSpPr/>
-          <p:nvPr/>
-        </p:nvSpPr>
-        <p:spPr>
-          <a:xfrm>
-            <a:off x="7962595" y="2212848"/>
+          <p:cNvPr id="37" name="Text 35"/>
+          <p:cNvSpPr/>
+          <p:nvPr/>
+        </p:nvSpPr>
+        <p:spPr>
+          <a:xfrm>
+            <a:off x="7962595" y="2377440"/>
             <a:ext cx="1313078" cy="640080"/>
           </a:xfrm>
           <a:prstGeom prst="rect">
@@ -4366,13 +4448,13 @@
       </p:sp>
       <p:sp>
         <p:nvSpPr>
-          <p:cNvPr id="37" name="Shape 35"/>
-          <p:cNvSpPr/>
-          <p:nvPr/>
-        </p:nvSpPr>
-        <p:spPr>
-          <a:xfrm>
-            <a:off x="7541971" y="3008376"/>
+          <p:cNvPr id="38" name="Shape 36"/>
+          <p:cNvSpPr/>
+          <p:nvPr/>
+        </p:nvSpPr>
+        <p:spPr>
+          <a:xfrm>
+            <a:off x="7541971" y="3172968"/>
             <a:ext cx="73152" cy="73152"/>
           </a:xfrm>
           <a:prstGeom prst="rect">
@@ -4386,14 +4468,14 @@
       </p:sp>
       <p:sp>
         <p:nvSpPr>
-          <p:cNvPr id="38" name="Text 36"/>
-          <p:cNvSpPr/>
-          <p:nvPr/>
-        </p:nvSpPr>
-        <p:spPr>
-          <a:xfrm>
-            <a:off x="7706563" y="2926080"/>
-            <a:ext cx="1532534" cy="566928"/>
+          <p:cNvPr id="39" name="Text 37"/>
+          <p:cNvSpPr/>
+          <p:nvPr/>
+        </p:nvSpPr>
+        <p:spPr>
+          <a:xfrm>
+            <a:off x="7706563" y="3090672"/>
+            <a:ext cx="1532534" cy="548640"/>
           </a:xfrm>
           <a:prstGeom prst="rect">
             <a:avLst/>
@@ -4428,13 +4510,13 @@
       </p:sp>
       <p:sp>
         <p:nvSpPr>
-          <p:cNvPr id="39" name="Shape 37"/>
-          <p:cNvSpPr/>
-          <p:nvPr/>
-        </p:nvSpPr>
-        <p:spPr>
-          <a:xfrm>
-            <a:off x="7541971" y="3611880"/>
+          <p:cNvPr id="40" name="Shape 38"/>
+          <p:cNvSpPr/>
+          <p:nvPr/>
+        </p:nvSpPr>
+        <p:spPr>
+          <a:xfrm>
+            <a:off x="7541971" y="3758184"/>
             <a:ext cx="73152" cy="73152"/>
           </a:xfrm>
           <a:prstGeom prst="rect">
@@ -4448,14 +4530,14 @@
       </p:sp>
       <p:sp>
         <p:nvSpPr>
-          <p:cNvPr id="40" name="Text 38"/>
-          <p:cNvSpPr/>
-          <p:nvPr/>
-        </p:nvSpPr>
-        <p:spPr>
-          <a:xfrm>
-            <a:off x="7706563" y="3529584"/>
-            <a:ext cx="1532534" cy="566928"/>
+          <p:cNvPr id="41" name="Text 39"/>
+          <p:cNvSpPr/>
+          <p:nvPr/>
+        </p:nvSpPr>
+        <p:spPr>
+          <a:xfrm>
+            <a:off x="7706563" y="3675888"/>
+            <a:ext cx="1532534" cy="548640"/>
           </a:xfrm>
           <a:prstGeom prst="rect">
             <a:avLst/>
@@ -4490,13 +4572,13 @@
       </p:sp>
       <p:sp>
         <p:nvSpPr>
-          <p:cNvPr id="41" name="Shape 39"/>
-          <p:cNvSpPr/>
-          <p:nvPr/>
-        </p:nvSpPr>
-        <p:spPr>
-          <a:xfrm>
-            <a:off x="9385402" y="3099816"/>
+          <p:cNvPr id="42" name="Shape 40"/>
+          <p:cNvSpPr/>
+          <p:nvPr/>
+        </p:nvSpPr>
+        <p:spPr>
+          <a:xfrm>
+            <a:off x="9385402" y="3172968"/>
             <a:ext cx="292608" cy="256032"/>
           </a:xfrm>
           <a:prstGeom prst="chevron">
@@ -4515,14 +4597,14 @@
       </p:sp>
       <p:sp>
         <p:nvSpPr>
-          <p:cNvPr id="42" name="Shape 40"/>
-          <p:cNvSpPr/>
-          <p:nvPr/>
-        </p:nvSpPr>
-        <p:spPr>
-          <a:xfrm>
-            <a:off x="9659722" y="2084832"/>
-            <a:ext cx="2044598" cy="2286000"/>
+          <p:cNvPr id="43" name="Shape 41"/>
+          <p:cNvSpPr/>
+          <p:nvPr/>
+        </p:nvSpPr>
+        <p:spPr>
+          <a:xfrm>
+            <a:off x="9659722" y="2249424"/>
+            <a:ext cx="2044598" cy="2103120"/>
           </a:xfrm>
           <a:prstGeom prst="roundRect">
             <a:avLst>
@@ -4542,13 +4624,13 @@
       </p:sp>
       <p:sp>
         <p:nvSpPr>
-          <p:cNvPr id="43" name="Shape 41"/>
-          <p:cNvSpPr/>
-          <p:nvPr/>
-        </p:nvSpPr>
-        <p:spPr>
-          <a:xfrm>
-            <a:off x="9806026" y="2231136"/>
+          <p:cNvPr id="44" name="Shape 42"/>
+          <p:cNvSpPr/>
+          <p:nvPr/>
+        </p:nvSpPr>
+        <p:spPr>
+          <a:xfrm>
+            <a:off x="9806026" y="2395728"/>
             <a:ext cx="365760" cy="365760"/>
           </a:xfrm>
           <a:prstGeom prst="roundRect">
@@ -4564,13 +4646,13 @@
       </p:sp>
       <p:sp>
         <p:nvSpPr>
-          <p:cNvPr id="44" name="Text 42"/>
-          <p:cNvSpPr/>
-          <p:nvPr/>
-        </p:nvSpPr>
-        <p:spPr>
-          <a:xfrm>
-            <a:off x="9806026" y="2231136"/>
+          <p:cNvPr id="45" name="Text 43"/>
+          <p:cNvSpPr/>
+          <p:nvPr/>
+        </p:nvSpPr>
+        <p:spPr>
+          <a:xfrm>
+            <a:off x="9806026" y="2395728"/>
             <a:ext cx="365760" cy="365760"/>
           </a:xfrm>
           <a:prstGeom prst="rect">
@@ -4603,13 +4685,13 @@
       </p:sp>
       <p:sp>
         <p:nvSpPr>
-          <p:cNvPr id="45" name="Text 43"/>
-          <p:cNvSpPr/>
-          <p:nvPr/>
-        </p:nvSpPr>
-        <p:spPr>
-          <a:xfrm>
-            <a:off x="10263226" y="2212848"/>
+          <p:cNvPr id="46" name="Text 44"/>
+          <p:cNvSpPr/>
+          <p:nvPr/>
+        </p:nvSpPr>
+        <p:spPr>
+          <a:xfrm>
+            <a:off x="10263226" y="2377440"/>
             <a:ext cx="1313078" cy="640080"/>
           </a:xfrm>
           <a:prstGeom prst="rect">
@@ -4645,13 +4727,13 @@
       </p:sp>
       <p:sp>
         <p:nvSpPr>
-          <p:cNvPr id="46" name="Shape 44"/>
-          <p:cNvSpPr/>
-          <p:nvPr/>
-        </p:nvSpPr>
-        <p:spPr>
-          <a:xfrm>
-            <a:off x="9842602" y="3008376"/>
+          <p:cNvPr id="47" name="Shape 45"/>
+          <p:cNvSpPr/>
+          <p:nvPr/>
+        </p:nvSpPr>
+        <p:spPr>
+          <a:xfrm>
+            <a:off x="9842602" y="3172968"/>
             <a:ext cx="73152" cy="73152"/>
           </a:xfrm>
           <a:prstGeom prst="rect">
@@ -4665,14 +4747,14 @@
       </p:sp>
       <p:sp>
         <p:nvSpPr>
-          <p:cNvPr id="47" name="Text 45"/>
-          <p:cNvSpPr/>
-          <p:nvPr/>
-        </p:nvSpPr>
-        <p:spPr>
-          <a:xfrm>
-            <a:off x="10007194" y="2926080"/>
-            <a:ext cx="1532534" cy="566928"/>
+          <p:cNvPr id="48" name="Text 46"/>
+          <p:cNvSpPr/>
+          <p:nvPr/>
+        </p:nvSpPr>
+        <p:spPr>
+          <a:xfrm>
+            <a:off x="10007194" y="3090672"/>
+            <a:ext cx="1532534" cy="548640"/>
           </a:xfrm>
           <a:prstGeom prst="rect">
             <a:avLst/>
@@ -4707,13 +4789,13 @@
       </p:sp>
       <p:sp>
         <p:nvSpPr>
-          <p:cNvPr id="48" name="Shape 46"/>
-          <p:cNvSpPr/>
-          <p:nvPr/>
-        </p:nvSpPr>
-        <p:spPr>
-          <a:xfrm>
-            <a:off x="9842602" y="3611880"/>
+          <p:cNvPr id="49" name="Shape 47"/>
+          <p:cNvSpPr/>
+          <p:nvPr/>
+        </p:nvSpPr>
+        <p:spPr>
+          <a:xfrm>
+            <a:off x="9842602" y="3758184"/>
             <a:ext cx="73152" cy="73152"/>
           </a:xfrm>
           <a:prstGeom prst="rect">
@@ -4727,14 +4809,14 @@
       </p:sp>
       <p:sp>
         <p:nvSpPr>
-          <p:cNvPr id="49" name="Text 47"/>
-          <p:cNvSpPr/>
-          <p:nvPr/>
-        </p:nvSpPr>
-        <p:spPr>
-          <a:xfrm>
-            <a:off x="10007194" y="3529584"/>
-            <a:ext cx="1532534" cy="566928"/>
+          <p:cNvPr id="50" name="Text 48"/>
+          <p:cNvSpPr/>
+          <p:nvPr/>
+        </p:nvSpPr>
+        <p:spPr>
+          <a:xfrm>
+            <a:off x="10007194" y="3675888"/>
+            <a:ext cx="1532534" cy="548640"/>
           </a:xfrm>
           <a:prstGeom prst="rect">
             <a:avLst/>
@@ -4769,14 +4851,14 @@
       </p:sp>
       <p:sp>
         <p:nvSpPr>
-          <p:cNvPr id="50" name="Text 48"/>
-          <p:cNvSpPr/>
-          <p:nvPr/>
-        </p:nvSpPr>
-        <p:spPr>
-          <a:xfrm>
-            <a:off x="457200" y="4498848"/>
-            <a:ext cx="11247120" cy="292608"/>
+          <p:cNvPr id="51" name="Text 49"/>
+          <p:cNvSpPr/>
+          <p:nvPr/>
+        </p:nvSpPr>
+        <p:spPr>
+          <a:xfrm>
+            <a:off x="457200" y="4480560"/>
+            <a:ext cx="11247120" cy="274320"/>
           </a:xfrm>
           <a:prstGeom prst="rect">
             <a:avLst/>
@@ -4822,13 +4904,13 @@
       </p:sp>
       <p:sp>
         <p:nvSpPr>
-          <p:cNvPr id="51" name="Shape 49"/>
-          <p:cNvSpPr/>
-          <p:nvPr/>
-        </p:nvSpPr>
-        <p:spPr>
-          <a:xfrm>
-            <a:off x="457200" y="4864608"/>
+          <p:cNvPr id="52" name="Shape 50"/>
+          <p:cNvSpPr/>
+          <p:nvPr/>
+        </p:nvSpPr>
+        <p:spPr>
+          <a:xfrm>
+            <a:off x="457200" y="4828032"/>
             <a:ext cx="11247120" cy="0"/>
           </a:xfrm>
           <a:prstGeom prst="line">
@@ -4845,13 +4927,13 @@
       </p:sp>
       <p:sp>
         <p:nvSpPr>
-          <p:cNvPr id="52" name="Text 50"/>
-          <p:cNvSpPr/>
-          <p:nvPr/>
-        </p:nvSpPr>
-        <p:spPr>
-          <a:xfrm>
-            <a:off x="457200" y="4974336"/>
+          <p:cNvPr id="53" name="Text 51"/>
+          <p:cNvSpPr/>
+          <p:nvPr/>
+        </p:nvSpPr>
+        <p:spPr>
+          <a:xfrm>
+            <a:off x="457200" y="4937760"/>
             <a:ext cx="5486400" cy="256032"/>
           </a:xfrm>
           <a:prstGeom prst="rect">
@@ -4876,7 +4958,7 @@
                 <a:ea typeface="Calibri" pitchFamily="34" charset="-122"/>
                 <a:cs typeface="Calibri" pitchFamily="34" charset="-120"/>
               </a:rPr>
-              <a:t>PROOF OF VALUE</a:t>
+              <a:t>THE PAYOFF</a:t>
             </a:r>
             <a:endParaRPr lang="en-US" sz="1100" dirty="0"/>
           </a:p>
@@ -4884,18 +4966,18 @@
       </p:sp>
       <p:sp>
         <p:nvSpPr>
-          <p:cNvPr id="53" name="Shape 51"/>
-          <p:cNvSpPr/>
-          <p:nvPr/>
-        </p:nvSpPr>
-        <p:spPr>
-          <a:xfrm>
-            <a:off x="457200" y="5285232"/>
-            <a:ext cx="2103120" cy="1188720"/>
+          <p:cNvPr id="54" name="Shape 52"/>
+          <p:cNvSpPr/>
+          <p:nvPr/>
+        </p:nvSpPr>
+        <p:spPr>
+          <a:xfrm>
+            <a:off x="457200" y="5230368"/>
+            <a:ext cx="2103120" cy="1152144"/>
           </a:xfrm>
           <a:prstGeom prst="roundRect">
             <a:avLst>
-              <a:gd name="adj" fmla="val 4615"/>
+              <a:gd name="adj" fmla="val 4762"/>
             </a:avLst>
           </a:prstGeom>
           <a:solidFill>
@@ -4911,14 +4993,14 @@
       </p:sp>
       <p:sp>
         <p:nvSpPr>
-          <p:cNvPr id="54" name="Text 52"/>
-          <p:cNvSpPr/>
-          <p:nvPr/>
-        </p:nvSpPr>
-        <p:spPr>
-          <a:xfrm>
-            <a:off x="502920" y="5404104"/>
-            <a:ext cx="2011680" cy="457200"/>
+          <p:cNvPr id="55" name="Text 53"/>
+          <p:cNvSpPr/>
+          <p:nvPr/>
+        </p:nvSpPr>
+        <p:spPr>
+          <a:xfrm>
+            <a:off x="502920" y="5340096"/>
+            <a:ext cx="2011680" cy="438912"/>
           </a:xfrm>
           <a:prstGeom prst="rect">
             <a:avLst/>
@@ -4934,7 +5016,7 @@
               <a:buNone/>
             </a:pPr>
             <a:r>
-              <a:rPr lang="en-US" sz="2600" b="1" dirty="0">
+              <a:rPr lang="en-US" sz="2500" b="1" dirty="0">
                 <a:solidFill>
                   <a:srgbClr val="12315B"/>
                 </a:solidFill>
@@ -4958,20 +5040,20 @@
               </a:rPr>
               <a:t>%</a:t>
             </a:r>
-            <a:endParaRPr lang="en-US" sz="2600" dirty="0"/>
-          </a:p>
-        </p:txBody>
-      </p:sp>
-      <p:sp>
-        <p:nvSpPr>
-          <p:cNvPr id="55" name="Text 53"/>
-          <p:cNvSpPr/>
-          <p:nvPr/>
-        </p:nvSpPr>
-        <p:spPr>
-          <a:xfrm>
-            <a:off x="548640" y="5907024"/>
-            <a:ext cx="1920240" cy="502920"/>
+            <a:endParaRPr lang="en-US" sz="2500" dirty="0"/>
+          </a:p>
+        </p:txBody>
+      </p:sp>
+      <p:sp>
+        <p:nvSpPr>
+          <p:cNvPr id="56" name="Text 54"/>
+          <p:cNvSpPr/>
+          <p:nvPr/>
+        </p:nvSpPr>
+        <p:spPr>
+          <a:xfrm>
+            <a:off x="548640" y="5815584"/>
+            <a:ext cx="1920240" cy="512064"/>
           </a:xfrm>
           <a:prstGeom prst="rect">
             <a:avLst/>
@@ -5006,18 +5088,18 @@
       </p:sp>
       <p:sp>
         <p:nvSpPr>
-          <p:cNvPr id="56" name="Shape 54"/>
-          <p:cNvSpPr/>
-          <p:nvPr/>
-        </p:nvSpPr>
-        <p:spPr>
-          <a:xfrm>
-            <a:off x="2743200" y="5285232"/>
-            <a:ext cx="2103120" cy="1188720"/>
+          <p:cNvPr id="57" name="Shape 55"/>
+          <p:cNvSpPr/>
+          <p:nvPr/>
+        </p:nvSpPr>
+        <p:spPr>
+          <a:xfrm>
+            <a:off x="2743200" y="5230368"/>
+            <a:ext cx="2103120" cy="1152144"/>
           </a:xfrm>
           <a:prstGeom prst="roundRect">
             <a:avLst>
-              <a:gd name="adj" fmla="val 4615"/>
+              <a:gd name="adj" fmla="val 4762"/>
             </a:avLst>
           </a:prstGeom>
           <a:solidFill>
@@ -5033,14 +5115,14 @@
       </p:sp>
       <p:sp>
         <p:nvSpPr>
-          <p:cNvPr id="57" name="Text 55"/>
-          <p:cNvSpPr/>
-          <p:nvPr/>
-        </p:nvSpPr>
-        <p:spPr>
-          <a:xfrm>
-            <a:off x="2788920" y="5404104"/>
-            <a:ext cx="2011680" cy="457200"/>
+          <p:cNvPr id="58" name="Text 56"/>
+          <p:cNvSpPr/>
+          <p:nvPr/>
+        </p:nvSpPr>
+        <p:spPr>
+          <a:xfrm>
+            <a:off x="2788920" y="5340096"/>
+            <a:ext cx="2011680" cy="438912"/>
           </a:xfrm>
           <a:prstGeom prst="rect">
             <a:avLst/>
@@ -5056,7 +5138,7 @@
               <a:buNone/>
             </a:pPr>
             <a:r>
-              <a:rPr lang="en-US" sz="2600" b="1" dirty="0">
+              <a:rPr lang="en-US" sz="2500" b="1" dirty="0">
                 <a:solidFill>
                   <a:srgbClr val="12315B"/>
                 </a:solidFill>
@@ -5080,20 +5162,20 @@
               </a:rPr>
               <a:t>%</a:t>
             </a:r>
-            <a:endParaRPr lang="en-US" sz="2600" dirty="0"/>
-          </a:p>
-        </p:txBody>
-      </p:sp>
-      <p:sp>
-        <p:nvSpPr>
-          <p:cNvPr id="58" name="Text 56"/>
-          <p:cNvSpPr/>
-          <p:nvPr/>
-        </p:nvSpPr>
-        <p:spPr>
-          <a:xfrm>
-            <a:off x="2834640" y="5907024"/>
-            <a:ext cx="1920240" cy="502920"/>
+            <a:endParaRPr lang="en-US" sz="2500" dirty="0"/>
+          </a:p>
+        </p:txBody>
+      </p:sp>
+      <p:sp>
+        <p:nvSpPr>
+          <p:cNvPr id="59" name="Text 57"/>
+          <p:cNvSpPr/>
+          <p:nvPr/>
+        </p:nvSpPr>
+        <p:spPr>
+          <a:xfrm>
+            <a:off x="2834640" y="5815584"/>
+            <a:ext cx="1920240" cy="512064"/>
           </a:xfrm>
           <a:prstGeom prst="rect">
             <a:avLst/>
@@ -5128,18 +5210,18 @@
       </p:sp>
       <p:sp>
         <p:nvSpPr>
-          <p:cNvPr id="59" name="Shape 57"/>
-          <p:cNvSpPr/>
-          <p:nvPr/>
-        </p:nvSpPr>
-        <p:spPr>
-          <a:xfrm>
-            <a:off x="5029200" y="5285232"/>
-            <a:ext cx="2103120" cy="1188720"/>
+          <p:cNvPr id="60" name="Shape 58"/>
+          <p:cNvSpPr/>
+          <p:nvPr/>
+        </p:nvSpPr>
+        <p:spPr>
+          <a:xfrm>
+            <a:off x="5029200" y="5230368"/>
+            <a:ext cx="2103120" cy="1152144"/>
           </a:xfrm>
           <a:prstGeom prst="roundRect">
             <a:avLst>
-              <a:gd name="adj" fmla="val 4615"/>
+              <a:gd name="adj" fmla="val 4762"/>
             </a:avLst>
           </a:prstGeom>
           <a:solidFill>
@@ -5155,14 +5237,14 @@
       </p:sp>
       <p:sp>
         <p:nvSpPr>
-          <p:cNvPr id="60" name="Text 58"/>
-          <p:cNvSpPr/>
-          <p:nvPr/>
-        </p:nvSpPr>
-        <p:spPr>
-          <a:xfrm>
-            <a:off x="5074920" y="5404104"/>
-            <a:ext cx="2011680" cy="457200"/>
+          <p:cNvPr id="61" name="Text 59"/>
+          <p:cNvSpPr/>
+          <p:nvPr/>
+        </p:nvSpPr>
+        <p:spPr>
+          <a:xfrm>
+            <a:off x="5074920" y="5340096"/>
+            <a:ext cx="2011680" cy="438912"/>
           </a:xfrm>
           <a:prstGeom prst="rect">
             <a:avLst/>
@@ -5178,7 +5260,7 @@
               <a:buNone/>
             </a:pPr>
             <a:r>
-              <a:rPr lang="en-US" sz="2600" b="1" dirty="0">
+              <a:rPr lang="en-US" sz="2500" b="1" dirty="0">
                 <a:solidFill>
                   <a:srgbClr val="12315B"/>
                 </a:solidFill>
@@ -5202,20 +5284,20 @@
               </a:rPr>
               <a:t>pts</a:t>
             </a:r>
-            <a:endParaRPr lang="en-US" sz="2600" dirty="0"/>
-          </a:p>
-        </p:txBody>
-      </p:sp>
-      <p:sp>
-        <p:nvSpPr>
-          <p:cNvPr id="61" name="Text 59"/>
-          <p:cNvSpPr/>
-          <p:nvPr/>
-        </p:nvSpPr>
-        <p:spPr>
-          <a:xfrm>
-            <a:off x="5120640" y="5907024"/>
-            <a:ext cx="1920240" cy="502920"/>
+            <a:endParaRPr lang="en-US" sz="2500" dirty="0"/>
+          </a:p>
+        </p:txBody>
+      </p:sp>
+      <p:sp>
+        <p:nvSpPr>
+          <p:cNvPr id="62" name="Text 60"/>
+          <p:cNvSpPr/>
+          <p:nvPr/>
+        </p:nvSpPr>
+        <p:spPr>
+          <a:xfrm>
+            <a:off x="5120640" y="5815584"/>
+            <a:ext cx="1920240" cy="512064"/>
           </a:xfrm>
           <a:prstGeom prst="rect">
             <a:avLst/>
@@ -5250,13 +5332,13 @@
       </p:sp>
       <p:sp>
         <p:nvSpPr>
-          <p:cNvPr id="62" name="Shape 60"/>
-          <p:cNvSpPr/>
-          <p:nvPr/>
-        </p:nvSpPr>
-        <p:spPr>
-          <a:xfrm>
-            <a:off x="7406640" y="4974336"/>
+          <p:cNvPr id="63" name="Shape 61"/>
+          <p:cNvSpPr/>
+          <p:nvPr/>
+        </p:nvSpPr>
+        <p:spPr>
+          <a:xfrm>
+            <a:off x="7406640" y="4937760"/>
             <a:ext cx="4297680" cy="1298448"/>
           </a:xfrm>
           <a:prstGeom prst="roundRect">
@@ -5272,13 +5354,13 @@
       </p:sp>
       <p:sp>
         <p:nvSpPr>
-          <p:cNvPr id="63" name="Text 61"/>
-          <p:cNvSpPr/>
-          <p:nvPr/>
-        </p:nvSpPr>
-        <p:spPr>
-          <a:xfrm>
-            <a:off x="7662672" y="5120640"/>
+          <p:cNvPr id="64" name="Text 62"/>
+          <p:cNvSpPr/>
+          <p:nvPr/>
+        </p:nvSpPr>
+        <p:spPr>
+          <a:xfrm>
+            <a:off x="7662672" y="5084064"/>
             <a:ext cx="3840480" cy="274320"/>
           </a:xfrm>
           <a:prstGeom prst="rect">
@@ -5303,7 +5385,7 @@
                 <a:ea typeface="Calibri" pitchFamily="34" charset="-122"/>
                 <a:cs typeface="Calibri" pitchFamily="34" charset="-120"/>
               </a:rPr>
-              <a:t>CONTINUOUS FEEDBACK LOOP</a:t>
+              <a:t>COMPOUNDING ADVANTAGE</a:t>
             </a:r>
             <a:endParaRPr lang="en-US" sz="1100" dirty="0"/>
           </a:p>
@@ -5311,13 +5393,13 @@
       </p:sp>
       <p:sp>
         <p:nvSpPr>
-          <p:cNvPr id="64" name="Text 62"/>
-          <p:cNvSpPr/>
-          <p:nvPr/>
-        </p:nvSpPr>
-        <p:spPr>
-          <a:xfrm>
-            <a:off x="7662672" y="5431536"/>
+          <p:cNvPr id="65" name="Text 63"/>
+          <p:cNvSpPr/>
+          <p:nvPr/>
+        </p:nvSpPr>
+        <p:spPr>
+          <a:xfrm>
+            <a:off x="7662672" y="5394960"/>
             <a:ext cx="3840480" cy="777240"/>
           </a:xfrm>
           <a:prstGeom prst="rect">
@@ -5353,7 +5435,7 @@
       </p:sp>
       <p:sp>
         <p:nvSpPr>
-          <p:cNvPr id="65" name="Shape 63"/>
+          <p:cNvPr id="66" name="Shape 64"/>
           <p:cNvSpPr/>
           <p:nvPr/>
         </p:nvSpPr>
@@ -5376,7 +5458,7 @@
       </p:sp>
       <p:sp>
         <p:nvSpPr>
-          <p:cNvPr id="66" name="Text 64"/>
+          <p:cNvPr id="67" name="Text 65"/>
           <p:cNvSpPr/>
           <p:nvPr/>
         </p:nvSpPr>
@@ -5415,7 +5497,7 @@
       </p:sp>
       <p:sp>
         <p:nvSpPr>
-          <p:cNvPr id="67" name="Text 65"/>
+          <p:cNvPr id="68" name="Text 66"/>
           <p:cNvSpPr/>
           <p:nvPr/>
         </p:nvSpPr>
@@ -5454,7 +5536,7 @@
       </p:sp>
       <p:sp>
         <p:nvSpPr>
-          <p:cNvPr id="68" name="Text 66"/>
+          <p:cNvPr id="69" name="Text 67"/>
           <p:cNvSpPr/>
           <p:nvPr/>
         </p:nvSpPr>

</xml_diff>

<commit_message>
Rebuild deck on the demo's real screen flow and on-screen data
Map both use cases to the actual app: Retail Signal 1 = auto-renewal
retention (Defend at-risk auto renewals), Commercial Signal 2 = small-
commercial growth (Underwriter of the Future). Each slide now mirrors the
on-screen decision loop (Sense -> Hypothesize -> Test -> Deploy -> Learn)
with real cohort/KPI numbers and the signature where-not-to-act discipline.

Co-Authored-By: Claude Opus 4.8 <noreply@anthropic.com>
Claude-Session: https://claude.ai/code/session_01GCTqGNdEESpSQWeDYc3Jjg
</commit_message>
<xml_diff>
--- a/Liberty_Mutual_AI_Signals.pptx
+++ b/Liberty_Mutual_AI_Signals.pptx
@@ -997,7 +997,7 @@
                 <a:ea typeface="Calibri" pitchFamily="34" charset="-122"/>
                 <a:cs typeface="Calibri" pitchFamily="34" charset="-120"/>
               </a:rPr>
-              <a:t>RETAIL  ·  SIGNAL 1</a:t>
+              <a:t>RETAIL  ·  SIGNAL 1  ·  RENEWAL IMPROVEMENT</a:t>
             </a:r>
             <a:endParaRPr lang="en-US" sz="1200" dirty="0"/>
           </a:p>
@@ -1039,7 +1039,7 @@
                 <a:ea typeface="Cambria" pitchFamily="34" charset="-122"/>
                 <a:cs typeface="Cambria" pitchFamily="34" charset="-120"/>
               </a:rPr>
-              <a:t>Renewal Improvement: a churn signal that protects premium before customers walk</a:t>
+              <a:t>Defend at-risk auto renewals before the customer shops</a:t>
             </a:r>
             <a:endParaRPr lang="en-US" sz="2600" dirty="0"/>
           </a:p>
@@ -1105,13 +1105,13 @@
                 <a:ea typeface="Calibri" pitchFamily="34" charset="-122"/>
                 <a:cs typeface="Calibri" pitchFamily="34" charset="-120"/>
               </a:rPr>
-              <a:t>THE CHALLENGE    </a:t>
+              <a:t>THE SIGNAL    </a:t>
             </a:r>
             <a:pPr indent="0" marL="0">
               <a:buNone/>
             </a:pPr>
             <a:r>
-              <a:rPr lang="en-US" sz="1250" i="1" dirty="0">
+              <a:rPr lang="en-US" sz="1200" i="1" dirty="0">
                 <a:solidFill>
                   <a:srgbClr val="1A2333"/>
                 </a:solidFill>
@@ -1119,7 +1119,7 @@
                 <a:ea typeface="Calibri" pitchFamily="34" charset="-122"/>
                 <a:cs typeface="Calibri" pitchFamily="34" charset="-120"/>
               </a:rPr>
-              <a:t>Most lapses are predictable and preventable — yet retention effort is spread evenly, spent late, and aimed at the wrong policies.</a:t>
+              <a:t>Auto retention has fallen 7.1 pts (73.5% → 66.4%). 550,849 high-LTV, claims-free renewals show shopping signals ~30–45 days out — worth $909M NWP / $2.27B CLV.</a:t>
             </a:r>
             <a:endParaRPr lang="en-US" sz="1100" dirty="0"/>
           </a:p>
@@ -1134,7 +1134,7 @@
         <p:spPr>
           <a:xfrm>
             <a:off x="457200" y="1938528"/>
-            <a:ext cx="5486400" cy="256032"/>
+            <a:ext cx="9144000" cy="256032"/>
           </a:xfrm>
           <a:prstGeom prst="rect">
             <a:avLst/>
@@ -1150,7 +1150,7 @@
               <a:buNone/>
             </a:pPr>
             <a:r>
-              <a:rPr lang="en-US" sz="1100" b="1" spc="200" kern="0" dirty="0">
+              <a:rPr lang="en-US" sz="1100" b="1" spc="150" kern="0" dirty="0">
                 <a:solidFill>
                   <a:srgbClr val="12315B"/>
                 </a:solidFill>
@@ -1158,7 +1158,7 @@
                 <a:ea typeface="Calibri" pitchFamily="34" charset="-122"/>
                 <a:cs typeface="Calibri" pitchFamily="34" charset="-120"/>
               </a:rPr>
-              <a:t>HOW THE SIGNAL RESPONDS</a:t>
+              <a:t>THE DECISION LOOP  ·  WHAT THE USER WALKS THROUGH ON SCREEN</a:t>
             </a:r>
             <a:endParaRPr lang="en-US" sz="1100" dirty="0"/>
           </a:p>
@@ -1261,7 +1261,7 @@
         <p:spPr>
           <a:xfrm>
             <a:off x="1060704" y="2377440"/>
-            <a:ext cx="1313078" cy="640080"/>
+            <a:ext cx="1313078" cy="256032"/>
           </a:xfrm>
           <a:prstGeom prst="rect">
             <a:avLst/>
@@ -1271,6 +1271,104 @@
         </p:spPr>
         <p:txBody>
           <a:bodyPr wrap="square" lIns="0" tIns="0" rIns="0" bIns="0" rtlCol="0" anchor="ctr"/>
+          <a:lstStyle/>
+          <a:p>
+            <a:pPr indent="0" marL="0">
+              <a:buNone/>
+            </a:pPr>
+            <a:r>
+              <a:rPr lang="en-US" sz="1300" b="1" dirty="0">
+                <a:solidFill>
+                  <a:srgbClr val="12315B"/>
+                </a:solidFill>
+                <a:latin typeface="Calibri" pitchFamily="34" charset="0"/>
+                <a:ea typeface="Calibri" pitchFamily="34" charset="-122"/>
+                <a:cs typeface="Calibri" pitchFamily="34" charset="-120"/>
+              </a:rPr>
+              <a:t>Sense</a:t>
+            </a:r>
+            <a:endParaRPr lang="en-US" sz="1300" dirty="0"/>
+          </a:p>
+        </p:txBody>
+      </p:sp>
+      <p:sp>
+        <p:nvSpPr>
+          <p:cNvPr id="11" name="Text 9"/>
+          <p:cNvSpPr/>
+          <p:nvPr/>
+        </p:nvSpPr>
+        <p:spPr>
+          <a:xfrm>
+            <a:off x="1060704" y="2633472"/>
+            <a:ext cx="1331366" cy="201168"/>
+          </a:xfrm>
+          <a:prstGeom prst="rect">
+            <a:avLst/>
+          </a:prstGeom>
+          <a:noFill/>
+          <a:ln/>
+        </p:spPr>
+        <p:txBody>
+          <a:bodyPr wrap="square" lIns="0" tIns="0" rIns="0" bIns="0" rtlCol="0" anchor="ctr"/>
+          <a:lstStyle/>
+          <a:p>
+            <a:pPr indent="0" marL="0">
+              <a:buNone/>
+            </a:pPr>
+            <a:r>
+              <a:rPr lang="en-US" sz="800" b="1" spc="100" kern="0" dirty="0">
+                <a:solidFill>
+                  <a:srgbClr val="2E6FB5"/>
+                </a:solidFill>
+                <a:latin typeface="Calibri" pitchFamily="34" charset="0"/>
+                <a:ea typeface="Calibri" pitchFamily="34" charset="-122"/>
+                <a:cs typeface="Calibri" pitchFamily="34" charset="-120"/>
+              </a:rPr>
+              <a:t>DECISION COCKPIT</a:t>
+            </a:r>
+            <a:endParaRPr lang="en-US" sz="800" dirty="0"/>
+          </a:p>
+        </p:txBody>
+      </p:sp>
+      <p:sp>
+        <p:nvSpPr>
+          <p:cNvPr id="12" name="Shape 10"/>
+          <p:cNvSpPr/>
+          <p:nvPr/>
+        </p:nvSpPr>
+        <p:spPr>
+          <a:xfrm>
+            <a:off x="640080" y="3127248"/>
+            <a:ext cx="73152" cy="73152"/>
+          </a:xfrm>
+          <a:prstGeom prst="rect">
+            <a:avLst/>
+          </a:prstGeom>
+          <a:solidFill>
+            <a:srgbClr val="2E6FB5"/>
+          </a:solidFill>
+          <a:ln/>
+        </p:spPr>
+      </p:sp>
+      <p:sp>
+        <p:nvSpPr>
+          <p:cNvPr id="13" name="Text 11"/>
+          <p:cNvSpPr/>
+          <p:nvPr/>
+        </p:nvSpPr>
+        <p:spPr>
+          <a:xfrm>
+            <a:off x="804672" y="3044952"/>
+            <a:ext cx="1532534" cy="566928"/>
+          </a:xfrm>
+          <a:prstGeom prst="rect">
+            <a:avLst/>
+          </a:prstGeom>
+          <a:noFill/>
+          <a:ln/>
+        </p:spPr>
+        <p:txBody>
+          <a:bodyPr wrap="square" lIns="0" tIns="0" rIns="0" bIns="0" rtlCol="0" anchor="t"/>
           <a:lstStyle/>
           <a:p>
             <a:pPr indent="0" marL="0">
@@ -1280,29 +1378,29 @@
               <a:buNone/>
             </a:pPr>
             <a:r>
-              <a:rPr lang="en-US" sz="1250" b="1" dirty="0">
-                <a:solidFill>
-                  <a:srgbClr val="12315B"/>
-                </a:solidFill>
-                <a:latin typeface="Calibri" pitchFamily="34" charset="0"/>
-                <a:ea typeface="Calibri" pitchFamily="34" charset="-122"/>
-                <a:cs typeface="Calibri" pitchFamily="34" charset="-120"/>
-              </a:rPr>
-              <a:t>Trigger &amp; data capture</a:t>
-            </a:r>
-            <a:endParaRPr lang="en-US" sz="1250" dirty="0"/>
-          </a:p>
-        </p:txBody>
-      </p:sp>
-      <p:sp>
-        <p:nvSpPr>
-          <p:cNvPr id="11" name="Shape 9"/>
-          <p:cNvSpPr/>
-          <p:nvPr/>
-        </p:nvSpPr>
-        <p:spPr>
-          <a:xfrm>
-            <a:off x="640080" y="3172968"/>
+              <a:rPr lang="en-US" sz="950" dirty="0">
+                <a:solidFill>
+                  <a:srgbClr val="5A6472"/>
+                </a:solidFill>
+                <a:latin typeface="Calibri" pitchFamily="34" charset="0"/>
+                <a:ea typeface="Calibri" pitchFamily="34" charset="-122"/>
+                <a:cs typeface="Calibri" pitchFamily="34" charset="-120"/>
+              </a:rPr>
+              <a:t>Auto-renewal signal tile fires in the retail cockpit</a:t>
+            </a:r>
+            <a:endParaRPr lang="en-US" sz="950" dirty="0"/>
+          </a:p>
+        </p:txBody>
+      </p:sp>
+      <p:sp>
+        <p:nvSpPr>
+          <p:cNvPr id="14" name="Shape 12"/>
+          <p:cNvSpPr/>
+          <p:nvPr/>
+        </p:nvSpPr>
+        <p:spPr>
+          <a:xfrm>
+            <a:off x="640080" y="3730752"/>
             <a:ext cx="73152" cy="73152"/>
           </a:xfrm>
           <a:prstGeom prst="rect">
@@ -1316,14 +1414,14 @@
       </p:sp>
       <p:sp>
         <p:nvSpPr>
-          <p:cNvPr id="12" name="Text 10"/>
-          <p:cNvSpPr/>
-          <p:nvPr/>
-        </p:nvSpPr>
-        <p:spPr>
-          <a:xfrm>
-            <a:off x="804672" y="3090672"/>
-            <a:ext cx="1532534" cy="548640"/>
+          <p:cNvPr id="15" name="Text 13"/>
+          <p:cNvSpPr/>
+          <p:nvPr/>
+        </p:nvSpPr>
+        <p:spPr>
+          <a:xfrm>
+            <a:off x="804672" y="3648456"/>
+            <a:ext cx="1532534" cy="566928"/>
           </a:xfrm>
           <a:prstGeom prst="rect">
             <a:avLst/>
@@ -1342,7 +1440,7 @@
               <a:buNone/>
             </a:pPr>
             <a:r>
-              <a:rPr lang="en-US" sz="1000" dirty="0">
+              <a:rPr lang="en-US" sz="950" dirty="0">
                 <a:solidFill>
                   <a:srgbClr val="5A6472"/>
                 </a:solidFill>
@@ -1350,77 +1448,15 @@
                 <a:ea typeface="Calibri" pitchFamily="34" charset="-122"/>
                 <a:cs typeface="Calibri" pitchFamily="34" charset="-120"/>
               </a:rPr>
-              <a:t>Enters the 90-day renewal window</a:t>
-            </a:r>
-            <a:endParaRPr lang="en-US" sz="1000" dirty="0"/>
-          </a:p>
-        </p:txBody>
-      </p:sp>
-      <p:sp>
-        <p:nvSpPr>
-          <p:cNvPr id="13" name="Shape 11"/>
-          <p:cNvSpPr/>
-          <p:nvPr/>
-        </p:nvSpPr>
-        <p:spPr>
-          <a:xfrm>
-            <a:off x="640080" y="3758184"/>
-            <a:ext cx="73152" cy="73152"/>
-          </a:xfrm>
-          <a:prstGeom prst="rect">
-            <a:avLst/>
-          </a:prstGeom>
-          <a:solidFill>
-            <a:srgbClr val="2E6FB5"/>
-          </a:solidFill>
-          <a:ln/>
-        </p:spPr>
-      </p:sp>
-      <p:sp>
-        <p:nvSpPr>
-          <p:cNvPr id="14" name="Text 12"/>
-          <p:cNvSpPr/>
-          <p:nvPr/>
-        </p:nvSpPr>
-        <p:spPr>
-          <a:xfrm>
-            <a:off x="804672" y="3675888"/>
-            <a:ext cx="1532534" cy="548640"/>
-          </a:xfrm>
-          <a:prstGeom prst="rect">
-            <a:avLst/>
-          </a:prstGeom>
-          <a:noFill/>
-          <a:ln/>
-        </p:spPr>
-        <p:txBody>
-          <a:bodyPr wrap="square" lIns="0" tIns="0" rIns="0" bIns="0" rtlCol="0" anchor="t"/>
-          <a:lstStyle/>
-          <a:p>
-            <a:pPr indent="0" marL="0">
-              <a:lnSpc>
-                <a:spcPct val="95000"/>
-              </a:lnSpc>
-              <a:buNone/>
-            </a:pPr>
-            <a:r>
-              <a:rPr lang="en-US" sz="1000" dirty="0">
-                <a:solidFill>
-                  <a:srgbClr val="5A6472"/>
-                </a:solidFill>
-                <a:latin typeface="Calibri" pitchFamily="34" charset="0"/>
-                <a:ea typeface="Calibri" pitchFamily="34" charset="-122"/>
-                <a:cs typeface="Calibri" pitchFamily="34" charset="-120"/>
-              </a:rPr>
-              <a:t>Tenure, price, claims &amp; competitor rates</a:t>
-            </a:r>
-            <a:endParaRPr lang="en-US" sz="1000" dirty="0"/>
-          </a:p>
-        </p:txBody>
-      </p:sp>
-      <p:sp>
-        <p:nvSpPr>
-          <p:cNvPr id="15" name="Shape 13"/>
+              <a:t>550,849 at-risk renewals · $909M NWP at stake</a:t>
+            </a:r>
+            <a:endParaRPr lang="en-US" sz="950" dirty="0"/>
+          </a:p>
+        </p:txBody>
+      </p:sp>
+      <p:sp>
+        <p:nvSpPr>
+          <p:cNvPr id="16" name="Shape 14"/>
           <p:cNvSpPr/>
           <p:nvPr/>
         </p:nvSpPr>
@@ -1445,7 +1481,7 @@
       </p:sp>
       <p:sp>
         <p:nvSpPr>
-          <p:cNvPr id="16" name="Shape 14"/>
+          <p:cNvPr id="17" name="Shape 15"/>
           <p:cNvSpPr/>
           <p:nvPr/>
         </p:nvSpPr>
@@ -1472,7 +1508,7 @@
       </p:sp>
       <p:sp>
         <p:nvSpPr>
-          <p:cNvPr id="17" name="Shape 15"/>
+          <p:cNvPr id="18" name="Shape 16"/>
           <p:cNvSpPr/>
           <p:nvPr/>
         </p:nvSpPr>
@@ -1494,7 +1530,7 @@
       </p:sp>
       <p:sp>
         <p:nvSpPr>
-          <p:cNvPr id="18" name="Text 16"/>
+          <p:cNvPr id="19" name="Text 17"/>
           <p:cNvSpPr/>
           <p:nvPr/>
         </p:nvSpPr>
@@ -1533,14 +1569,14 @@
       </p:sp>
       <p:sp>
         <p:nvSpPr>
-          <p:cNvPr id="19" name="Text 17"/>
+          <p:cNvPr id="20" name="Text 18"/>
           <p:cNvSpPr/>
           <p:nvPr/>
         </p:nvSpPr>
         <p:spPr>
           <a:xfrm>
             <a:off x="3361334" y="2377440"/>
-            <a:ext cx="1313078" cy="640080"/>
+            <a:ext cx="1313078" cy="256032"/>
           </a:xfrm>
           <a:prstGeom prst="rect">
             <a:avLst/>
@@ -1550,6 +1586,104 @@
         </p:spPr>
         <p:txBody>
           <a:bodyPr wrap="square" lIns="0" tIns="0" rIns="0" bIns="0" rtlCol="0" anchor="ctr"/>
+          <a:lstStyle/>
+          <a:p>
+            <a:pPr indent="0" marL="0">
+              <a:buNone/>
+            </a:pPr>
+            <a:r>
+              <a:rPr lang="en-US" sz="1300" b="1" dirty="0">
+                <a:solidFill>
+                  <a:srgbClr val="12315B"/>
+                </a:solidFill>
+                <a:latin typeface="Calibri" pitchFamily="34" charset="0"/>
+                <a:ea typeface="Calibri" pitchFamily="34" charset="-122"/>
+                <a:cs typeface="Calibri" pitchFamily="34" charset="-120"/>
+              </a:rPr>
+              <a:t>Hypothesize</a:t>
+            </a:r>
+            <a:endParaRPr lang="en-US" sz="1300" dirty="0"/>
+          </a:p>
+        </p:txBody>
+      </p:sp>
+      <p:sp>
+        <p:nvSpPr>
+          <p:cNvPr id="21" name="Text 19"/>
+          <p:cNvSpPr/>
+          <p:nvPr/>
+        </p:nvSpPr>
+        <p:spPr>
+          <a:xfrm>
+            <a:off x="3361334" y="2633472"/>
+            <a:ext cx="1331366" cy="201168"/>
+          </a:xfrm>
+          <a:prstGeom prst="rect">
+            <a:avLst/>
+          </a:prstGeom>
+          <a:noFill/>
+          <a:ln/>
+        </p:spPr>
+        <p:txBody>
+          <a:bodyPr wrap="square" lIns="0" tIns="0" rIns="0" bIns="0" rtlCol="0" anchor="ctr"/>
+          <a:lstStyle/>
+          <a:p>
+            <a:pPr indent="0" marL="0">
+              <a:buNone/>
+            </a:pPr>
+            <a:r>
+              <a:rPr lang="en-US" sz="800" b="1" spc="100" kern="0" dirty="0">
+                <a:solidFill>
+                  <a:srgbClr val="2E6FB5"/>
+                </a:solidFill>
+                <a:latin typeface="Calibri" pitchFamily="34" charset="0"/>
+                <a:ea typeface="Calibri" pitchFamily="34" charset="-122"/>
+                <a:cs typeface="Calibri" pitchFamily="34" charset="-120"/>
+              </a:rPr>
+              <a:t>ANALYSE</a:t>
+            </a:r>
+            <a:endParaRPr lang="en-US" sz="800" dirty="0"/>
+          </a:p>
+        </p:txBody>
+      </p:sp>
+      <p:sp>
+        <p:nvSpPr>
+          <p:cNvPr id="22" name="Shape 20"/>
+          <p:cNvSpPr/>
+          <p:nvPr/>
+        </p:nvSpPr>
+        <p:spPr>
+          <a:xfrm>
+            <a:off x="2940710" y="3127248"/>
+            <a:ext cx="73152" cy="73152"/>
+          </a:xfrm>
+          <a:prstGeom prst="rect">
+            <a:avLst/>
+          </a:prstGeom>
+          <a:solidFill>
+            <a:srgbClr val="2E6FB5"/>
+          </a:solidFill>
+          <a:ln/>
+        </p:spPr>
+      </p:sp>
+      <p:sp>
+        <p:nvSpPr>
+          <p:cNvPr id="23" name="Text 21"/>
+          <p:cNvSpPr/>
+          <p:nvPr/>
+        </p:nvSpPr>
+        <p:spPr>
+          <a:xfrm>
+            <a:off x="3105302" y="3044952"/>
+            <a:ext cx="1532534" cy="566928"/>
+          </a:xfrm>
+          <a:prstGeom prst="rect">
+            <a:avLst/>
+          </a:prstGeom>
+          <a:noFill/>
+          <a:ln/>
+        </p:spPr>
+        <p:txBody>
+          <a:bodyPr wrap="square" lIns="0" tIns="0" rIns="0" bIns="0" rtlCol="0" anchor="t"/>
           <a:lstStyle/>
           <a:p>
             <a:pPr indent="0" marL="0">
@@ -1559,29 +1693,29 @@
               <a:buNone/>
             </a:pPr>
             <a:r>
-              <a:rPr lang="en-US" sz="1250" b="1" dirty="0">
-                <a:solidFill>
-                  <a:srgbClr val="12315B"/>
-                </a:solidFill>
-                <a:latin typeface="Calibri" pitchFamily="34" charset="0"/>
-                <a:ea typeface="Calibri" pitchFamily="34" charset="-122"/>
-                <a:cs typeface="Calibri" pitchFamily="34" charset="-120"/>
-              </a:rPr>
-              <a:t>Churn risk scoring</a:t>
-            </a:r>
-            <a:endParaRPr lang="en-US" sz="1250" dirty="0"/>
-          </a:p>
-        </p:txBody>
-      </p:sp>
-      <p:sp>
-        <p:nvSpPr>
-          <p:cNvPr id="20" name="Shape 18"/>
-          <p:cNvSpPr/>
-          <p:nvPr/>
-        </p:nvSpPr>
-        <p:spPr>
-          <a:xfrm>
-            <a:off x="2940710" y="3172968"/>
+              <a:rPr lang="en-US" sz="950" dirty="0">
+                <a:solidFill>
+                  <a:srgbClr val="5A6472"/>
+                </a:solidFill>
+                <a:latin typeface="Calibri" pitchFamily="34" charset="0"/>
+                <a:ea typeface="Calibri" pitchFamily="34" charset="-122"/>
+                <a:cs typeface="Calibri" pitchFamily="34" charset="-120"/>
+              </a:rPr>
+              <a:t>“Defend at-risk auto renewals” — elasticity-first</a:t>
+            </a:r>
+            <a:endParaRPr lang="en-US" sz="950" dirty="0"/>
+          </a:p>
+        </p:txBody>
+      </p:sp>
+      <p:sp>
+        <p:nvSpPr>
+          <p:cNvPr id="24" name="Shape 22"/>
+          <p:cNvSpPr/>
+          <p:nvPr/>
+        </p:nvSpPr>
+        <p:spPr>
+          <a:xfrm>
+            <a:off x="2940710" y="3730752"/>
             <a:ext cx="73152" cy="73152"/>
           </a:xfrm>
           <a:prstGeom prst="rect">
@@ -1595,14 +1729,14 @@
       </p:sp>
       <p:sp>
         <p:nvSpPr>
-          <p:cNvPr id="21" name="Text 19"/>
-          <p:cNvSpPr/>
-          <p:nvPr/>
-        </p:nvSpPr>
-        <p:spPr>
-          <a:xfrm>
-            <a:off x="3105302" y="3090672"/>
-            <a:ext cx="1532534" cy="548640"/>
+          <p:cNvPr id="25" name="Text 23"/>
+          <p:cNvSpPr/>
+          <p:nvPr/>
+        </p:nvSpPr>
+        <p:spPr>
+          <a:xfrm>
+            <a:off x="3105302" y="3648456"/>
+            <a:ext cx="1532534" cy="566928"/>
           </a:xfrm>
           <a:prstGeom prst="rect">
             <a:avLst/>
@@ -1621,7 +1755,7 @@
               <a:buNone/>
             </a:pPr>
             <a:r>
-              <a:rPr lang="en-US" sz="1000" dirty="0">
+              <a:rPr lang="en-US" sz="950" dirty="0">
                 <a:solidFill>
                   <a:srgbClr val="5A6472"/>
                 </a:solidFill>
@@ -1629,77 +1763,15 @@
                 <a:ea typeface="Calibri" pitchFamily="34" charset="-122"/>
                 <a:cs typeface="Calibri" pitchFamily="34" charset="-120"/>
               </a:rPr>
-              <a:t>Daily lapse-propensity score, 0–100</a:t>
-            </a:r>
-            <a:endParaRPr lang="en-US" sz="1000" dirty="0"/>
-          </a:p>
-        </p:txBody>
-      </p:sp>
-      <p:sp>
-        <p:nvSpPr>
-          <p:cNvPr id="22" name="Shape 20"/>
-          <p:cNvSpPr/>
-          <p:nvPr/>
-        </p:nvSpPr>
-        <p:spPr>
-          <a:xfrm>
-            <a:off x="2940710" y="3758184"/>
-            <a:ext cx="73152" cy="73152"/>
-          </a:xfrm>
-          <a:prstGeom prst="rect">
-            <a:avLst/>
-          </a:prstGeom>
-          <a:solidFill>
-            <a:srgbClr val="2E6FB5"/>
-          </a:solidFill>
-          <a:ln/>
-        </p:spPr>
-      </p:sp>
-      <p:sp>
-        <p:nvSpPr>
-          <p:cNvPr id="23" name="Text 21"/>
-          <p:cNvSpPr/>
-          <p:nvPr/>
-        </p:nvSpPr>
-        <p:spPr>
-          <a:xfrm>
-            <a:off x="3105302" y="3675888"/>
-            <a:ext cx="1532534" cy="548640"/>
-          </a:xfrm>
-          <a:prstGeom prst="rect">
-            <a:avLst/>
-          </a:prstGeom>
-          <a:noFill/>
-          <a:ln/>
-        </p:spPr>
-        <p:txBody>
-          <a:bodyPr wrap="square" lIns="0" tIns="0" rIns="0" bIns="0" rtlCol="0" anchor="t"/>
-          <a:lstStyle/>
-          <a:p>
-            <a:pPr indent="0" marL="0">
-              <a:lnSpc>
-                <a:spcPct val="95000"/>
-              </a:lnSpc>
-              <a:buNone/>
-            </a:pPr>
-            <a:r>
-              <a:rPr lang="en-US" sz="1000" dirty="0">
-                <a:solidFill>
-                  <a:srgbClr val="5A6472"/>
-                </a:solidFill>
-                <a:latin typeface="Calibri" pitchFamily="34" charset="0"/>
-                <a:ea typeface="Calibri" pitchFamily="34" charset="-122"/>
-                <a:cs typeface="Calibri" pitchFamily="34" charset="-120"/>
-              </a:rPr>
-              <a:t>Price sensitivity, life-events, engagement</a:t>
-            </a:r>
-            <a:endParaRPr lang="en-US" sz="1000" dirty="0"/>
-          </a:p>
-        </p:txBody>
-      </p:sp>
-      <p:sp>
-        <p:nvSpPr>
-          <p:cNvPr id="24" name="Shape 22"/>
+              <a:t>3 archetypes: Shopping Renewer + Silent Pre-Shopper act; Sticky-Bundled excluded</a:t>
+            </a:r>
+            <a:endParaRPr lang="en-US" sz="950" dirty="0"/>
+          </a:p>
+        </p:txBody>
+      </p:sp>
+      <p:sp>
+        <p:nvSpPr>
+          <p:cNvPr id="26" name="Shape 24"/>
           <p:cNvSpPr/>
           <p:nvPr/>
         </p:nvSpPr>
@@ -1724,7 +1796,7 @@
       </p:sp>
       <p:sp>
         <p:nvSpPr>
-          <p:cNvPr id="25" name="Shape 23"/>
+          <p:cNvPr id="27" name="Shape 25"/>
           <p:cNvSpPr/>
           <p:nvPr/>
         </p:nvSpPr>
@@ -1751,7 +1823,7 @@
       </p:sp>
       <p:sp>
         <p:nvSpPr>
-          <p:cNvPr id="26" name="Shape 24"/>
+          <p:cNvPr id="28" name="Shape 26"/>
           <p:cNvSpPr/>
           <p:nvPr/>
         </p:nvSpPr>
@@ -1773,7 +1845,7 @@
       </p:sp>
       <p:sp>
         <p:nvSpPr>
-          <p:cNvPr id="27" name="Text 25"/>
+          <p:cNvPr id="29" name="Text 27"/>
           <p:cNvSpPr/>
           <p:nvPr/>
         </p:nvSpPr>
@@ -1812,14 +1884,14 @@
       </p:sp>
       <p:sp>
         <p:nvSpPr>
-          <p:cNvPr id="28" name="Text 26"/>
+          <p:cNvPr id="30" name="Text 28"/>
           <p:cNvSpPr/>
           <p:nvPr/>
         </p:nvSpPr>
         <p:spPr>
           <a:xfrm>
             <a:off x="5661965" y="2377440"/>
-            <a:ext cx="1313078" cy="640080"/>
+            <a:ext cx="1313078" cy="256032"/>
           </a:xfrm>
           <a:prstGeom prst="rect">
             <a:avLst/>
@@ -1829,6 +1901,104 @@
         </p:spPr>
         <p:txBody>
           <a:bodyPr wrap="square" lIns="0" tIns="0" rIns="0" bIns="0" rtlCol="0" anchor="ctr"/>
+          <a:lstStyle/>
+          <a:p>
+            <a:pPr indent="0" marL="0">
+              <a:buNone/>
+            </a:pPr>
+            <a:r>
+              <a:rPr lang="en-US" sz="1300" b="1" dirty="0">
+                <a:solidFill>
+                  <a:srgbClr val="12315B"/>
+                </a:solidFill>
+                <a:latin typeface="Calibri" pitchFamily="34" charset="0"/>
+                <a:ea typeface="Calibri" pitchFamily="34" charset="-122"/>
+                <a:cs typeface="Calibri" pitchFamily="34" charset="-120"/>
+              </a:rPr>
+              <a:t>Test</a:t>
+            </a:r>
+            <a:endParaRPr lang="en-US" sz="1300" dirty="0"/>
+          </a:p>
+        </p:txBody>
+      </p:sp>
+      <p:sp>
+        <p:nvSpPr>
+          <p:cNvPr id="31" name="Text 29"/>
+          <p:cNvSpPr/>
+          <p:nvPr/>
+        </p:nvSpPr>
+        <p:spPr>
+          <a:xfrm>
+            <a:off x="5661965" y="2633472"/>
+            <a:ext cx="1331366" cy="201168"/>
+          </a:xfrm>
+          <a:prstGeom prst="rect">
+            <a:avLst/>
+          </a:prstGeom>
+          <a:noFill/>
+          <a:ln/>
+        </p:spPr>
+        <p:txBody>
+          <a:bodyPr wrap="square" lIns="0" tIns="0" rIns="0" bIns="0" rtlCol="0" anchor="ctr"/>
+          <a:lstStyle/>
+          <a:p>
+            <a:pPr indent="0" marL="0">
+              <a:buNone/>
+            </a:pPr>
+            <a:r>
+              <a:rPr lang="en-US" sz="800" b="1" spc="100" kern="0" dirty="0">
+                <a:solidFill>
+                  <a:srgbClr val="2E6FB5"/>
+                </a:solidFill>
+                <a:latin typeface="Calibri" pitchFamily="34" charset="0"/>
+                <a:ea typeface="Calibri" pitchFamily="34" charset="-122"/>
+                <a:cs typeface="Calibri" pitchFamily="34" charset="-120"/>
+              </a:rPr>
+              <a:t>SIMULATION STUDIO</a:t>
+            </a:r>
+            <a:endParaRPr lang="en-US" sz="800" dirty="0"/>
+          </a:p>
+        </p:txBody>
+      </p:sp>
+      <p:sp>
+        <p:nvSpPr>
+          <p:cNvPr id="32" name="Shape 30"/>
+          <p:cNvSpPr/>
+          <p:nvPr/>
+        </p:nvSpPr>
+        <p:spPr>
+          <a:xfrm>
+            <a:off x="5241341" y="3127248"/>
+            <a:ext cx="73152" cy="73152"/>
+          </a:xfrm>
+          <a:prstGeom prst="rect">
+            <a:avLst/>
+          </a:prstGeom>
+          <a:solidFill>
+            <a:srgbClr val="2E6FB5"/>
+          </a:solidFill>
+          <a:ln/>
+        </p:spPr>
+      </p:sp>
+      <p:sp>
+        <p:nvSpPr>
+          <p:cNvPr id="33" name="Text 31"/>
+          <p:cNvSpPr/>
+          <p:nvPr/>
+        </p:nvSpPr>
+        <p:spPr>
+          <a:xfrm>
+            <a:off x="5405933" y="3044952"/>
+            <a:ext cx="1532534" cy="566928"/>
+          </a:xfrm>
+          <a:prstGeom prst="rect">
+            <a:avLst/>
+          </a:prstGeom>
+          <a:noFill/>
+          <a:ln/>
+        </p:spPr>
+        <p:txBody>
+          <a:bodyPr wrap="square" lIns="0" tIns="0" rIns="0" bIns="0" rtlCol="0" anchor="t"/>
           <a:lstStyle/>
           <a:p>
             <a:pPr indent="0" marL="0">
@@ -1838,29 +2008,29 @@
               <a:buNone/>
             </a:pPr>
             <a:r>
-              <a:rPr lang="en-US" sz="1250" b="1" dirty="0">
-                <a:solidFill>
-                  <a:srgbClr val="12315B"/>
-                </a:solidFill>
-                <a:latin typeface="Calibri" pitchFamily="34" charset="0"/>
-                <a:ea typeface="Calibri" pitchFamily="34" charset="-122"/>
-                <a:cs typeface="Calibri" pitchFamily="34" charset="-120"/>
-              </a:rPr>
-              <a:t>Prioritize the movable middle</a:t>
-            </a:r>
-            <a:endParaRPr lang="en-US" sz="1250" dirty="0"/>
-          </a:p>
-        </p:txBody>
-      </p:sp>
-      <p:sp>
-        <p:nvSpPr>
-          <p:cNvPr id="29" name="Shape 27"/>
-          <p:cNvSpPr/>
-          <p:nvPr/>
-        </p:nvSpPr>
-        <p:spPr>
-          <a:xfrm>
-            <a:off x="5241341" y="3172968"/>
+              <a:rPr lang="en-US" sz="950" dirty="0">
+                <a:solidFill>
+                  <a:srgbClr val="5A6472"/>
+                </a:solidFill>
+                <a:latin typeface="Calibri" pitchFamily="34" charset="0"/>
+                <a:ea typeface="Calibri" pitchFamily="34" charset="-122"/>
+                <a:cs typeface="Calibri" pitchFamily="34" charset="-120"/>
+              </a:rPr>
+              <a:t>What-If levers or If-What goal-seek: reprice, offer, holdout</a:t>
+            </a:r>
+            <a:endParaRPr lang="en-US" sz="950" dirty="0"/>
+          </a:p>
+        </p:txBody>
+      </p:sp>
+      <p:sp>
+        <p:nvSpPr>
+          <p:cNvPr id="34" name="Shape 32"/>
+          <p:cNvSpPr/>
+          <p:nvPr/>
+        </p:nvSpPr>
+        <p:spPr>
+          <a:xfrm>
+            <a:off x="5241341" y="3730752"/>
             <a:ext cx="73152" cy="73152"/>
           </a:xfrm>
           <a:prstGeom prst="rect">
@@ -1874,14 +2044,14 @@
       </p:sp>
       <p:sp>
         <p:nvSpPr>
-          <p:cNvPr id="30" name="Text 28"/>
-          <p:cNvSpPr/>
-          <p:nvPr/>
-        </p:nvSpPr>
-        <p:spPr>
-          <a:xfrm>
-            <a:off x="5405933" y="3090672"/>
-            <a:ext cx="1532534" cy="548640"/>
+          <p:cNvPr id="35" name="Text 33"/>
+          <p:cNvSpPr/>
+          <p:nvPr/>
+        </p:nvSpPr>
+        <p:spPr>
+          <a:xfrm>
+            <a:off x="5405933" y="3648456"/>
+            <a:ext cx="1532534" cy="566928"/>
           </a:xfrm>
           <a:prstGeom prst="rect">
             <a:avLst/>
@@ -1900,7 +2070,7 @@
               <a:buNone/>
             </a:pPr>
             <a:r>
-              <a:rPr lang="en-US" sz="1000" dirty="0">
+              <a:rPr lang="en-US" sz="950" dirty="0">
                 <a:solidFill>
                   <a:srgbClr val="5A6472"/>
                 </a:solidFill>
@@ -1908,77 +2078,15 @@
                 <a:ea typeface="Calibri" pitchFamily="34" charset="-122"/>
                 <a:cs typeface="Calibri" pitchFamily="34" charset="-120"/>
               </a:rPr>
-              <a:t>Ranked by value × movability</a:t>
-            </a:r>
-            <a:endParaRPr lang="en-US" sz="1000" dirty="0"/>
-          </a:p>
-        </p:txBody>
-      </p:sp>
-      <p:sp>
-        <p:nvSpPr>
-          <p:cNvPr id="31" name="Shape 29"/>
-          <p:cNvSpPr/>
-          <p:nvPr/>
-        </p:nvSpPr>
-        <p:spPr>
-          <a:xfrm>
-            <a:off x="5241341" y="3758184"/>
-            <a:ext cx="73152" cy="73152"/>
-          </a:xfrm>
-          <a:prstGeom prst="rect">
-            <a:avLst/>
-          </a:prstGeom>
-          <a:solidFill>
-            <a:srgbClr val="2E6FB5"/>
-          </a:solidFill>
-          <a:ln/>
-        </p:spPr>
-      </p:sp>
-      <p:sp>
-        <p:nvSpPr>
-          <p:cNvPr id="32" name="Text 30"/>
-          <p:cNvSpPr/>
-          <p:nvPr/>
-        </p:nvSpPr>
-        <p:spPr>
-          <a:xfrm>
-            <a:off x="5405933" y="3675888"/>
-            <a:ext cx="1532534" cy="548640"/>
-          </a:xfrm>
-          <a:prstGeom prst="rect">
-            <a:avLst/>
-          </a:prstGeom>
-          <a:noFill/>
-          <a:ln/>
-        </p:spPr>
-        <p:txBody>
-          <a:bodyPr wrap="square" lIns="0" tIns="0" rIns="0" bIns="0" rtlCol="0" anchor="t"/>
-          <a:lstStyle/>
-          <a:p>
-            <a:pPr indent="0" marL="0">
-              <a:lnSpc>
-                <a:spcPct val="95000"/>
-              </a:lnSpc>
-              <a:buNone/>
-            </a:pPr>
-            <a:r>
-              <a:rPr lang="en-US" sz="1000" dirty="0">
-                <a:solidFill>
-                  <a:srgbClr val="5A6472"/>
-                </a:solidFill>
-                <a:latin typeface="Calibri" pitchFamily="34" charset="0"/>
-                <a:ea typeface="Calibri" pitchFamily="34" charset="-122"/>
-                <a:cs typeface="Calibri" pitchFamily="34" charset="-120"/>
-              </a:rPr>
-              <a:t>Targets the high-premium middle</a:t>
-            </a:r>
-            <a:endParaRPr lang="en-US" sz="1000" dirty="0"/>
-          </a:p>
-        </p:txBody>
-      </p:sp>
-      <p:sp>
-        <p:nvSpPr>
-          <p:cNvPr id="33" name="Shape 31"/>
+              <a:t>Live fair-lending pill vs 0.85 floor</a:t>
+            </a:r>
+            <a:endParaRPr lang="en-US" sz="950" dirty="0"/>
+          </a:p>
+        </p:txBody>
+      </p:sp>
+      <p:sp>
+        <p:nvSpPr>
+          <p:cNvPr id="36" name="Shape 34"/>
           <p:cNvSpPr/>
           <p:nvPr/>
         </p:nvSpPr>
@@ -2003,7 +2111,7 @@
       </p:sp>
       <p:sp>
         <p:nvSpPr>
-          <p:cNvPr id="34" name="Shape 32"/>
+          <p:cNvPr id="37" name="Shape 35"/>
           <p:cNvSpPr/>
           <p:nvPr/>
         </p:nvSpPr>
@@ -2030,7 +2138,7 @@
       </p:sp>
       <p:sp>
         <p:nvSpPr>
-          <p:cNvPr id="35" name="Shape 33"/>
+          <p:cNvPr id="38" name="Shape 36"/>
           <p:cNvSpPr/>
           <p:nvPr/>
         </p:nvSpPr>
@@ -2052,7 +2160,7 @@
       </p:sp>
       <p:sp>
         <p:nvSpPr>
-          <p:cNvPr id="36" name="Text 34"/>
+          <p:cNvPr id="39" name="Text 37"/>
           <p:cNvSpPr/>
           <p:nvPr/>
         </p:nvSpPr>
@@ -2091,14 +2199,14 @@
       </p:sp>
       <p:sp>
         <p:nvSpPr>
-          <p:cNvPr id="37" name="Text 35"/>
+          <p:cNvPr id="40" name="Text 38"/>
           <p:cNvSpPr/>
           <p:nvPr/>
         </p:nvSpPr>
         <p:spPr>
           <a:xfrm>
             <a:off x="7962595" y="2377440"/>
-            <a:ext cx="1313078" cy="640080"/>
+            <a:ext cx="1313078" cy="256032"/>
           </a:xfrm>
           <a:prstGeom prst="rect">
             <a:avLst/>
@@ -2108,6 +2216,104 @@
         </p:spPr>
         <p:txBody>
           <a:bodyPr wrap="square" lIns="0" tIns="0" rIns="0" bIns="0" rtlCol="0" anchor="ctr"/>
+          <a:lstStyle/>
+          <a:p>
+            <a:pPr indent="0" marL="0">
+              <a:buNone/>
+            </a:pPr>
+            <a:r>
+              <a:rPr lang="en-US" sz="1300" b="1" dirty="0">
+                <a:solidFill>
+                  <a:srgbClr val="12315B"/>
+                </a:solidFill>
+                <a:latin typeface="Calibri" pitchFamily="34" charset="0"/>
+                <a:ea typeface="Calibri" pitchFamily="34" charset="-122"/>
+                <a:cs typeface="Calibri" pitchFamily="34" charset="-120"/>
+              </a:rPr>
+              <a:t>Deploy</a:t>
+            </a:r>
+            <a:endParaRPr lang="en-US" sz="1300" dirty="0"/>
+          </a:p>
+        </p:txBody>
+      </p:sp>
+      <p:sp>
+        <p:nvSpPr>
+          <p:cNvPr id="41" name="Text 39"/>
+          <p:cNvSpPr/>
+          <p:nvPr/>
+        </p:nvSpPr>
+        <p:spPr>
+          <a:xfrm>
+            <a:off x="7962595" y="2633472"/>
+            <a:ext cx="1331366" cy="201168"/>
+          </a:xfrm>
+          <a:prstGeom prst="rect">
+            <a:avLst/>
+          </a:prstGeom>
+          <a:noFill/>
+          <a:ln/>
+        </p:spPr>
+        <p:txBody>
+          <a:bodyPr wrap="square" lIns="0" tIns="0" rIns="0" bIns="0" rtlCol="0" anchor="ctr"/>
+          <a:lstStyle/>
+          <a:p>
+            <a:pPr indent="0" marL="0">
+              <a:buNone/>
+            </a:pPr>
+            <a:r>
+              <a:rPr lang="en-US" sz="800" b="1" spc="100" kern="0" dirty="0">
+                <a:solidFill>
+                  <a:srgbClr val="2E6FB5"/>
+                </a:solidFill>
+                <a:latin typeface="Calibri" pitchFamily="34" charset="0"/>
+                <a:ea typeface="Calibri" pitchFamily="34" charset="-122"/>
+                <a:cs typeface="Calibri" pitchFamily="34" charset="-120"/>
+              </a:rPr>
+              <a:t>APPROVAL → RCT</a:t>
+            </a:r>
+            <a:endParaRPr lang="en-US" sz="800" dirty="0"/>
+          </a:p>
+        </p:txBody>
+      </p:sp>
+      <p:sp>
+        <p:nvSpPr>
+          <p:cNvPr id="42" name="Shape 40"/>
+          <p:cNvSpPr/>
+          <p:nvPr/>
+        </p:nvSpPr>
+        <p:spPr>
+          <a:xfrm>
+            <a:off x="7541971" y="3127248"/>
+            <a:ext cx="73152" cy="73152"/>
+          </a:xfrm>
+          <a:prstGeom prst="rect">
+            <a:avLst/>
+          </a:prstGeom>
+          <a:solidFill>
+            <a:srgbClr val="2E6FB5"/>
+          </a:solidFill>
+          <a:ln/>
+        </p:spPr>
+      </p:sp>
+      <p:sp>
+        <p:nvSpPr>
+          <p:cNvPr id="43" name="Text 41"/>
+          <p:cNvSpPr/>
+          <p:nvPr/>
+        </p:nvSpPr>
+        <p:spPr>
+          <a:xfrm>
+            <a:off x="7706563" y="3044952"/>
+            <a:ext cx="1532534" cy="566928"/>
+          </a:xfrm>
+          <a:prstGeom prst="rect">
+            <a:avLst/>
+          </a:prstGeom>
+          <a:noFill/>
+          <a:ln/>
+        </p:spPr>
+        <p:txBody>
+          <a:bodyPr wrap="square" lIns="0" tIns="0" rIns="0" bIns="0" rtlCol="0" anchor="t"/>
           <a:lstStyle/>
           <a:p>
             <a:pPr indent="0" marL="0">
@@ -2117,29 +2323,29 @@
               <a:buNone/>
             </a:pPr>
             <a:r>
-              <a:rPr lang="en-US" sz="1250" b="1" dirty="0">
-                <a:solidFill>
-                  <a:srgbClr val="12315B"/>
-                </a:solidFill>
-                <a:latin typeface="Calibri" pitchFamily="34" charset="0"/>
-                <a:ea typeface="Calibri" pitchFamily="34" charset="-122"/>
-                <a:cs typeface="Calibri" pitchFamily="34" charset="-120"/>
-              </a:rPr>
-              <a:t>Retention action orchestration</a:t>
-            </a:r>
-            <a:endParaRPr lang="en-US" sz="1250" dirty="0"/>
-          </a:p>
-        </p:txBody>
-      </p:sp>
-      <p:sp>
-        <p:nvSpPr>
-          <p:cNvPr id="38" name="Shape 36"/>
-          <p:cNvSpPr/>
-          <p:nvPr/>
-        </p:nvSpPr>
-        <p:spPr>
-          <a:xfrm>
-            <a:off x="7541971" y="3172968"/>
+              <a:rPr lang="en-US" sz="950" dirty="0">
+                <a:solidFill>
+                  <a:srgbClr val="5A6472"/>
+                </a:solidFill>
+                <a:latin typeface="Calibri" pitchFamily="34" charset="0"/>
+                <a:ea typeface="Calibri" pitchFamily="34" charset="-122"/>
+                <a:cs typeface="Calibri" pitchFamily="34" charset="-120"/>
+              </a:rPr>
+              <a:t>Risk · MRM · Business Lead sign-off, then compliance gate</a:t>
+            </a:r>
+            <a:endParaRPr lang="en-US" sz="950" dirty="0"/>
+          </a:p>
+        </p:txBody>
+      </p:sp>
+      <p:sp>
+        <p:nvSpPr>
+          <p:cNvPr id="44" name="Shape 42"/>
+          <p:cNvSpPr/>
+          <p:nvPr/>
+        </p:nvSpPr>
+        <p:spPr>
+          <a:xfrm>
+            <a:off x="7541971" y="3730752"/>
             <a:ext cx="73152" cy="73152"/>
           </a:xfrm>
           <a:prstGeom prst="rect">
@@ -2153,14 +2359,14 @@
       </p:sp>
       <p:sp>
         <p:nvSpPr>
-          <p:cNvPr id="39" name="Text 37"/>
-          <p:cNvSpPr/>
-          <p:nvPr/>
-        </p:nvSpPr>
-        <p:spPr>
-          <a:xfrm>
-            <a:off x="7706563" y="3090672"/>
-            <a:ext cx="1532534" cy="548640"/>
+          <p:cNvPr id="45" name="Text 43"/>
+          <p:cNvSpPr/>
+          <p:nvPr/>
+        </p:nvSpPr>
+        <p:spPr>
+          <a:xfrm>
+            <a:off x="7706563" y="3648456"/>
+            <a:ext cx="1532534" cy="566928"/>
           </a:xfrm>
           <a:prstGeom prst="rect">
             <a:avLst/>
@@ -2179,7 +2385,7 @@
               <a:buNone/>
             </a:pPr>
             <a:r>
-              <a:rPr lang="en-US" sz="1000" dirty="0">
+              <a:rPr lang="en-US" sz="950" dirty="0">
                 <a:solidFill>
                   <a:srgbClr val="5A6472"/>
                 </a:solidFill>
@@ -2187,77 +2393,15 @@
                 <a:ea typeface="Calibri" pitchFamily="34" charset="-122"/>
                 <a:cs typeface="Calibri" pitchFamily="34" charset="-120"/>
               </a:rPr>
-              <a:t>Best next action: price, bundle or call</a:t>
-            </a:r>
-            <a:endParaRPr lang="en-US" sz="1000" dirty="0"/>
-          </a:p>
-        </p:txBody>
-      </p:sp>
-      <p:sp>
-        <p:nvSpPr>
-          <p:cNvPr id="40" name="Shape 38"/>
-          <p:cNvSpPr/>
-          <p:nvPr/>
-        </p:nvSpPr>
-        <p:spPr>
-          <a:xfrm>
-            <a:off x="7541971" y="3758184"/>
-            <a:ext cx="73152" cy="73152"/>
-          </a:xfrm>
-          <a:prstGeom prst="rect">
-            <a:avLst/>
-          </a:prstGeom>
-          <a:solidFill>
-            <a:srgbClr val="2E6FB5"/>
-          </a:solidFill>
-          <a:ln/>
-        </p:spPr>
-      </p:sp>
-      <p:sp>
-        <p:nvSpPr>
-          <p:cNvPr id="41" name="Text 39"/>
-          <p:cNvSpPr/>
-          <p:nvPr/>
-        </p:nvSpPr>
-        <p:spPr>
-          <a:xfrm>
-            <a:off x="7706563" y="3675888"/>
-            <a:ext cx="1532534" cy="548640"/>
-          </a:xfrm>
-          <a:prstGeom prst="rect">
-            <a:avLst/>
-          </a:prstGeom>
-          <a:noFill/>
-          <a:ln/>
-        </p:spPr>
-        <p:txBody>
-          <a:bodyPr wrap="square" lIns="0" tIns="0" rIns="0" bIns="0" rtlCol="0" anchor="t"/>
-          <a:lstStyle/>
-          <a:p>
-            <a:pPr indent="0" marL="0">
-              <a:lnSpc>
-                <a:spcPct val="95000"/>
-              </a:lnSpc>
-              <a:buNone/>
-            </a:pPr>
-            <a:r>
-              <a:rPr lang="en-US" sz="1000" dirty="0">
-                <a:solidFill>
-                  <a:srgbClr val="5A6472"/>
-                </a:solidFill>
-                <a:latin typeface="Calibri" pitchFamily="34" charset="0"/>
-                <a:ea typeface="Calibri" pitchFamily="34" charset="-122"/>
-                <a:cs typeface="Calibri" pitchFamily="34" charset="-120"/>
-              </a:rPr>
-              <a:t>Executed via CRM &amp; channel systems</a:t>
-            </a:r>
-            <a:endParaRPr lang="en-US" sz="1000" dirty="0"/>
-          </a:p>
-        </p:txBody>
-      </p:sp>
-      <p:sp>
-        <p:nvSpPr>
-          <p:cNvPr id="42" name="Shape 40"/>
+              <a:t>440,679 treatment · 110,170 holdout · auto-rollback armed</a:t>
+            </a:r>
+            <a:endParaRPr lang="en-US" sz="950" dirty="0"/>
+          </a:p>
+        </p:txBody>
+      </p:sp>
+      <p:sp>
+        <p:nvSpPr>
+          <p:cNvPr id="46" name="Shape 44"/>
           <p:cNvSpPr/>
           <p:nvPr/>
         </p:nvSpPr>
@@ -2282,7 +2426,7 @@
       </p:sp>
       <p:sp>
         <p:nvSpPr>
-          <p:cNvPr id="43" name="Shape 41"/>
+          <p:cNvPr id="47" name="Shape 45"/>
           <p:cNvSpPr/>
           <p:nvPr/>
         </p:nvSpPr>
@@ -2309,7 +2453,7 @@
       </p:sp>
       <p:sp>
         <p:nvSpPr>
-          <p:cNvPr id="44" name="Shape 42"/>
+          <p:cNvPr id="48" name="Shape 46"/>
           <p:cNvSpPr/>
           <p:nvPr/>
         </p:nvSpPr>
@@ -2331,7 +2475,7 @@
       </p:sp>
       <p:sp>
         <p:nvSpPr>
-          <p:cNvPr id="45" name="Text 43"/>
+          <p:cNvPr id="49" name="Text 47"/>
           <p:cNvSpPr/>
           <p:nvPr/>
         </p:nvSpPr>
@@ -2370,14 +2514,14 @@
       </p:sp>
       <p:sp>
         <p:nvSpPr>
-          <p:cNvPr id="46" name="Text 44"/>
+          <p:cNvPr id="50" name="Text 48"/>
           <p:cNvSpPr/>
           <p:nvPr/>
         </p:nvSpPr>
         <p:spPr>
           <a:xfrm>
             <a:off x="10263226" y="2377440"/>
-            <a:ext cx="1313078" cy="640080"/>
+            <a:ext cx="1313078" cy="256032"/>
           </a:xfrm>
           <a:prstGeom prst="rect">
             <a:avLst/>
@@ -2387,6 +2531,104 @@
         </p:spPr>
         <p:txBody>
           <a:bodyPr wrap="square" lIns="0" tIns="0" rIns="0" bIns="0" rtlCol="0" anchor="ctr"/>
+          <a:lstStyle/>
+          <a:p>
+            <a:pPr indent="0" marL="0">
+              <a:buNone/>
+            </a:pPr>
+            <a:r>
+              <a:rPr lang="en-US" sz="1300" b="1" dirty="0">
+                <a:solidFill>
+                  <a:srgbClr val="12315B"/>
+                </a:solidFill>
+                <a:latin typeface="Calibri" pitchFamily="34" charset="0"/>
+                <a:ea typeface="Calibri" pitchFamily="34" charset="-122"/>
+                <a:cs typeface="Calibri" pitchFamily="34" charset="-120"/>
+              </a:rPr>
+              <a:t>Learn</a:t>
+            </a:r>
+            <a:endParaRPr lang="en-US" sz="1300" dirty="0"/>
+          </a:p>
+        </p:txBody>
+      </p:sp>
+      <p:sp>
+        <p:nvSpPr>
+          <p:cNvPr id="51" name="Text 49"/>
+          <p:cNvSpPr/>
+          <p:nvPr/>
+        </p:nvSpPr>
+        <p:spPr>
+          <a:xfrm>
+            <a:off x="10263226" y="2633472"/>
+            <a:ext cx="1331366" cy="201168"/>
+          </a:xfrm>
+          <a:prstGeom prst="rect">
+            <a:avLst/>
+          </a:prstGeom>
+          <a:noFill/>
+          <a:ln/>
+        </p:spPr>
+        <p:txBody>
+          <a:bodyPr wrap="square" lIns="0" tIns="0" rIns="0" bIns="0" rtlCol="0" anchor="ctr"/>
+          <a:lstStyle/>
+          <a:p>
+            <a:pPr indent="0" marL="0">
+              <a:buNone/>
+            </a:pPr>
+            <a:r>
+              <a:rPr lang="en-US" sz="800" b="1" spc="100" kern="0" dirty="0">
+                <a:solidFill>
+                  <a:srgbClr val="2E6FB5"/>
+                </a:solidFill>
+                <a:latin typeface="Calibri" pitchFamily="34" charset="0"/>
+                <a:ea typeface="Calibri" pitchFamily="34" charset="-122"/>
+                <a:cs typeface="Calibri" pitchFamily="34" charset="-120"/>
+              </a:rPr>
+              <a:t>MEASURED</a:t>
+            </a:r>
+            <a:endParaRPr lang="en-US" sz="800" dirty="0"/>
+          </a:p>
+        </p:txBody>
+      </p:sp>
+      <p:sp>
+        <p:nvSpPr>
+          <p:cNvPr id="52" name="Shape 50"/>
+          <p:cNvSpPr/>
+          <p:nvPr/>
+        </p:nvSpPr>
+        <p:spPr>
+          <a:xfrm>
+            <a:off x="9842602" y="3127248"/>
+            <a:ext cx="73152" cy="73152"/>
+          </a:xfrm>
+          <a:prstGeom prst="rect">
+            <a:avLst/>
+          </a:prstGeom>
+          <a:solidFill>
+            <a:srgbClr val="2E6FB5"/>
+          </a:solidFill>
+          <a:ln/>
+        </p:spPr>
+      </p:sp>
+      <p:sp>
+        <p:nvSpPr>
+          <p:cNvPr id="53" name="Text 51"/>
+          <p:cNvSpPr/>
+          <p:nvPr/>
+        </p:nvSpPr>
+        <p:spPr>
+          <a:xfrm>
+            <a:off x="10007194" y="3044952"/>
+            <a:ext cx="1532534" cy="566928"/>
+          </a:xfrm>
+          <a:prstGeom prst="rect">
+            <a:avLst/>
+          </a:prstGeom>
+          <a:noFill/>
+          <a:ln/>
+        </p:spPr>
+        <p:txBody>
+          <a:bodyPr wrap="square" lIns="0" tIns="0" rIns="0" bIns="0" rtlCol="0" anchor="t"/>
           <a:lstStyle/>
           <a:p>
             <a:pPr indent="0" marL="0">
@@ -2396,29 +2638,29 @@
               <a:buNone/>
             </a:pPr>
             <a:r>
-              <a:rPr lang="en-US" sz="1250" b="1" dirty="0">
-                <a:solidFill>
-                  <a:srgbClr val="12315B"/>
-                </a:solidFill>
-                <a:latin typeface="Calibri" pitchFamily="34" charset="0"/>
-                <a:ea typeface="Calibri" pitchFamily="34" charset="-122"/>
-                <a:cs typeface="Calibri" pitchFamily="34" charset="-120"/>
-              </a:rPr>
-              <a:t>Measure &amp; learn</a:t>
-            </a:r>
-            <a:endParaRPr lang="en-US" sz="1250" dirty="0"/>
-          </a:p>
-        </p:txBody>
-      </p:sp>
-      <p:sp>
-        <p:nvSpPr>
-          <p:cNvPr id="47" name="Shape 45"/>
-          <p:cNvSpPr/>
-          <p:nvPr/>
-        </p:nvSpPr>
-        <p:spPr>
-          <a:xfrm>
-            <a:off x="9842602" y="3172968"/>
+              <a:rPr lang="en-US" sz="950" dirty="0">
+                <a:solidFill>
+                  <a:srgbClr val="5A6472"/>
+                </a:solidFill>
+                <a:latin typeface="Calibri" pitchFamily="34" charset="0"/>
+                <a:ea typeface="Calibri" pitchFamily="34" charset="-122"/>
+                <a:cs typeface="Calibri" pitchFamily="34" charset="-120"/>
+              </a:rPr>
+              <a:t>Realised vs predicted; writeback to the elasticity model</a:t>
+            </a:r>
+            <a:endParaRPr lang="en-US" sz="950" dirty="0"/>
+          </a:p>
+        </p:txBody>
+      </p:sp>
+      <p:sp>
+        <p:nvSpPr>
+          <p:cNvPr id="54" name="Shape 52"/>
+          <p:cNvSpPr/>
+          <p:nvPr/>
+        </p:nvSpPr>
+        <p:spPr>
+          <a:xfrm>
+            <a:off x="9842602" y="3730752"/>
             <a:ext cx="73152" cy="73152"/>
           </a:xfrm>
           <a:prstGeom prst="rect">
@@ -2432,14 +2674,14 @@
       </p:sp>
       <p:sp>
         <p:nvSpPr>
-          <p:cNvPr id="48" name="Text 46"/>
-          <p:cNvSpPr/>
-          <p:nvPr/>
-        </p:nvSpPr>
-        <p:spPr>
-          <a:xfrm>
-            <a:off x="10007194" y="3090672"/>
-            <a:ext cx="1532534" cy="548640"/>
+          <p:cNvPr id="55" name="Text 53"/>
+          <p:cNvSpPr/>
+          <p:nvPr/>
+        </p:nvSpPr>
+        <p:spPr>
+          <a:xfrm>
+            <a:off x="10007194" y="3648456"/>
+            <a:ext cx="1532534" cy="566928"/>
           </a:xfrm>
           <a:prstGeom prst="rect">
             <a:avLst/>
@@ -2458,7 +2700,7 @@
               <a:buNone/>
             </a:pPr>
             <a:r>
-              <a:rPr lang="en-US" sz="1000" dirty="0">
+              <a:rPr lang="en-US" sz="950" dirty="0">
                 <a:solidFill>
                   <a:srgbClr val="5A6472"/>
                 </a:solidFill>
@@ -2466,77 +2708,15 @@
                 <a:ea typeface="Calibri" pitchFamily="34" charset="-122"/>
                 <a:cs typeface="Calibri" pitchFamily="34" charset="-120"/>
               </a:rPr>
-              <a:t>Lift measured vs. a holdout</a:t>
-            </a:r>
-            <a:endParaRPr lang="en-US" sz="1000" dirty="0"/>
-          </a:p>
-        </p:txBody>
-      </p:sp>
-      <p:sp>
-        <p:nvSpPr>
-          <p:cNvPr id="49" name="Shape 47"/>
-          <p:cNvSpPr/>
-          <p:nvPr/>
-        </p:nvSpPr>
-        <p:spPr>
-          <a:xfrm>
-            <a:off x="9842602" y="3758184"/>
-            <a:ext cx="73152" cy="73152"/>
-          </a:xfrm>
-          <a:prstGeom prst="rect">
-            <a:avLst/>
-          </a:prstGeom>
-          <a:solidFill>
-            <a:srgbClr val="2E6FB5"/>
-          </a:solidFill>
-          <a:ln/>
-        </p:spPr>
-      </p:sp>
-      <p:sp>
-        <p:nvSpPr>
-          <p:cNvPr id="50" name="Text 48"/>
-          <p:cNvSpPr/>
-          <p:nvPr/>
-        </p:nvSpPr>
-        <p:spPr>
-          <a:xfrm>
-            <a:off x="10007194" y="3675888"/>
-            <a:ext cx="1532534" cy="548640"/>
-          </a:xfrm>
-          <a:prstGeom prst="rect">
-            <a:avLst/>
-          </a:prstGeom>
-          <a:noFill/>
-          <a:ln/>
-        </p:spPr>
-        <p:txBody>
-          <a:bodyPr wrap="square" lIns="0" tIns="0" rIns="0" bIns="0" rtlCol="0" anchor="t"/>
-          <a:lstStyle/>
-          <a:p>
-            <a:pPr indent="0" marL="0">
-              <a:lnSpc>
-                <a:spcPct val="95000"/>
-              </a:lnSpc>
-              <a:buNone/>
-            </a:pPr>
-            <a:r>
-              <a:rPr lang="en-US" sz="1000" dirty="0">
-                <a:solidFill>
-                  <a:srgbClr val="5A6472"/>
-                </a:solidFill>
-                <a:latin typeface="Calibri" pitchFamily="34" charset="0"/>
-                <a:ea typeface="Calibri" pitchFamily="34" charset="-122"/>
-                <a:cs typeface="Calibri" pitchFamily="34" charset="-120"/>
-              </a:rPr>
-              <a:t>Outcomes retrain the model weekly</a:t>
-            </a:r>
-            <a:endParaRPr lang="en-US" sz="1000" dirty="0"/>
-          </a:p>
-        </p:txBody>
-      </p:sp>
-      <p:sp>
-        <p:nvSpPr>
-          <p:cNvPr id="51" name="Text 49"/>
+              <a:t>Lapse 30% → 11% held across the 8-wk pilot</a:t>
+            </a:r>
+            <a:endParaRPr lang="en-US" sz="950" dirty="0"/>
+          </a:p>
+        </p:txBody>
+      </p:sp>
+      <p:sp>
+        <p:nvSpPr>
+          <p:cNvPr id="56" name="Text 54"/>
           <p:cNvSpPr/>
           <p:nvPr/>
         </p:nvSpPr>
@@ -2567,7 +2747,7 @@
                 <a:ea typeface="Calibri" pitchFamily="34" charset="-122"/>
                 <a:cs typeface="Calibri" pitchFamily="34" charset="-120"/>
               </a:rPr>
-              <a:t>ENABLING DATA &amp; SYSTEMS   </a:t>
+              <a:t>MODELS &amp; GUARDRAILS   </a:t>
             </a:r>
             <a:pPr indent="0" marL="0">
               <a:buNone/>
@@ -2581,7 +2761,7 @@
                 <a:ea typeface="Calibri" pitchFamily="34" charset="-122"/>
                 <a:cs typeface="Calibri" pitchFamily="34" charset="-120"/>
               </a:rPr>
-              <a:t>Policy admin · Claims history · CRM &amp; agency · Pricing engine · Competitor rate feed · Marketing automation</a:t>
+              <a:t>Rate-elasticity · stickiness (0.70 gate) · shopping-propensity · fair-lending margin under NAIC Model Bulletin 24-08</a:t>
             </a:r>
             <a:endParaRPr lang="en-US" sz="1050" dirty="0"/>
           </a:p>
@@ -2589,7 +2769,7 @@
       </p:sp>
       <p:sp>
         <p:nvSpPr>
-          <p:cNvPr id="52" name="Shape 50"/>
+          <p:cNvPr id="57" name="Shape 55"/>
           <p:cNvSpPr/>
           <p:nvPr/>
         </p:nvSpPr>
@@ -2612,14 +2792,14 @@
       </p:sp>
       <p:sp>
         <p:nvSpPr>
-          <p:cNvPr id="53" name="Text 51"/>
+          <p:cNvPr id="58" name="Text 56"/>
           <p:cNvSpPr/>
           <p:nvPr/>
         </p:nvSpPr>
         <p:spPr>
           <a:xfrm>
             <a:off x="457200" y="4937760"/>
-            <a:ext cx="5486400" cy="256032"/>
+            <a:ext cx="6400800" cy="256032"/>
           </a:xfrm>
           <a:prstGeom prst="rect">
             <a:avLst/>
@@ -2635,7 +2815,7 @@
               <a:buNone/>
             </a:pPr>
             <a:r>
-              <a:rPr lang="en-US" sz="1100" b="1" spc="200" kern="0" dirty="0">
+              <a:rPr lang="en-US" sz="1100" b="1" spc="100" kern="0" dirty="0">
                 <a:solidFill>
                   <a:srgbClr val="12315B"/>
                 </a:solidFill>
@@ -2643,7 +2823,7 @@
                 <a:ea typeface="Calibri" pitchFamily="34" charset="-122"/>
                 <a:cs typeface="Calibri" pitchFamily="34" charset="-120"/>
               </a:rPr>
-              <a:t>THE PAYOFF</a:t>
+              <a:t>PROOF  ·  SIMULATED, THEN MEASURED IN PILOT</a:t>
             </a:r>
             <a:endParaRPr lang="en-US" sz="1100" dirty="0"/>
           </a:p>
@@ -2651,7 +2831,7 @@
       </p:sp>
       <p:sp>
         <p:nvSpPr>
-          <p:cNvPr id="54" name="Shape 52"/>
+          <p:cNvPr id="59" name="Shape 57"/>
           <p:cNvSpPr/>
           <p:nvPr/>
         </p:nvSpPr>
@@ -2678,7 +2858,7 @@
       </p:sp>
       <p:sp>
         <p:nvSpPr>
-          <p:cNvPr id="55" name="Text 53"/>
+          <p:cNvPr id="60" name="Text 58"/>
           <p:cNvSpPr/>
           <p:nvPr/>
         </p:nvSpPr>
@@ -2701,7 +2881,7 @@
               <a:buNone/>
             </a:pPr>
             <a:r>
-              <a:rPr lang="en-US" sz="2500" b="1" dirty="0">
+              <a:rPr lang="en-US" sz="2200" b="1" dirty="0">
                 <a:solidFill>
                   <a:srgbClr val="12315B"/>
                 </a:solidFill>
@@ -2709,29 +2889,18 @@
                 <a:ea typeface="Cambria" pitchFamily="34" charset="-122"/>
                 <a:cs typeface="Cambria" pitchFamily="34" charset="-120"/>
               </a:rPr>
-              <a:t>3–5</a:t>
+              <a:t>$138.2M</a:t>
             </a:r>
             <a:pPr algn="ctr" indent="0" marL="0">
               <a:buNone/>
             </a:pPr>
-            <a:r>
-              <a:rPr lang="en-US" sz="1300" b="1" dirty="0">
-                <a:solidFill>
-                  <a:srgbClr val="2E6FB5"/>
-                </a:solidFill>
-                <a:latin typeface="Cambria" pitchFamily="34" charset="0"/>
-                <a:ea typeface="Cambria" pitchFamily="34" charset="-122"/>
-                <a:cs typeface="Cambria" pitchFamily="34" charset="-120"/>
-              </a:rPr>
-              <a:t>pts</a:t>
-            </a:r>
-            <a:endParaRPr lang="en-US" sz="2500" dirty="0"/>
-          </a:p>
-        </p:txBody>
-      </p:sp>
-      <p:sp>
-        <p:nvSpPr>
-          <p:cNvPr id="56" name="Text 54"/>
+            <a:endParaRPr lang="en-US" sz="2200" dirty="0"/>
+          </a:p>
+        </p:txBody>
+      </p:sp>
+      <p:sp>
+        <p:nvSpPr>
+          <p:cNvPr id="61" name="Text 59"/>
           <p:cNvSpPr/>
           <p:nvPr/>
         </p:nvSpPr>
@@ -2765,7 +2934,7 @@
                 <a:ea typeface="Calibri" pitchFamily="34" charset="-122"/>
                 <a:cs typeface="Calibri" pitchFamily="34" charset="-120"/>
               </a:rPr>
-              <a:t>Retention-rate lift on targeted segments</a:t>
+              <a:t>Protected NWP per year</a:t>
             </a:r>
             <a:endParaRPr lang="en-US" sz="950" dirty="0"/>
           </a:p>
@@ -2773,7 +2942,7 @@
       </p:sp>
       <p:sp>
         <p:nvSpPr>
-          <p:cNvPr id="57" name="Shape 55"/>
+          <p:cNvPr id="62" name="Shape 60"/>
           <p:cNvSpPr/>
           <p:nvPr/>
         </p:nvSpPr>
@@ -2800,7 +2969,7 @@
       </p:sp>
       <p:sp>
         <p:nvSpPr>
-          <p:cNvPr id="58" name="Text 56"/>
+          <p:cNvPr id="63" name="Text 61"/>
           <p:cNvSpPr/>
           <p:nvPr/>
         </p:nvSpPr>
@@ -2823,7 +2992,7 @@
               <a:buNone/>
             </a:pPr>
             <a:r>
-              <a:rPr lang="en-US" sz="2500" b="1" dirty="0">
+              <a:rPr lang="en-US" sz="2200" b="1" dirty="0">
                 <a:solidFill>
                   <a:srgbClr val="12315B"/>
                 </a:solidFill>
@@ -2831,18 +3000,29 @@
                 <a:ea typeface="Cambria" pitchFamily="34" charset="-122"/>
                 <a:cs typeface="Cambria" pitchFamily="34" charset="-120"/>
               </a:rPr>
-              <a:t>8:1</a:t>
+              <a:t>−19</a:t>
             </a:r>
             <a:pPr algn="ctr" indent="0" marL="0">
               <a:buNone/>
             </a:pPr>
-            <a:endParaRPr lang="en-US" sz="2500" dirty="0"/>
-          </a:p>
-        </p:txBody>
-      </p:sp>
-      <p:sp>
-        <p:nvSpPr>
-          <p:cNvPr id="59" name="Text 57"/>
+            <a:r>
+              <a:rPr lang="en-US" sz="1200" b="1" dirty="0">
+                <a:solidFill>
+                  <a:srgbClr val="2E6FB5"/>
+                </a:solidFill>
+                <a:latin typeface="Cambria" pitchFamily="34" charset="0"/>
+                <a:ea typeface="Cambria" pitchFamily="34" charset="-122"/>
+                <a:cs typeface="Cambria" pitchFamily="34" charset="-120"/>
+              </a:rPr>
+              <a:t> pts</a:t>
+            </a:r>
+            <a:endParaRPr lang="en-US" sz="2200" dirty="0"/>
+          </a:p>
+        </p:txBody>
+      </p:sp>
+      <p:sp>
+        <p:nvSpPr>
+          <p:cNvPr id="64" name="Text 62"/>
           <p:cNvSpPr/>
           <p:nvPr/>
         </p:nvSpPr>
@@ -2876,7 +3056,7 @@
                 <a:ea typeface="Calibri" pitchFamily="34" charset="-122"/>
                 <a:cs typeface="Calibri" pitchFamily="34" charset="-120"/>
               </a:rPr>
-              <a:t>ROI vs. untargeted outreach</a:t>
+              <a:t>Lapse reduction (30% → 11%)</a:t>
             </a:r>
             <a:endParaRPr lang="en-US" sz="950" dirty="0"/>
           </a:p>
@@ -2884,7 +3064,7 @@
       </p:sp>
       <p:sp>
         <p:nvSpPr>
-          <p:cNvPr id="60" name="Shape 58"/>
+          <p:cNvPr id="65" name="Shape 63"/>
           <p:cNvSpPr/>
           <p:nvPr/>
         </p:nvSpPr>
@@ -2911,7 +3091,7 @@
       </p:sp>
       <p:sp>
         <p:nvSpPr>
-          <p:cNvPr id="61" name="Text 59"/>
+          <p:cNvPr id="66" name="Text 64"/>
           <p:cNvSpPr/>
           <p:nvPr/>
         </p:nvSpPr>
@@ -2934,7 +3114,7 @@
               <a:buNone/>
             </a:pPr>
             <a:r>
-              <a:rPr lang="en-US" sz="2500" b="1" dirty="0">
+              <a:rPr lang="en-US" sz="2200" b="1" dirty="0">
                 <a:solidFill>
                   <a:srgbClr val="12315B"/>
                 </a:solidFill>
@@ -2942,29 +3122,18 @@
                 <a:ea typeface="Cambria" pitchFamily="34" charset="-122"/>
                 <a:cs typeface="Cambria" pitchFamily="34" charset="-120"/>
               </a:rPr>
-              <a:t>60–90</a:t>
+              <a:t>0.93</a:t>
             </a:r>
             <a:pPr algn="ctr" indent="0" marL="0">
               <a:buNone/>
             </a:pPr>
-            <a:r>
-              <a:rPr lang="en-US" sz="1300" b="1" dirty="0">
-                <a:solidFill>
-                  <a:srgbClr val="2E6FB5"/>
-                </a:solidFill>
-                <a:latin typeface="Cambria" pitchFamily="34" charset="0"/>
-                <a:ea typeface="Cambria" pitchFamily="34" charset="-122"/>
-                <a:cs typeface="Cambria" pitchFamily="34" charset="-120"/>
-              </a:rPr>
-              <a:t>d</a:t>
-            </a:r>
-            <a:endParaRPr lang="en-US" sz="2500" dirty="0"/>
-          </a:p>
-        </p:txBody>
-      </p:sp>
-      <p:sp>
-        <p:nvSpPr>
-          <p:cNvPr id="62" name="Text 60"/>
+            <a:endParaRPr lang="en-US" sz="2200" dirty="0"/>
+          </a:p>
+        </p:txBody>
+      </p:sp>
+      <p:sp>
+        <p:nvSpPr>
+          <p:cNvPr id="67" name="Text 65"/>
           <p:cNvSpPr/>
           <p:nvPr/>
         </p:nvSpPr>
@@ -2998,7 +3167,7 @@
                 <a:ea typeface="Calibri" pitchFamily="34" charset="-122"/>
                 <a:cs typeface="Calibri" pitchFamily="34" charset="-120"/>
               </a:rPr>
-              <a:t>Lead time before renewal date</a:t>
+              <a:t>Fair-lending margin vs 0.85 floor</a:t>
             </a:r>
             <a:endParaRPr lang="en-US" sz="950" dirty="0"/>
           </a:p>
@@ -3006,7 +3175,7 @@
       </p:sp>
       <p:sp>
         <p:nvSpPr>
-          <p:cNvPr id="63" name="Shape 61"/>
+          <p:cNvPr id="68" name="Shape 66"/>
           <p:cNvSpPr/>
           <p:nvPr/>
         </p:nvSpPr>
@@ -3028,7 +3197,7 @@
       </p:sp>
       <p:sp>
         <p:nvSpPr>
-          <p:cNvPr id="64" name="Text 62"/>
+          <p:cNvPr id="69" name="Text 67"/>
           <p:cNvSpPr/>
           <p:nvPr/>
         </p:nvSpPr>
@@ -3059,7 +3228,7 @@
                 <a:ea typeface="Calibri" pitchFamily="34" charset="-122"/>
                 <a:cs typeface="Calibri" pitchFamily="34" charset="-120"/>
               </a:rPr>
-              <a:t>COMPOUNDING ADVANTAGE</a:t>
+              <a:t>WHERE NOT TO ACT</a:t>
             </a:r>
             <a:endParaRPr lang="en-US" sz="1100" dirty="0"/>
           </a:p>
@@ -3067,14 +3236,14 @@
       </p:sp>
       <p:sp>
         <p:nvSpPr>
-          <p:cNvPr id="65" name="Text 63"/>
-          <p:cNvSpPr/>
-          <p:nvPr/>
-        </p:nvSpPr>
-        <p:spPr>
-          <a:xfrm>
-            <a:off x="7662672" y="5394960"/>
-            <a:ext cx="3840480" cy="777240"/>
+          <p:cNvPr id="70" name="Text 68"/>
+          <p:cNvSpPr/>
+          <p:nvPr/>
+        </p:nvSpPr>
+        <p:spPr>
+          <a:xfrm>
+            <a:off x="7662672" y="5376672"/>
+            <a:ext cx="3840480" cy="822960"/>
           </a:xfrm>
           <a:prstGeom prst="rect">
             <a:avLst/>
@@ -3088,12 +3257,12 @@
           <a:p>
             <a:pPr indent="0" marL="0">
               <a:lnSpc>
-                <a:spcPct val="100000"/>
+                <a:spcPct val="98000"/>
               </a:lnSpc>
               <a:buNone/>
             </a:pPr>
             <a:r>
-              <a:rPr lang="en-US" sz="1200" dirty="0">
+              <a:rPr lang="en-US" sz="1100" dirty="0">
                 <a:solidFill>
                   <a:srgbClr val="FFFFFF"/>
                 </a:solidFill>
@@ -3101,15 +3270,15 @@
                 <a:ea typeface="Calibri" pitchFamily="34" charset="-122"/>
                 <a:cs typeface="Calibri" pitchFamily="34" charset="-120"/>
               </a:rPr>
-              <a:t>Every renew / lapse result flows back into training, so targeting and offer economics sharpen with each renewal cycle.</a:t>
-            </a:r>
-            <a:endParaRPr lang="en-US" sz="1200" dirty="0"/>
-          </a:p>
-        </p:txBody>
-      </p:sp>
-      <p:sp>
-        <p:nvSpPr>
-          <p:cNvPr id="66" name="Shape 64"/>
+              <a:t>The Sticky-Bundled archetype — deeply bundled, auto-pay, 8-yr tenure, 0.77 stickiness — gets NO discount. Repricing the operationally loyal is margin given away and a fair-lending basis failure.</a:t>
+            </a:r>
+            <a:endParaRPr lang="en-US" sz="1100" dirty="0"/>
+          </a:p>
+        </p:txBody>
+      </p:sp>
+      <p:sp>
+        <p:nvSpPr>
+          <p:cNvPr id="71" name="Shape 69"/>
           <p:cNvSpPr/>
           <p:nvPr/>
         </p:nvSpPr>
@@ -3132,7 +3301,7 @@
       </p:sp>
       <p:sp>
         <p:nvSpPr>
-          <p:cNvPr id="67" name="Text 65"/>
+          <p:cNvPr id="72" name="Text 70"/>
           <p:cNvSpPr/>
           <p:nvPr/>
         </p:nvSpPr>
@@ -3163,7 +3332,7 @@
                 <a:ea typeface="Calibri" pitchFamily="34" charset="-122"/>
                 <a:cs typeface="Calibri" pitchFamily="34" charset="-120"/>
               </a:rPr>
-              <a:t>Liberty Mutual  |  AI Signal Portfolio</a:t>
+              <a:t>Liberty Mutual · TwinX Decision Cockpit</a:t>
             </a:r>
             <a:endParaRPr lang="en-US" sz="900" dirty="0"/>
           </a:p>
@@ -3171,7 +3340,7 @@
       </p:sp>
       <p:sp>
         <p:nvSpPr>
-          <p:cNvPr id="68" name="Text 66"/>
+          <p:cNvPr id="73" name="Text 71"/>
           <p:cNvSpPr/>
           <p:nvPr/>
         </p:nvSpPr>
@@ -3210,7 +3379,7 @@
       </p:sp>
       <p:sp>
         <p:nvSpPr>
-          <p:cNvPr id="69" name="Text 67"/>
+          <p:cNvPr id="74" name="Text 72"/>
           <p:cNvSpPr/>
           <p:nvPr/>
         </p:nvSpPr>
@@ -3312,7 +3481,7 @@
                 <a:ea typeface="Calibri" pitchFamily="34" charset="-122"/>
                 <a:cs typeface="Calibri" pitchFamily="34" charset="-120"/>
               </a:rPr>
-              <a:t>COMMERCIAL  ·  SIGNAL 2</a:t>
+              <a:t>COMMERCIAL  ·  SIGNAL 2  ·  UNDERWRITING OF THE FUTURE</a:t>
             </a:r>
             <a:endParaRPr lang="en-US" sz="1200" dirty="0"/>
           </a:p>
@@ -3354,7 +3523,7 @@
                 <a:ea typeface="Cambria" pitchFamily="34" charset="-122"/>
                 <a:cs typeface="Cambria" pitchFamily="34" charset="-120"/>
               </a:rPr>
-              <a:t>Underwriting of the Future: write better risk faster by augmenting the underwriter</a:t>
+              <a:t>Win back the growing small-commercial account</a:t>
             </a:r>
             <a:endParaRPr lang="en-US" sz="2600" dirty="0"/>
           </a:p>
@@ -3420,13 +3589,13 @@
                 <a:ea typeface="Calibri" pitchFamily="34" charset="-122"/>
                 <a:cs typeface="Calibri" pitchFamily="34" charset="-120"/>
               </a:rPr>
-              <a:t>THE CHALLENGE    </a:t>
+              <a:t>THE SIGNAL    </a:t>
             </a:r>
             <a:pPr indent="0" marL="0">
               <a:buNone/>
             </a:pPr>
             <a:r>
-              <a:rPr lang="en-US" sz="1250" i="1" dirty="0">
+              <a:rPr lang="en-US" sz="1200" i="1" dirty="0">
                 <a:solidFill>
                   <a:srgbClr val="1A2333"/>
                 </a:solidFill>
@@ -3434,7 +3603,7 @@
                 <a:ea typeface="Calibri" pitchFamily="34" charset="-122"/>
                 <a:cs typeface="Calibri" pitchFamily="34" charset="-120"/>
               </a:rPr>
-              <a:t>Manual intake and inconsistent risk selection slow quotes, drain underwriter capacity, and let mispriced accounts onto the book.</a:t>
+              <a:t>38,400 small businesses are entering expansion — and 61% are placing the new / expanded coverage off-us with insurtechs (Next · Hiscox · biBERK): ~$2.1B of premium leaving.</a:t>
             </a:r>
             <a:endParaRPr lang="en-US" sz="1100" dirty="0"/>
           </a:p>
@@ -3449,7 +3618,7 @@
         <p:spPr>
           <a:xfrm>
             <a:off x="457200" y="1938528"/>
-            <a:ext cx="5486400" cy="256032"/>
+            <a:ext cx="9144000" cy="256032"/>
           </a:xfrm>
           <a:prstGeom prst="rect">
             <a:avLst/>
@@ -3465,7 +3634,7 @@
               <a:buNone/>
             </a:pPr>
             <a:r>
-              <a:rPr lang="en-US" sz="1100" b="1" spc="200" kern="0" dirty="0">
+              <a:rPr lang="en-US" sz="1100" b="1" spc="150" kern="0" dirty="0">
                 <a:solidFill>
                   <a:srgbClr val="12315B"/>
                 </a:solidFill>
@@ -3473,7 +3642,7 @@
                 <a:ea typeface="Calibri" pitchFamily="34" charset="-122"/>
                 <a:cs typeface="Calibri" pitchFamily="34" charset="-120"/>
               </a:rPr>
-              <a:t>HOW THE SIGNAL RESPONDS</a:t>
+              <a:t>THE DECISION LOOP  ·  WHAT THE USER WALKS THROUGH ON SCREEN</a:t>
             </a:r>
             <a:endParaRPr lang="en-US" sz="1100" dirty="0"/>
           </a:p>
@@ -3576,7 +3745,7 @@
         <p:spPr>
           <a:xfrm>
             <a:off x="1060704" y="2377440"/>
-            <a:ext cx="1313078" cy="640080"/>
+            <a:ext cx="1313078" cy="256032"/>
           </a:xfrm>
           <a:prstGeom prst="rect">
             <a:avLst/>
@@ -3586,6 +3755,104 @@
         </p:spPr>
         <p:txBody>
           <a:bodyPr wrap="square" lIns="0" tIns="0" rIns="0" bIns="0" rtlCol="0" anchor="ctr"/>
+          <a:lstStyle/>
+          <a:p>
+            <a:pPr indent="0" marL="0">
+              <a:buNone/>
+            </a:pPr>
+            <a:r>
+              <a:rPr lang="en-US" sz="1300" b="1" dirty="0">
+                <a:solidFill>
+                  <a:srgbClr val="12315B"/>
+                </a:solidFill>
+                <a:latin typeface="Calibri" pitchFamily="34" charset="0"/>
+                <a:ea typeface="Calibri" pitchFamily="34" charset="-122"/>
+                <a:cs typeface="Calibri" pitchFamily="34" charset="-120"/>
+              </a:rPr>
+              <a:t>Sense</a:t>
+            </a:r>
+            <a:endParaRPr lang="en-US" sz="1300" dirty="0"/>
+          </a:p>
+        </p:txBody>
+      </p:sp>
+      <p:sp>
+        <p:nvSpPr>
+          <p:cNvPr id="11" name="Text 9"/>
+          <p:cNvSpPr/>
+          <p:nvPr/>
+        </p:nvSpPr>
+        <p:spPr>
+          <a:xfrm>
+            <a:off x="1060704" y="2633472"/>
+            <a:ext cx="1331366" cy="201168"/>
+          </a:xfrm>
+          <a:prstGeom prst="rect">
+            <a:avLst/>
+          </a:prstGeom>
+          <a:noFill/>
+          <a:ln/>
+        </p:spPr>
+        <p:txBody>
+          <a:bodyPr wrap="square" lIns="0" tIns="0" rIns="0" bIns="0" rtlCol="0" anchor="ctr"/>
+          <a:lstStyle/>
+          <a:p>
+            <a:pPr indent="0" marL="0">
+              <a:buNone/>
+            </a:pPr>
+            <a:r>
+              <a:rPr lang="en-US" sz="800" b="1" spc="100" kern="0" dirty="0">
+                <a:solidFill>
+                  <a:srgbClr val="2E6FB5"/>
+                </a:solidFill>
+                <a:latin typeface="Calibri" pitchFamily="34" charset="0"/>
+                <a:ea typeface="Calibri" pitchFamily="34" charset="-122"/>
+                <a:cs typeface="Calibri" pitchFamily="34" charset="-120"/>
+              </a:rPr>
+              <a:t>DECISION COCKPIT</a:t>
+            </a:r>
+            <a:endParaRPr lang="en-US" sz="800" dirty="0"/>
+          </a:p>
+        </p:txBody>
+      </p:sp>
+      <p:sp>
+        <p:nvSpPr>
+          <p:cNvPr id="12" name="Shape 10"/>
+          <p:cNvSpPr/>
+          <p:nvPr/>
+        </p:nvSpPr>
+        <p:spPr>
+          <a:xfrm>
+            <a:off x="640080" y="3127248"/>
+            <a:ext cx="73152" cy="73152"/>
+          </a:xfrm>
+          <a:prstGeom prst="rect">
+            <a:avLst/>
+          </a:prstGeom>
+          <a:solidFill>
+            <a:srgbClr val="2E6FB5"/>
+          </a:solidFill>
+          <a:ln/>
+        </p:spPr>
+      </p:sp>
+      <p:sp>
+        <p:nvSpPr>
+          <p:cNvPr id="13" name="Text 11"/>
+          <p:cNvSpPr/>
+          <p:nvPr/>
+        </p:nvSpPr>
+        <p:spPr>
+          <a:xfrm>
+            <a:off x="804672" y="3044952"/>
+            <a:ext cx="1532534" cy="566928"/>
+          </a:xfrm>
+          <a:prstGeom prst="rect">
+            <a:avLst/>
+          </a:prstGeom>
+          <a:noFill/>
+          <a:ln/>
+        </p:spPr>
+        <p:txBody>
+          <a:bodyPr wrap="square" lIns="0" tIns="0" rIns="0" bIns="0" rtlCol="0" anchor="t"/>
           <a:lstStyle/>
           <a:p>
             <a:pPr indent="0" marL="0">
@@ -3595,29 +3862,29 @@
               <a:buNone/>
             </a:pPr>
             <a:r>
-              <a:rPr lang="en-US" sz="1250" b="1" dirty="0">
-                <a:solidFill>
-                  <a:srgbClr val="12315B"/>
-                </a:solidFill>
-                <a:latin typeface="Calibri" pitchFamily="34" charset="0"/>
-                <a:ea typeface="Calibri" pitchFamily="34" charset="-122"/>
-                <a:cs typeface="Calibri" pitchFamily="34" charset="-120"/>
-              </a:rPr>
-              <a:t>Submission intake</a:t>
-            </a:r>
-            <a:endParaRPr lang="en-US" sz="1250" dirty="0"/>
-          </a:p>
-        </p:txBody>
-      </p:sp>
-      <p:sp>
-        <p:nvSpPr>
-          <p:cNvPr id="11" name="Shape 9"/>
-          <p:cNvSpPr/>
-          <p:nvPr/>
-        </p:nvSpPr>
-        <p:spPr>
-          <a:xfrm>
-            <a:off x="640080" y="3172968"/>
+              <a:rPr lang="en-US" sz="950" dirty="0">
+                <a:solidFill>
+                  <a:srgbClr val="5A6472"/>
+                </a:solidFill>
+                <a:latin typeface="Calibri" pitchFamily="34" charset="0"/>
+                <a:ea typeface="Calibri" pitchFamily="34" charset="-122"/>
+                <a:cs typeface="Calibri" pitchFamily="34" charset="-120"/>
+              </a:rPr>
+              <a:t>Small-commercial growth signal fires in the commercial cockpit</a:t>
+            </a:r>
+            <a:endParaRPr lang="en-US" sz="950" dirty="0"/>
+          </a:p>
+        </p:txBody>
+      </p:sp>
+      <p:sp>
+        <p:nvSpPr>
+          <p:cNvPr id="14" name="Shape 12"/>
+          <p:cNvSpPr/>
+          <p:nvPr/>
+        </p:nvSpPr>
+        <p:spPr>
+          <a:xfrm>
+            <a:off x="640080" y="3730752"/>
             <a:ext cx="73152" cy="73152"/>
           </a:xfrm>
           <a:prstGeom prst="rect">
@@ -3631,14 +3898,14 @@
       </p:sp>
       <p:sp>
         <p:nvSpPr>
-          <p:cNvPr id="12" name="Text 10"/>
-          <p:cNvSpPr/>
-          <p:nvPr/>
-        </p:nvSpPr>
-        <p:spPr>
-          <a:xfrm>
-            <a:off x="804672" y="3090672"/>
-            <a:ext cx="1532534" cy="548640"/>
+          <p:cNvPr id="15" name="Text 13"/>
+          <p:cNvSpPr/>
+          <p:nvPr/>
+        </p:nvSpPr>
+        <p:spPr>
+          <a:xfrm>
+            <a:off x="804672" y="3648456"/>
+            <a:ext cx="1532534" cy="566928"/>
           </a:xfrm>
           <a:prstGeom prst="rect">
             <a:avLst/>
@@ -3657,7 +3924,7 @@
               <a:buNone/>
             </a:pPr>
             <a:r>
-              <a:rPr lang="en-US" sz="1000" dirty="0">
+              <a:rPr lang="en-US" sz="950" dirty="0">
                 <a:solidFill>
                   <a:srgbClr val="5A6472"/>
                 </a:solidFill>
@@ -3665,77 +3932,15 @@
                 <a:ea typeface="Calibri" pitchFamily="34" charset="-122"/>
                 <a:cs typeface="Calibri" pitchFamily="34" charset="-120"/>
               </a:rPr>
-              <a:t>Lands in the UW workbench</a:t>
-            </a:r>
-            <a:endParaRPr lang="en-US" sz="1000" dirty="0"/>
-          </a:p>
-        </p:txBody>
-      </p:sp>
-      <p:sp>
-        <p:nvSpPr>
-          <p:cNvPr id="13" name="Shape 11"/>
-          <p:cNvSpPr/>
-          <p:nvPr/>
-        </p:nvSpPr>
-        <p:spPr>
-          <a:xfrm>
-            <a:off x="640080" y="3758184"/>
-            <a:ext cx="73152" cy="73152"/>
-          </a:xfrm>
-          <a:prstGeom prst="rect">
-            <a:avLst/>
-          </a:prstGeom>
-          <a:solidFill>
-            <a:srgbClr val="2E6FB5"/>
-          </a:solidFill>
-          <a:ln/>
-        </p:spPr>
-      </p:sp>
-      <p:sp>
-        <p:nvSpPr>
-          <p:cNvPr id="14" name="Text 12"/>
-          <p:cNvSpPr/>
-          <p:nvPr/>
-        </p:nvSpPr>
-        <p:spPr>
-          <a:xfrm>
-            <a:off x="804672" y="3675888"/>
-            <a:ext cx="1532534" cy="548640"/>
-          </a:xfrm>
-          <a:prstGeom prst="rect">
-            <a:avLst/>
-          </a:prstGeom>
-          <a:noFill/>
-          <a:ln/>
-        </p:spPr>
-        <p:txBody>
-          <a:bodyPr wrap="square" lIns="0" tIns="0" rIns="0" bIns="0" rtlCol="0" anchor="t"/>
-          <a:lstStyle/>
-          <a:p>
-            <a:pPr indent="0" marL="0">
-              <a:lnSpc>
-                <a:spcPct val="95000"/>
-              </a:lnSpc>
-              <a:buNone/>
-            </a:pPr>
-            <a:r>
-              <a:rPr lang="en-US" sz="1000" dirty="0">
-                <a:solidFill>
-                  <a:srgbClr val="5A6472"/>
-                </a:solidFill>
-                <a:latin typeface="Calibri" pitchFamily="34" charset="0"/>
-                <a:ea typeface="Calibri" pitchFamily="34" charset="-122"/>
-                <a:cs typeface="Calibri" pitchFamily="34" charset="-120"/>
-              </a:rPr>
-              <a:t>AI extracts ACORD, loss runs &amp; financials</a:t>
-            </a:r>
-            <a:endParaRPr lang="en-US" sz="1000" dirty="0"/>
-          </a:p>
-        </p:txBody>
-      </p:sp>
-      <p:sp>
-        <p:nvSpPr>
-          <p:cNvPr id="15" name="Shape 13"/>
+              <a:t>38,400 growing accounts · $2.1B premium off-us</a:t>
+            </a:r>
+            <a:endParaRPr lang="en-US" sz="950" dirty="0"/>
+          </a:p>
+        </p:txBody>
+      </p:sp>
+      <p:sp>
+        <p:nvSpPr>
+          <p:cNvPr id="16" name="Shape 14"/>
           <p:cNvSpPr/>
           <p:nvPr/>
         </p:nvSpPr>
@@ -3760,7 +3965,7 @@
       </p:sp>
       <p:sp>
         <p:nvSpPr>
-          <p:cNvPr id="16" name="Shape 14"/>
+          <p:cNvPr id="17" name="Shape 15"/>
           <p:cNvSpPr/>
           <p:nvPr/>
         </p:nvSpPr>
@@ -3787,7 +3992,7 @@
       </p:sp>
       <p:sp>
         <p:nvSpPr>
-          <p:cNvPr id="17" name="Shape 15"/>
+          <p:cNvPr id="18" name="Shape 16"/>
           <p:cNvSpPr/>
           <p:nvPr/>
         </p:nvSpPr>
@@ -3809,7 +4014,7 @@
       </p:sp>
       <p:sp>
         <p:nvSpPr>
-          <p:cNvPr id="18" name="Text 16"/>
+          <p:cNvPr id="19" name="Text 17"/>
           <p:cNvSpPr/>
           <p:nvPr/>
         </p:nvSpPr>
@@ -3848,14 +4053,14 @@
       </p:sp>
       <p:sp>
         <p:nvSpPr>
-          <p:cNvPr id="19" name="Text 17"/>
+          <p:cNvPr id="20" name="Text 18"/>
           <p:cNvSpPr/>
           <p:nvPr/>
         </p:nvSpPr>
         <p:spPr>
           <a:xfrm>
             <a:off x="3361334" y="2377440"/>
-            <a:ext cx="1313078" cy="640080"/>
+            <a:ext cx="1313078" cy="256032"/>
           </a:xfrm>
           <a:prstGeom prst="rect">
             <a:avLst/>
@@ -3865,6 +4070,104 @@
         </p:spPr>
         <p:txBody>
           <a:bodyPr wrap="square" lIns="0" tIns="0" rIns="0" bIns="0" rtlCol="0" anchor="ctr"/>
+          <a:lstStyle/>
+          <a:p>
+            <a:pPr indent="0" marL="0">
+              <a:buNone/>
+            </a:pPr>
+            <a:r>
+              <a:rPr lang="en-US" sz="1300" b="1" dirty="0">
+                <a:solidFill>
+                  <a:srgbClr val="12315B"/>
+                </a:solidFill>
+                <a:latin typeface="Calibri" pitchFamily="34" charset="0"/>
+                <a:ea typeface="Calibri" pitchFamily="34" charset="-122"/>
+                <a:cs typeface="Calibri" pitchFamily="34" charset="-120"/>
+              </a:rPr>
+              <a:t>Hypothesize</a:t>
+            </a:r>
+            <a:endParaRPr lang="en-US" sz="1300" dirty="0"/>
+          </a:p>
+        </p:txBody>
+      </p:sp>
+      <p:sp>
+        <p:nvSpPr>
+          <p:cNvPr id="21" name="Text 19"/>
+          <p:cNvSpPr/>
+          <p:nvPr/>
+        </p:nvSpPr>
+        <p:spPr>
+          <a:xfrm>
+            <a:off x="3361334" y="2633472"/>
+            <a:ext cx="1331366" cy="201168"/>
+          </a:xfrm>
+          <a:prstGeom prst="rect">
+            <a:avLst/>
+          </a:prstGeom>
+          <a:noFill/>
+          <a:ln/>
+        </p:spPr>
+        <p:txBody>
+          <a:bodyPr wrap="square" lIns="0" tIns="0" rIns="0" bIns="0" rtlCol="0" anchor="ctr"/>
+          <a:lstStyle/>
+          <a:p>
+            <a:pPr indent="0" marL="0">
+              <a:buNone/>
+            </a:pPr>
+            <a:r>
+              <a:rPr lang="en-US" sz="800" b="1" spc="100" kern="0" dirty="0">
+                <a:solidFill>
+                  <a:srgbClr val="2E6FB5"/>
+                </a:solidFill>
+                <a:latin typeface="Calibri" pitchFamily="34" charset="0"/>
+                <a:ea typeface="Calibri" pitchFamily="34" charset="-122"/>
+                <a:cs typeface="Calibri" pitchFamily="34" charset="-120"/>
+              </a:rPr>
+              <a:t>ANALYSE</a:t>
+            </a:r>
+            <a:endParaRPr lang="en-US" sz="800" dirty="0"/>
+          </a:p>
+        </p:txBody>
+      </p:sp>
+      <p:sp>
+        <p:nvSpPr>
+          <p:cNvPr id="22" name="Shape 20"/>
+          <p:cNvSpPr/>
+          <p:nvPr/>
+        </p:nvSpPr>
+        <p:spPr>
+          <a:xfrm>
+            <a:off x="2940710" y="3127248"/>
+            <a:ext cx="73152" cy="73152"/>
+          </a:xfrm>
+          <a:prstGeom prst="rect">
+            <a:avLst/>
+          </a:prstGeom>
+          <a:solidFill>
+            <a:srgbClr val="2E6FB5"/>
+          </a:solidFill>
+          <a:ln/>
+        </p:spPr>
+      </p:sp>
+      <p:sp>
+        <p:nvSpPr>
+          <p:cNvPr id="23" name="Text 21"/>
+          <p:cNvSpPr/>
+          <p:nvPr/>
+        </p:nvSpPr>
+        <p:spPr>
+          <a:xfrm>
+            <a:off x="3105302" y="3044952"/>
+            <a:ext cx="1532534" cy="566928"/>
+          </a:xfrm>
+          <a:prstGeom prst="rect">
+            <a:avLst/>
+          </a:prstGeom>
+          <a:noFill/>
+          <a:ln/>
+        </p:spPr>
+        <p:txBody>
+          <a:bodyPr wrap="square" lIns="0" tIns="0" rIns="0" bIns="0" rtlCol="0" anchor="t"/>
           <a:lstStyle/>
           <a:p>
             <a:pPr indent="0" marL="0">
@@ -3874,29 +4177,29 @@
               <a:buNone/>
             </a:pPr>
             <a:r>
-              <a:rPr lang="en-US" sz="1250" b="1" dirty="0">
-                <a:solidFill>
-                  <a:srgbClr val="12315B"/>
-                </a:solidFill>
-                <a:latin typeface="Calibri" pitchFamily="34" charset="0"/>
-                <a:ea typeface="Calibri" pitchFamily="34" charset="-122"/>
-                <a:cs typeface="Calibri" pitchFamily="34" charset="-120"/>
-              </a:rPr>
-              <a:t>Risk enrichment</a:t>
-            </a:r>
-            <a:endParaRPr lang="en-US" sz="1250" dirty="0"/>
-          </a:p>
-        </p:txBody>
-      </p:sp>
-      <p:sp>
-        <p:nvSpPr>
-          <p:cNvPr id="20" name="Shape 18"/>
-          <p:cNvSpPr/>
-          <p:nvPr/>
-        </p:nvSpPr>
-        <p:spPr>
-          <a:xfrm>
-            <a:off x="2940710" y="3172968"/>
+              <a:rPr lang="en-US" sz="950" dirty="0">
+                <a:solidFill>
+                  <a:srgbClr val="5A6472"/>
+                </a:solidFill>
+                <a:latin typeface="Calibri" pitchFamily="34" charset="0"/>
+                <a:ea typeface="Calibri" pitchFamily="34" charset="-122"/>
+                <a:cs typeface="Calibri" pitchFamily="34" charset="-120"/>
+              </a:rPr>
+              <a:t>“Win back the growing account” — precision underwriting</a:t>
+            </a:r>
+            <a:endParaRPr lang="en-US" sz="950" dirty="0"/>
+          </a:p>
+        </p:txBody>
+      </p:sp>
+      <p:sp>
+        <p:nvSpPr>
+          <p:cNvPr id="24" name="Shape 22"/>
+          <p:cNvSpPr/>
+          <p:nvPr/>
+        </p:nvSpPr>
+        <p:spPr>
+          <a:xfrm>
+            <a:off x="2940710" y="3730752"/>
             <a:ext cx="73152" cy="73152"/>
           </a:xfrm>
           <a:prstGeom prst="rect">
@@ -3910,14 +4213,14 @@
       </p:sp>
       <p:sp>
         <p:nvSpPr>
-          <p:cNvPr id="21" name="Text 19"/>
-          <p:cNvSpPr/>
-          <p:nvPr/>
-        </p:nvSpPr>
-        <p:spPr>
-          <a:xfrm>
-            <a:off x="3105302" y="3090672"/>
-            <a:ext cx="1532534" cy="548640"/>
+          <p:cNvPr id="25" name="Text 23"/>
+          <p:cNvSpPr/>
+          <p:nvPr/>
+        </p:nvSpPr>
+        <p:spPr>
+          <a:xfrm>
+            <a:off x="3105302" y="3648456"/>
+            <a:ext cx="1532534" cy="566928"/>
           </a:xfrm>
           <a:prstGeom prst="rect">
             <a:avLst/>
@@ -3936,7 +4239,7 @@
               <a:buNone/>
             </a:pPr>
             <a:r>
-              <a:rPr lang="en-US" sz="1000" dirty="0">
+              <a:rPr lang="en-US" sz="950" dirty="0">
                 <a:solidFill>
                   <a:srgbClr val="5A6472"/>
                 </a:solidFill>
@@ -3944,77 +4247,15 @@
                 <a:ea typeface="Calibri" pitchFamily="34" charset="-122"/>
                 <a:cs typeface="Calibri" pitchFamily="34" charset="-120"/>
               </a:rPr>
-              <a:t>Appends property, firmographic &amp; cat data</a:t>
-            </a:r>
-            <a:endParaRPr lang="en-US" sz="1000" dirty="0"/>
-          </a:p>
-        </p:txBody>
-      </p:sp>
-      <p:sp>
-        <p:nvSpPr>
-          <p:cNvPr id="22" name="Shape 20"/>
-          <p:cNvSpPr/>
-          <p:nvPr/>
-        </p:nvSpPr>
-        <p:spPr>
-          <a:xfrm>
-            <a:off x="2940710" y="3758184"/>
-            <a:ext cx="73152" cy="73152"/>
-          </a:xfrm>
-          <a:prstGeom prst="rect">
-            <a:avLst/>
-          </a:prstGeom>
-          <a:solidFill>
-            <a:srgbClr val="2E6FB5"/>
-          </a:solidFill>
-          <a:ln/>
-        </p:spPr>
-      </p:sp>
-      <p:sp>
-        <p:nvSpPr>
-          <p:cNvPr id="23" name="Text 21"/>
-          <p:cNvSpPr/>
-          <p:nvPr/>
-        </p:nvSpPr>
-        <p:spPr>
-          <a:xfrm>
-            <a:off x="3105302" y="3675888"/>
-            <a:ext cx="1532534" cy="548640"/>
-          </a:xfrm>
-          <a:prstGeom prst="rect">
-            <a:avLst/>
-          </a:prstGeom>
-          <a:noFill/>
-          <a:ln/>
-        </p:spPr>
-        <p:txBody>
-          <a:bodyPr wrap="square" lIns="0" tIns="0" rIns="0" bIns="0" rtlCol="0" anchor="t"/>
-          <a:lstStyle/>
-          <a:p>
-            <a:pPr indent="0" marL="0">
-              <a:lnSpc>
-                <a:spcPct val="95000"/>
-              </a:lnSpc>
-              <a:buNone/>
-            </a:pPr>
-            <a:r>
-              <a:rPr lang="en-US" sz="1000" dirty="0">
-                <a:solidFill>
-                  <a:srgbClr val="5A6472"/>
-                </a:solidFill>
-                <a:latin typeface="Calibri" pitchFamily="34" charset="0"/>
-                <a:ea typeface="Calibri" pitchFamily="34" charset="-122"/>
-                <a:cs typeface="Calibri" pitchFamily="34" charset="-120"/>
-              </a:rPr>
-              <a:t>Rebuilds exposure &amp; prior-loss view</a:t>
-            </a:r>
-            <a:endParaRPr lang="en-US" sz="1000" dirty="0"/>
-          </a:p>
-        </p:txBody>
-      </p:sp>
-      <p:sp>
-        <p:nvSpPr>
-          <p:cNvPr id="24" name="Shape 22"/>
+              <a:t>Drivers: off-us placement, payroll, new site, fleet, revenue surge</a:t>
+            </a:r>
+            <a:endParaRPr lang="en-US" sz="950" dirty="0"/>
+          </a:p>
+        </p:txBody>
+      </p:sp>
+      <p:sp>
+        <p:nvSpPr>
+          <p:cNvPr id="26" name="Shape 24"/>
           <p:cNvSpPr/>
           <p:nvPr/>
         </p:nvSpPr>
@@ -4039,7 +4280,7 @@
       </p:sp>
       <p:sp>
         <p:nvSpPr>
-          <p:cNvPr id="25" name="Shape 23"/>
+          <p:cNvPr id="27" name="Shape 25"/>
           <p:cNvSpPr/>
           <p:nvPr/>
         </p:nvSpPr>
@@ -4066,7 +4307,7 @@
       </p:sp>
       <p:sp>
         <p:nvSpPr>
-          <p:cNvPr id="26" name="Shape 24"/>
+          <p:cNvPr id="28" name="Shape 26"/>
           <p:cNvSpPr/>
           <p:nvPr/>
         </p:nvSpPr>
@@ -4088,7 +4329,7 @@
       </p:sp>
       <p:sp>
         <p:nvSpPr>
-          <p:cNvPr id="27" name="Text 25"/>
+          <p:cNvPr id="29" name="Text 27"/>
           <p:cNvSpPr/>
           <p:nvPr/>
         </p:nvSpPr>
@@ -4127,14 +4368,14 @@
       </p:sp>
       <p:sp>
         <p:nvSpPr>
-          <p:cNvPr id="28" name="Text 26"/>
+          <p:cNvPr id="30" name="Text 28"/>
           <p:cNvSpPr/>
           <p:nvPr/>
         </p:nvSpPr>
         <p:spPr>
           <a:xfrm>
             <a:off x="5661965" y="2377440"/>
-            <a:ext cx="1313078" cy="640080"/>
+            <a:ext cx="1313078" cy="256032"/>
           </a:xfrm>
           <a:prstGeom prst="rect">
             <a:avLst/>
@@ -4144,6 +4385,104 @@
         </p:spPr>
         <p:txBody>
           <a:bodyPr wrap="square" lIns="0" tIns="0" rIns="0" bIns="0" rtlCol="0" anchor="ctr"/>
+          <a:lstStyle/>
+          <a:p>
+            <a:pPr indent="0" marL="0">
+              <a:buNone/>
+            </a:pPr>
+            <a:r>
+              <a:rPr lang="en-US" sz="1300" b="1" dirty="0">
+                <a:solidFill>
+                  <a:srgbClr val="12315B"/>
+                </a:solidFill>
+                <a:latin typeface="Calibri" pitchFamily="34" charset="0"/>
+                <a:ea typeface="Calibri" pitchFamily="34" charset="-122"/>
+                <a:cs typeface="Calibri" pitchFamily="34" charset="-120"/>
+              </a:rPr>
+              <a:t>Test</a:t>
+            </a:r>
+            <a:endParaRPr lang="en-US" sz="1300" dirty="0"/>
+          </a:p>
+        </p:txBody>
+      </p:sp>
+      <p:sp>
+        <p:nvSpPr>
+          <p:cNvPr id="31" name="Text 29"/>
+          <p:cNvSpPr/>
+          <p:nvPr/>
+        </p:nvSpPr>
+        <p:spPr>
+          <a:xfrm>
+            <a:off x="5661965" y="2633472"/>
+            <a:ext cx="1331366" cy="201168"/>
+          </a:xfrm>
+          <a:prstGeom prst="rect">
+            <a:avLst/>
+          </a:prstGeom>
+          <a:noFill/>
+          <a:ln/>
+        </p:spPr>
+        <p:txBody>
+          <a:bodyPr wrap="square" lIns="0" tIns="0" rIns="0" bIns="0" rtlCol="0" anchor="ctr"/>
+          <a:lstStyle/>
+          <a:p>
+            <a:pPr indent="0" marL="0">
+              <a:buNone/>
+            </a:pPr>
+            <a:r>
+              <a:rPr lang="en-US" sz="800" b="1" spc="100" kern="0" dirty="0">
+                <a:solidFill>
+                  <a:srgbClr val="2E6FB5"/>
+                </a:solidFill>
+                <a:latin typeface="Calibri" pitchFamily="34" charset="0"/>
+                <a:ea typeface="Calibri" pitchFamily="34" charset="-122"/>
+                <a:cs typeface="Calibri" pitchFamily="34" charset="-120"/>
+              </a:rPr>
+              <a:t>SIMULATION STUDIO</a:t>
+            </a:r>
+            <a:endParaRPr lang="en-US" sz="800" dirty="0"/>
+          </a:p>
+        </p:txBody>
+      </p:sp>
+      <p:sp>
+        <p:nvSpPr>
+          <p:cNvPr id="32" name="Shape 30"/>
+          <p:cNvSpPr/>
+          <p:nvPr/>
+        </p:nvSpPr>
+        <p:spPr>
+          <a:xfrm>
+            <a:off x="5241341" y="3127248"/>
+            <a:ext cx="73152" cy="73152"/>
+          </a:xfrm>
+          <a:prstGeom prst="rect">
+            <a:avLst/>
+          </a:prstGeom>
+          <a:solidFill>
+            <a:srgbClr val="2E6FB5"/>
+          </a:solidFill>
+          <a:ln/>
+        </p:spPr>
+      </p:sp>
+      <p:sp>
+        <p:nvSpPr>
+          <p:cNvPr id="33" name="Text 31"/>
+          <p:cNvSpPr/>
+          <p:nvPr/>
+        </p:nvSpPr>
+        <p:spPr>
+          <a:xfrm>
+            <a:off x="5405933" y="3044952"/>
+            <a:ext cx="1532534" cy="566928"/>
+          </a:xfrm>
+          <a:prstGeom prst="rect">
+            <a:avLst/>
+          </a:prstGeom>
+          <a:noFill/>
+          <a:ln/>
+        </p:spPr>
+        <p:txBody>
+          <a:bodyPr wrap="square" lIns="0" tIns="0" rIns="0" bIns="0" rtlCol="0" anchor="t"/>
           <a:lstStyle/>
           <a:p>
             <a:pPr indent="0" marL="0">
@@ -4153,29 +4492,29 @@
               <a:buNone/>
             </a:pPr>
             <a:r>
-              <a:rPr lang="en-US" sz="1250" b="1" dirty="0">
-                <a:solidFill>
-                  <a:srgbClr val="12315B"/>
-                </a:solidFill>
-                <a:latin typeface="Calibri" pitchFamily="34" charset="0"/>
-                <a:ea typeface="Calibri" pitchFamily="34" charset="-122"/>
-                <a:cs typeface="Calibri" pitchFamily="34" charset="-120"/>
-              </a:rPr>
-              <a:t>Triage &amp; appetite check</a:t>
-            </a:r>
-            <a:endParaRPr lang="en-US" sz="1250" dirty="0"/>
-          </a:p>
-        </p:txBody>
-      </p:sp>
-      <p:sp>
-        <p:nvSpPr>
-          <p:cNvPr id="29" name="Shape 27"/>
-          <p:cNvSpPr/>
-          <p:nvPr/>
-        </p:nvSpPr>
-        <p:spPr>
-          <a:xfrm>
-            <a:off x="5241341" y="3172968"/>
+              <a:rPr lang="en-US" sz="950" dirty="0">
+                <a:solidFill>
+                  <a:srgbClr val="5A6472"/>
+                </a:solidFill>
+                <a:latin typeface="Calibri" pitchFamily="34" charset="0"/>
+                <a:ea typeface="Calibri" pitchFamily="34" charset="-122"/>
+                <a:cs typeface="Calibri" pitchFamily="34" charset="-120"/>
+              </a:rPr>
+              <a:t>Levers: lead line, rate-discount ceiling, bundle, channel</a:t>
+            </a:r>
+            <a:endParaRPr lang="en-US" sz="950" dirty="0"/>
+          </a:p>
+        </p:txBody>
+      </p:sp>
+      <p:sp>
+        <p:nvSpPr>
+          <p:cNvPr id="34" name="Shape 32"/>
+          <p:cNvSpPr/>
+          <p:nvPr/>
+        </p:nvSpPr>
+        <p:spPr>
+          <a:xfrm>
+            <a:off x="5241341" y="3730752"/>
             <a:ext cx="73152" cy="73152"/>
           </a:xfrm>
           <a:prstGeom prst="rect">
@@ -4189,14 +4528,14 @@
       </p:sp>
       <p:sp>
         <p:nvSpPr>
-          <p:cNvPr id="30" name="Text 28"/>
-          <p:cNvSpPr/>
-          <p:nvPr/>
-        </p:nvSpPr>
-        <p:spPr>
-          <a:xfrm>
-            <a:off x="5405933" y="3090672"/>
-            <a:ext cx="1532534" cy="548640"/>
+          <p:cNvPr id="35" name="Text 33"/>
+          <p:cNvSpPr/>
+          <p:nvPr/>
+        </p:nvSpPr>
+        <p:spPr>
+          <a:xfrm>
+            <a:off x="5405933" y="3648456"/>
+            <a:ext cx="1532534" cy="566928"/>
           </a:xfrm>
           <a:prstGeom prst="rect">
             <a:avLst/>
@@ -4215,7 +4554,7 @@
               <a:buNone/>
             </a:pPr>
             <a:r>
-              <a:rPr lang="en-US" sz="1000" dirty="0">
+              <a:rPr lang="en-US" sz="950" dirty="0">
                 <a:solidFill>
                   <a:srgbClr val="5A6472"/>
                 </a:solidFill>
@@ -4223,77 +4562,15 @@
                 <a:ea typeface="Calibri" pitchFamily="34" charset="-122"/>
                 <a:cs typeface="Calibri" pitchFamily="34" charset="-120"/>
               </a:rPr>
-              <a:t>Automated appetite-fit scoring</a:t>
-            </a:r>
-            <a:endParaRPr lang="en-US" sz="1000" dirty="0"/>
-          </a:p>
-        </p:txBody>
-      </p:sp>
-      <p:sp>
-        <p:nvSpPr>
-          <p:cNvPr id="31" name="Shape 29"/>
-          <p:cNvSpPr/>
-          <p:nvPr/>
-        </p:nvSpPr>
-        <p:spPr>
-          <a:xfrm>
-            <a:off x="5241341" y="3758184"/>
-            <a:ext cx="73152" cy="73152"/>
-          </a:xfrm>
-          <a:prstGeom prst="rect">
-            <a:avLst/>
-          </a:prstGeom>
-          <a:solidFill>
-            <a:srgbClr val="2E6FB5"/>
-          </a:solidFill>
-          <a:ln/>
-        </p:spPr>
-      </p:sp>
-      <p:sp>
-        <p:nvSpPr>
-          <p:cNvPr id="32" name="Text 30"/>
-          <p:cNvSpPr/>
-          <p:nvPr/>
-        </p:nvSpPr>
-        <p:spPr>
-          <a:xfrm>
-            <a:off x="5405933" y="3675888"/>
-            <a:ext cx="1532534" cy="548640"/>
-          </a:xfrm>
-          <a:prstGeom prst="rect">
-            <a:avLst/>
-          </a:prstGeom>
-          <a:noFill/>
-          <a:ln/>
-        </p:spPr>
-        <p:txBody>
-          <a:bodyPr wrap="square" lIns="0" tIns="0" rIns="0" bIns="0" rtlCol="0" anchor="t"/>
-          <a:lstStyle/>
-          <a:p>
-            <a:pPr indent="0" marL="0">
-              <a:lnSpc>
-                <a:spcPct val="95000"/>
-              </a:lnSpc>
-              <a:buNone/>
-            </a:pPr>
-            <a:r>
-              <a:rPr lang="en-US" sz="1000" dirty="0">
-                <a:solidFill>
-                  <a:srgbClr val="5A6472"/>
-                </a:solidFill>
-                <a:latin typeface="Calibri" pitchFamily="34" charset="0"/>
-                <a:ea typeface="Calibri" pitchFamily="34" charset="-122"/>
-                <a:cs typeface="Calibri" pitchFamily="34" charset="-120"/>
-              </a:rPr>
-              <a:t>Auto-declines misfits, speeds clean risks</a:t>
-            </a:r>
-            <a:endParaRPr lang="en-US" sz="1000" dirty="0"/>
-          </a:p>
-        </p:txBody>
-      </p:sp>
-      <p:sp>
-        <p:nvSpPr>
-          <p:cNvPr id="33" name="Shape 31"/>
+              <a:t>Hard rate-adequacy floor + loss-ratio limit</a:t>
+            </a:r>
+            <a:endParaRPr lang="en-US" sz="950" dirty="0"/>
+          </a:p>
+        </p:txBody>
+      </p:sp>
+      <p:sp>
+        <p:nvSpPr>
+          <p:cNvPr id="36" name="Shape 34"/>
           <p:cNvSpPr/>
           <p:nvPr/>
         </p:nvSpPr>
@@ -4318,7 +4595,7 @@
       </p:sp>
       <p:sp>
         <p:nvSpPr>
-          <p:cNvPr id="34" name="Shape 32"/>
+          <p:cNvPr id="37" name="Shape 35"/>
           <p:cNvSpPr/>
           <p:nvPr/>
         </p:nvSpPr>
@@ -4345,7 +4622,7 @@
       </p:sp>
       <p:sp>
         <p:nvSpPr>
-          <p:cNvPr id="35" name="Shape 33"/>
+          <p:cNvPr id="38" name="Shape 36"/>
           <p:cNvSpPr/>
           <p:nvPr/>
         </p:nvSpPr>
@@ -4367,7 +4644,7 @@
       </p:sp>
       <p:sp>
         <p:nvSpPr>
-          <p:cNvPr id="36" name="Text 34"/>
+          <p:cNvPr id="39" name="Text 37"/>
           <p:cNvSpPr/>
           <p:nvPr/>
         </p:nvSpPr>
@@ -4406,14 +4683,14 @@
       </p:sp>
       <p:sp>
         <p:nvSpPr>
-          <p:cNvPr id="37" name="Text 35"/>
+          <p:cNvPr id="40" name="Text 38"/>
           <p:cNvSpPr/>
           <p:nvPr/>
         </p:nvSpPr>
         <p:spPr>
           <a:xfrm>
             <a:off x="7962595" y="2377440"/>
-            <a:ext cx="1313078" cy="640080"/>
+            <a:ext cx="1313078" cy="256032"/>
           </a:xfrm>
           <a:prstGeom prst="rect">
             <a:avLst/>
@@ -4423,6 +4700,104 @@
         </p:spPr>
         <p:txBody>
           <a:bodyPr wrap="square" lIns="0" tIns="0" rIns="0" bIns="0" rtlCol="0" anchor="ctr"/>
+          <a:lstStyle/>
+          <a:p>
+            <a:pPr indent="0" marL="0">
+              <a:buNone/>
+            </a:pPr>
+            <a:r>
+              <a:rPr lang="en-US" sz="1300" b="1" dirty="0">
+                <a:solidFill>
+                  <a:srgbClr val="12315B"/>
+                </a:solidFill>
+                <a:latin typeface="Calibri" pitchFamily="34" charset="0"/>
+                <a:ea typeface="Calibri" pitchFamily="34" charset="-122"/>
+                <a:cs typeface="Calibri" pitchFamily="34" charset="-120"/>
+              </a:rPr>
+              <a:t>Deploy</a:t>
+            </a:r>
+            <a:endParaRPr lang="en-US" sz="1300" dirty="0"/>
+          </a:p>
+        </p:txBody>
+      </p:sp>
+      <p:sp>
+        <p:nvSpPr>
+          <p:cNvPr id="41" name="Text 39"/>
+          <p:cNvSpPr/>
+          <p:nvPr/>
+        </p:nvSpPr>
+        <p:spPr>
+          <a:xfrm>
+            <a:off x="7962595" y="2633472"/>
+            <a:ext cx="1331366" cy="201168"/>
+          </a:xfrm>
+          <a:prstGeom prst="rect">
+            <a:avLst/>
+          </a:prstGeom>
+          <a:noFill/>
+          <a:ln/>
+        </p:spPr>
+        <p:txBody>
+          <a:bodyPr wrap="square" lIns="0" tIns="0" rIns="0" bIns="0" rtlCol="0" anchor="ctr"/>
+          <a:lstStyle/>
+          <a:p>
+            <a:pPr indent="0" marL="0">
+              <a:buNone/>
+            </a:pPr>
+            <a:r>
+              <a:rPr lang="en-US" sz="800" b="1" spc="100" kern="0" dirty="0">
+                <a:solidFill>
+                  <a:srgbClr val="2E6FB5"/>
+                </a:solidFill>
+                <a:latin typeface="Calibri" pitchFamily="34" charset="0"/>
+                <a:ea typeface="Calibri" pitchFamily="34" charset="-122"/>
+                <a:cs typeface="Calibri" pitchFamily="34" charset="-120"/>
+              </a:rPr>
+              <a:t>APPROVAL → RCT</a:t>
+            </a:r>
+            <a:endParaRPr lang="en-US" sz="800" dirty="0"/>
+          </a:p>
+        </p:txBody>
+      </p:sp>
+      <p:sp>
+        <p:nvSpPr>
+          <p:cNvPr id="42" name="Shape 40"/>
+          <p:cNvSpPr/>
+          <p:nvPr/>
+        </p:nvSpPr>
+        <p:spPr>
+          <a:xfrm>
+            <a:off x="7541971" y="3127248"/>
+            <a:ext cx="73152" cy="73152"/>
+          </a:xfrm>
+          <a:prstGeom prst="rect">
+            <a:avLst/>
+          </a:prstGeom>
+          <a:solidFill>
+            <a:srgbClr val="2E6FB5"/>
+          </a:solidFill>
+          <a:ln/>
+        </p:spPr>
+      </p:sp>
+      <p:sp>
+        <p:nvSpPr>
+          <p:cNvPr id="43" name="Text 41"/>
+          <p:cNvSpPr/>
+          <p:nvPr/>
+        </p:nvSpPr>
+        <p:spPr>
+          <a:xfrm>
+            <a:off x="7706563" y="3044952"/>
+            <a:ext cx="1532534" cy="566928"/>
+          </a:xfrm>
+          <a:prstGeom prst="rect">
+            <a:avLst/>
+          </a:prstGeom>
+          <a:noFill/>
+          <a:ln/>
+        </p:spPr>
+        <p:txBody>
+          <a:bodyPr wrap="square" lIns="0" tIns="0" rIns="0" bIns="0" rtlCol="0" anchor="t"/>
           <a:lstStyle/>
           <a:p>
             <a:pPr indent="0" marL="0">
@@ -4432,29 +4807,29 @@
               <a:buNone/>
             </a:pPr>
             <a:r>
-              <a:rPr lang="en-US" sz="1250" b="1" dirty="0">
-                <a:solidFill>
-                  <a:srgbClr val="12315B"/>
-                </a:solidFill>
-                <a:latin typeface="Calibri" pitchFamily="34" charset="0"/>
-                <a:ea typeface="Calibri" pitchFamily="34" charset="-122"/>
-                <a:cs typeface="Calibri" pitchFamily="34" charset="-120"/>
-              </a:rPr>
-              <a:t>Pricing &amp; recommendation</a:t>
-            </a:r>
-            <a:endParaRPr lang="en-US" sz="1250" dirty="0"/>
-          </a:p>
-        </p:txBody>
-      </p:sp>
-      <p:sp>
-        <p:nvSpPr>
-          <p:cNvPr id="38" name="Shape 36"/>
-          <p:cNvSpPr/>
-          <p:nvPr/>
-        </p:nvSpPr>
-        <p:spPr>
-          <a:xfrm>
-            <a:off x="7541971" y="3172968"/>
+              <a:rPr lang="en-US" sz="950" dirty="0">
+                <a:solidFill>
+                  <a:srgbClr val="5A6472"/>
+                </a:solidFill>
+                <a:latin typeface="Calibri" pitchFamily="34" charset="0"/>
+                <a:ea typeface="Calibri" pitchFamily="34" charset="-122"/>
+                <a:cs typeface="Calibri" pitchFamily="34" charset="-120"/>
+              </a:rPr>
+              <a:t>Underwriting · Actuarial sign-off, then compliance gate</a:t>
+            </a:r>
+            <a:endParaRPr lang="en-US" sz="950" dirty="0"/>
+          </a:p>
+        </p:txBody>
+      </p:sp>
+      <p:sp>
+        <p:nvSpPr>
+          <p:cNvPr id="44" name="Shape 42"/>
+          <p:cNvSpPr/>
+          <p:nvPr/>
+        </p:nvSpPr>
+        <p:spPr>
+          <a:xfrm>
+            <a:off x="7541971" y="3730752"/>
             <a:ext cx="73152" cy="73152"/>
           </a:xfrm>
           <a:prstGeom prst="rect">
@@ -4468,14 +4843,14 @@
       </p:sp>
       <p:sp>
         <p:nvSpPr>
-          <p:cNvPr id="39" name="Text 37"/>
-          <p:cNvSpPr/>
-          <p:nvPr/>
-        </p:nvSpPr>
-        <p:spPr>
-          <a:xfrm>
-            <a:off x="7706563" y="3090672"/>
-            <a:ext cx="1532534" cy="548640"/>
+          <p:cNvPr id="45" name="Text 43"/>
+          <p:cNvSpPr/>
+          <p:nvPr/>
+        </p:nvSpPr>
+        <p:spPr>
+          <a:xfrm>
+            <a:off x="7706563" y="3648456"/>
+            <a:ext cx="1532534" cy="566928"/>
           </a:xfrm>
           <a:prstGeom prst="rect">
             <a:avLst/>
@@ -4494,7 +4869,7 @@
               <a:buNone/>
             </a:pPr>
             <a:r>
-              <a:rPr lang="en-US" sz="1000" dirty="0">
+              <a:rPr lang="en-US" sz="950" dirty="0">
                 <a:solidFill>
                   <a:srgbClr val="5A6472"/>
                 </a:solidFill>
@@ -4502,77 +4877,15 @@
                 <a:ea typeface="Calibri" pitchFamily="34" charset="-122"/>
                 <a:cs typeface="Calibri" pitchFamily="34" charset="-120"/>
               </a:rPr>
-              <a:t>Model-suggested price &amp; terms</a:t>
-            </a:r>
-            <a:endParaRPr lang="en-US" sz="1000" dirty="0"/>
-          </a:p>
-        </p:txBody>
-      </p:sp>
-      <p:sp>
-        <p:nvSpPr>
-          <p:cNvPr id="40" name="Shape 38"/>
-          <p:cNvSpPr/>
-          <p:nvPr/>
-        </p:nvSpPr>
-        <p:spPr>
-          <a:xfrm>
-            <a:off x="7541971" y="3758184"/>
-            <a:ext cx="73152" cy="73152"/>
-          </a:xfrm>
-          <a:prstGeom prst="rect">
-            <a:avLst/>
-          </a:prstGeom>
-          <a:solidFill>
-            <a:srgbClr val="2E6FB5"/>
-          </a:solidFill>
-          <a:ln/>
-        </p:spPr>
-      </p:sp>
-      <p:sp>
-        <p:nvSpPr>
-          <p:cNvPr id="41" name="Text 39"/>
-          <p:cNvSpPr/>
-          <p:nvPr/>
-        </p:nvSpPr>
-        <p:spPr>
-          <a:xfrm>
-            <a:off x="7706563" y="3675888"/>
-            <a:ext cx="1532534" cy="548640"/>
-          </a:xfrm>
-          <a:prstGeom prst="rect">
-            <a:avLst/>
-          </a:prstGeom>
-          <a:noFill/>
-          <a:ln/>
-        </p:spPr>
-        <p:txBody>
-          <a:bodyPr wrap="square" lIns="0" tIns="0" rIns="0" bIns="0" rtlCol="0" anchor="t"/>
-          <a:lstStyle/>
-          <a:p>
-            <a:pPr indent="0" marL="0">
-              <a:lnSpc>
-                <a:spcPct val="95000"/>
-              </a:lnSpc>
-              <a:buNone/>
-            </a:pPr>
-            <a:r>
-              <a:rPr lang="en-US" sz="1000" dirty="0">
-                <a:solidFill>
-                  <a:srgbClr val="5A6472"/>
-                </a:solidFill>
-                <a:latin typeface="Calibri" pitchFamily="34" charset="0"/>
-                <a:ea typeface="Calibri" pitchFamily="34" charset="-122"/>
-                <a:cs typeface="Calibri" pitchFamily="34" charset="-120"/>
-              </a:rPr>
-              <a:t>With rationale and risk flags</a:t>
-            </a:r>
-            <a:endParaRPr lang="en-US" sz="1000" dirty="0"/>
-          </a:p>
-        </p:txBody>
-      </p:sp>
-      <p:sp>
-        <p:nvSpPr>
-          <p:cNvPr id="42" name="Shape 40"/>
+              <a:t>34,560 treatment · 3,840 holdout (90 / 10)</a:t>
+            </a:r>
+            <a:endParaRPr lang="en-US" sz="950" dirty="0"/>
+          </a:p>
+        </p:txBody>
+      </p:sp>
+      <p:sp>
+        <p:nvSpPr>
+          <p:cNvPr id="46" name="Shape 44"/>
           <p:cNvSpPr/>
           <p:nvPr/>
         </p:nvSpPr>
@@ -4597,7 +4910,7 @@
       </p:sp>
       <p:sp>
         <p:nvSpPr>
-          <p:cNvPr id="43" name="Shape 41"/>
+          <p:cNvPr id="47" name="Shape 45"/>
           <p:cNvSpPr/>
           <p:nvPr/>
         </p:nvSpPr>
@@ -4624,7 +4937,7 @@
       </p:sp>
       <p:sp>
         <p:nvSpPr>
-          <p:cNvPr id="44" name="Shape 42"/>
+          <p:cNvPr id="48" name="Shape 46"/>
           <p:cNvSpPr/>
           <p:nvPr/>
         </p:nvSpPr>
@@ -4646,7 +4959,7 @@
       </p:sp>
       <p:sp>
         <p:nvSpPr>
-          <p:cNvPr id="45" name="Text 43"/>
+          <p:cNvPr id="49" name="Text 47"/>
           <p:cNvSpPr/>
           <p:nvPr/>
         </p:nvSpPr>
@@ -4685,14 +4998,14 @@
       </p:sp>
       <p:sp>
         <p:nvSpPr>
-          <p:cNvPr id="46" name="Text 44"/>
+          <p:cNvPr id="50" name="Text 48"/>
           <p:cNvSpPr/>
           <p:nvPr/>
         </p:nvSpPr>
         <p:spPr>
           <a:xfrm>
             <a:off x="10263226" y="2377440"/>
-            <a:ext cx="1313078" cy="640080"/>
+            <a:ext cx="1313078" cy="256032"/>
           </a:xfrm>
           <a:prstGeom prst="rect">
             <a:avLst/>
@@ -4702,6 +5015,104 @@
         </p:spPr>
         <p:txBody>
           <a:bodyPr wrap="square" lIns="0" tIns="0" rIns="0" bIns="0" rtlCol="0" anchor="ctr"/>
+          <a:lstStyle/>
+          <a:p>
+            <a:pPr indent="0" marL="0">
+              <a:buNone/>
+            </a:pPr>
+            <a:r>
+              <a:rPr lang="en-US" sz="1300" b="1" dirty="0">
+                <a:solidFill>
+                  <a:srgbClr val="12315B"/>
+                </a:solidFill>
+                <a:latin typeface="Calibri" pitchFamily="34" charset="0"/>
+                <a:ea typeface="Calibri" pitchFamily="34" charset="-122"/>
+                <a:cs typeface="Calibri" pitchFamily="34" charset="-120"/>
+              </a:rPr>
+              <a:t>Learn</a:t>
+            </a:r>
+            <a:endParaRPr lang="en-US" sz="1300" dirty="0"/>
+          </a:p>
+        </p:txBody>
+      </p:sp>
+      <p:sp>
+        <p:nvSpPr>
+          <p:cNvPr id="51" name="Text 49"/>
+          <p:cNvSpPr/>
+          <p:nvPr/>
+        </p:nvSpPr>
+        <p:spPr>
+          <a:xfrm>
+            <a:off x="10263226" y="2633472"/>
+            <a:ext cx="1331366" cy="201168"/>
+          </a:xfrm>
+          <a:prstGeom prst="rect">
+            <a:avLst/>
+          </a:prstGeom>
+          <a:noFill/>
+          <a:ln/>
+        </p:spPr>
+        <p:txBody>
+          <a:bodyPr wrap="square" lIns="0" tIns="0" rIns="0" bIns="0" rtlCol="0" anchor="ctr"/>
+          <a:lstStyle/>
+          <a:p>
+            <a:pPr indent="0" marL="0">
+              <a:buNone/>
+            </a:pPr>
+            <a:r>
+              <a:rPr lang="en-US" sz="800" b="1" spc="100" kern="0" dirty="0">
+                <a:solidFill>
+                  <a:srgbClr val="2E6FB5"/>
+                </a:solidFill>
+                <a:latin typeface="Calibri" pitchFamily="34" charset="0"/>
+                <a:ea typeface="Calibri" pitchFamily="34" charset="-122"/>
+                <a:cs typeface="Calibri" pitchFamily="34" charset="-120"/>
+              </a:rPr>
+              <a:t>MEASURED</a:t>
+            </a:r>
+            <a:endParaRPr lang="en-US" sz="800" dirty="0"/>
+          </a:p>
+        </p:txBody>
+      </p:sp>
+      <p:sp>
+        <p:nvSpPr>
+          <p:cNvPr id="52" name="Shape 50"/>
+          <p:cNvSpPr/>
+          <p:nvPr/>
+        </p:nvSpPr>
+        <p:spPr>
+          <a:xfrm>
+            <a:off x="9842602" y="3127248"/>
+            <a:ext cx="73152" cy="73152"/>
+          </a:xfrm>
+          <a:prstGeom prst="rect">
+            <a:avLst/>
+          </a:prstGeom>
+          <a:solidFill>
+            <a:srgbClr val="2E6FB5"/>
+          </a:solidFill>
+          <a:ln/>
+        </p:spPr>
+      </p:sp>
+      <p:sp>
+        <p:nvSpPr>
+          <p:cNvPr id="53" name="Text 51"/>
+          <p:cNvSpPr/>
+          <p:nvPr/>
+        </p:nvSpPr>
+        <p:spPr>
+          <a:xfrm>
+            <a:off x="10007194" y="3044952"/>
+            <a:ext cx="1532534" cy="566928"/>
+          </a:xfrm>
+          <a:prstGeom prst="rect">
+            <a:avLst/>
+          </a:prstGeom>
+          <a:noFill/>
+          <a:ln/>
+        </p:spPr>
+        <p:txBody>
+          <a:bodyPr wrap="square" lIns="0" tIns="0" rIns="0" bIns="0" rtlCol="0" anchor="t"/>
           <a:lstStyle/>
           <a:p>
             <a:pPr indent="0" marL="0">
@@ -4711,29 +5122,29 @@
               <a:buNone/>
             </a:pPr>
             <a:r>
-              <a:rPr lang="en-US" sz="1250" b="1" dirty="0">
-                <a:solidFill>
-                  <a:srgbClr val="12315B"/>
-                </a:solidFill>
-                <a:latin typeface="Calibri" pitchFamily="34" charset="0"/>
-                <a:ea typeface="Calibri" pitchFamily="34" charset="-122"/>
-                <a:cs typeface="Calibri" pitchFamily="34" charset="-120"/>
-              </a:rPr>
-              <a:t>Underwriter decision</a:t>
-            </a:r>
-            <a:endParaRPr lang="en-US" sz="1250" dirty="0"/>
-          </a:p>
-        </p:txBody>
-      </p:sp>
-      <p:sp>
-        <p:nvSpPr>
-          <p:cNvPr id="47" name="Shape 45"/>
-          <p:cNvSpPr/>
-          <p:nvPr/>
-        </p:nvSpPr>
-        <p:spPr>
-          <a:xfrm>
-            <a:off x="9842602" y="3172968"/>
+              <a:rPr lang="en-US" sz="950" dirty="0">
+                <a:solidFill>
+                  <a:srgbClr val="5A6472"/>
+                </a:solidFill>
+                <a:latin typeface="Calibri" pitchFamily="34" charset="0"/>
+                <a:ea typeface="Calibri" pitchFamily="34" charset="-122"/>
+                <a:cs typeface="Calibri" pitchFamily="34" charset="-120"/>
+              </a:rPr>
+              <a:t>Per-segment realised vs predicted; writeback to appetite</a:t>
+            </a:r>
+            <a:endParaRPr lang="en-US" sz="950" dirty="0"/>
+          </a:p>
+        </p:txBody>
+      </p:sp>
+      <p:sp>
+        <p:nvSpPr>
+          <p:cNvPr id="54" name="Shape 52"/>
+          <p:cNvSpPr/>
+          <p:nvPr/>
+        </p:nvSpPr>
+        <p:spPr>
+          <a:xfrm>
+            <a:off x="9842602" y="3730752"/>
             <a:ext cx="73152" cy="73152"/>
           </a:xfrm>
           <a:prstGeom prst="rect">
@@ -4747,14 +5158,14 @@
       </p:sp>
       <p:sp>
         <p:nvSpPr>
-          <p:cNvPr id="48" name="Text 46"/>
-          <p:cNvSpPr/>
-          <p:nvPr/>
-        </p:nvSpPr>
-        <p:spPr>
-          <a:xfrm>
-            <a:off x="10007194" y="3090672"/>
-            <a:ext cx="1532534" cy="548640"/>
+          <p:cNvPr id="55" name="Text 53"/>
+          <p:cNvSpPr/>
+          <p:nvPr/>
+        </p:nvSpPr>
+        <p:spPr>
+          <a:xfrm>
+            <a:off x="10007194" y="3648456"/>
+            <a:ext cx="1532534" cy="566928"/>
           </a:xfrm>
           <a:prstGeom prst="rect">
             <a:avLst/>
@@ -4773,7 +5184,7 @@
               <a:buNone/>
             </a:pPr>
             <a:r>
-              <a:rPr lang="en-US" sz="1000" dirty="0">
+              <a:rPr lang="en-US" sz="950" dirty="0">
                 <a:solidFill>
                   <a:srgbClr val="5A6472"/>
                 </a:solidFill>
@@ -4781,77 +5192,15 @@
                 <a:ea typeface="Calibri" pitchFamily="34" charset="-122"/>
                 <a:cs typeface="Calibri" pitchFamily="34" charset="-120"/>
               </a:rPr>
-              <a:t>Reviews the decision-ready package</a:t>
-            </a:r>
-            <a:endParaRPr lang="en-US" sz="1000" dirty="0"/>
-          </a:p>
-        </p:txBody>
-      </p:sp>
-      <p:sp>
-        <p:nvSpPr>
-          <p:cNvPr id="49" name="Shape 47"/>
-          <p:cNvSpPr/>
-          <p:nvPr/>
-        </p:nvSpPr>
-        <p:spPr>
-          <a:xfrm>
-            <a:off x="9842602" y="3758184"/>
-            <a:ext cx="73152" cy="73152"/>
-          </a:xfrm>
-          <a:prstGeom prst="rect">
-            <a:avLst/>
-          </a:prstGeom>
-          <a:solidFill>
-            <a:srgbClr val="2E6FB5"/>
-          </a:solidFill>
-          <a:ln/>
-        </p:spPr>
-      </p:sp>
-      <p:sp>
-        <p:nvSpPr>
-          <p:cNvPr id="50" name="Text 48"/>
-          <p:cNvSpPr/>
-          <p:nvPr/>
-        </p:nvSpPr>
-        <p:spPr>
-          <a:xfrm>
-            <a:off x="10007194" y="3675888"/>
-            <a:ext cx="1532534" cy="548640"/>
-          </a:xfrm>
-          <a:prstGeom prst="rect">
-            <a:avLst/>
-          </a:prstGeom>
-          <a:noFill/>
-          <a:ln/>
-        </p:spPr>
-        <p:txBody>
-          <a:bodyPr wrap="square" lIns="0" tIns="0" rIns="0" bIns="0" rtlCol="0" anchor="t"/>
-          <a:lstStyle/>
-          <a:p>
-            <a:pPr indent="0" marL="0">
-              <a:lnSpc>
-                <a:spcPct val="95000"/>
-              </a:lnSpc>
-              <a:buNone/>
-            </a:pPr>
-            <a:r>
-              <a:rPr lang="en-US" sz="1000" dirty="0">
-                <a:solidFill>
-                  <a:srgbClr val="5A6472"/>
-                </a:solidFill>
-                <a:latin typeface="Calibri" pitchFamily="34" charset="0"/>
-                <a:ea typeface="Calibri" pitchFamily="34" charset="-122"/>
-                <a:cs typeface="Calibri" pitchFamily="34" charset="-120"/>
-              </a:rPr>
-              <a:t>Judges complex risks, binds &amp; documents</a:t>
-            </a:r>
-            <a:endParaRPr lang="en-US" sz="1000" dirty="0"/>
-          </a:p>
-        </p:txBody>
-      </p:sp>
-      <p:sp>
-        <p:nvSpPr>
-          <p:cNvPr id="51" name="Text 49"/>
+              <a:t>Bind lift held; loss ratio inside the limit</a:t>
+            </a:r>
+            <a:endParaRPr lang="en-US" sz="950" dirty="0"/>
+          </a:p>
+        </p:txBody>
+      </p:sp>
+      <p:sp>
+        <p:nvSpPr>
+          <p:cNvPr id="56" name="Text 54"/>
           <p:cNvSpPr/>
           <p:nvPr/>
         </p:nvSpPr>
@@ -4882,7 +5231,7 @@
                 <a:ea typeface="Calibri" pitchFamily="34" charset="-122"/>
                 <a:cs typeface="Calibri" pitchFamily="34" charset="-120"/>
               </a:rPr>
-              <a:t>ENABLING DATA &amp; SYSTEMS   </a:t>
+              <a:t>MODELS &amp; GUARDRAILS   </a:t>
             </a:r>
             <a:pPr indent="0" marL="0">
               <a:buNone/>
@@ -4896,7 +5245,7 @@
                 <a:ea typeface="Calibri" pitchFamily="34" charset="-122"/>
                 <a:cs typeface="Calibri" pitchFamily="34" charset="-120"/>
               </a:rPr>
-              <a:t>UW workbench · Document AI · Third-party data vendors · Catastrophe models · Rating engine · Policy admin</a:t>
+              <a:t>Liberty submission + loss data · elasticity-aware pricing · rate-adequacy floor · loss-ratio limit · pricing-consistency (NAIC 24-08)</a:t>
             </a:r>
             <a:endParaRPr lang="en-US" sz="1050" dirty="0"/>
           </a:p>
@@ -4904,7 +5253,7 @@
       </p:sp>
       <p:sp>
         <p:nvSpPr>
-          <p:cNvPr id="52" name="Shape 50"/>
+          <p:cNvPr id="57" name="Shape 55"/>
           <p:cNvSpPr/>
           <p:nvPr/>
         </p:nvSpPr>
@@ -4927,14 +5276,14 @@
       </p:sp>
       <p:sp>
         <p:nvSpPr>
-          <p:cNvPr id="53" name="Text 51"/>
+          <p:cNvPr id="58" name="Text 56"/>
           <p:cNvSpPr/>
           <p:nvPr/>
         </p:nvSpPr>
         <p:spPr>
           <a:xfrm>
             <a:off x="457200" y="4937760"/>
-            <a:ext cx="5486400" cy="256032"/>
+            <a:ext cx="6400800" cy="256032"/>
           </a:xfrm>
           <a:prstGeom prst="rect">
             <a:avLst/>
@@ -4950,7 +5299,7 @@
               <a:buNone/>
             </a:pPr>
             <a:r>
-              <a:rPr lang="en-US" sz="1100" b="1" spc="200" kern="0" dirty="0">
+              <a:rPr lang="en-US" sz="1100" b="1" spc="100" kern="0" dirty="0">
                 <a:solidFill>
                   <a:srgbClr val="12315B"/>
                 </a:solidFill>
@@ -4958,7 +5307,7 @@
                 <a:ea typeface="Calibri" pitchFamily="34" charset="-122"/>
                 <a:cs typeface="Calibri" pitchFamily="34" charset="-120"/>
               </a:rPr>
-              <a:t>THE PAYOFF</a:t>
+              <a:t>PROOF  ·  SIMULATED, THEN MEASURED IN PILOT</a:t>
             </a:r>
             <a:endParaRPr lang="en-US" sz="1100" dirty="0"/>
           </a:p>
@@ -4966,7 +5315,7 @@
       </p:sp>
       <p:sp>
         <p:nvSpPr>
-          <p:cNvPr id="54" name="Shape 52"/>
+          <p:cNvPr id="59" name="Shape 57"/>
           <p:cNvSpPr/>
           <p:nvPr/>
         </p:nvSpPr>
@@ -4993,7 +5342,7 @@
       </p:sp>
       <p:sp>
         <p:nvSpPr>
-          <p:cNvPr id="55" name="Text 53"/>
+          <p:cNvPr id="60" name="Text 58"/>
           <p:cNvSpPr/>
           <p:nvPr/>
         </p:nvSpPr>
@@ -5016,7 +5365,7 @@
               <a:buNone/>
             </a:pPr>
             <a:r>
-              <a:rPr lang="en-US" sz="2500" b="1" dirty="0">
+              <a:rPr lang="en-US" sz="2200" b="1" dirty="0">
                 <a:solidFill>
                   <a:srgbClr val="12315B"/>
                 </a:solidFill>
@@ -5024,13 +5373,13 @@
                 <a:ea typeface="Cambria" pitchFamily="34" charset="-122"/>
                 <a:cs typeface="Cambria" pitchFamily="34" charset="-120"/>
               </a:rPr>
-              <a:t>40</a:t>
+              <a:t>8.4→19.1</a:t>
             </a:r>
             <a:pPr algn="ctr" indent="0" marL="0">
               <a:buNone/>
             </a:pPr>
             <a:r>
-              <a:rPr lang="en-US" sz="1300" b="1" dirty="0">
+              <a:rPr lang="en-US" sz="1200" b="1" dirty="0">
                 <a:solidFill>
                   <a:srgbClr val="2E6FB5"/>
                 </a:solidFill>
@@ -5038,15 +5387,15 @@
                 <a:ea typeface="Cambria" pitchFamily="34" charset="-122"/>
                 <a:cs typeface="Cambria" pitchFamily="34" charset="-120"/>
               </a:rPr>
-              <a:t>%</a:t>
-            </a:r>
-            <a:endParaRPr lang="en-US" sz="2500" dirty="0"/>
-          </a:p>
-        </p:txBody>
-      </p:sp>
-      <p:sp>
-        <p:nvSpPr>
-          <p:cNvPr id="56" name="Text 54"/>
+              <a:t> %</a:t>
+            </a:r>
+            <a:endParaRPr lang="en-US" sz="2200" dirty="0"/>
+          </a:p>
+        </p:txBody>
+      </p:sp>
+      <p:sp>
+        <p:nvSpPr>
+          <p:cNvPr id="61" name="Text 59"/>
           <p:cNvSpPr/>
           <p:nvPr/>
         </p:nvSpPr>
@@ -5080,7 +5429,7 @@
                 <a:ea typeface="Calibri" pitchFamily="34" charset="-122"/>
                 <a:cs typeface="Calibri" pitchFamily="34" charset="-120"/>
               </a:rPr>
-              <a:t>Faster quote turnaround on in-appetite risks</a:t>
+              <a:t>Quote-to-bind conversion</a:t>
             </a:r>
             <a:endParaRPr lang="en-US" sz="950" dirty="0"/>
           </a:p>
@@ -5088,7 +5437,7 @@
       </p:sp>
       <p:sp>
         <p:nvSpPr>
-          <p:cNvPr id="57" name="Shape 55"/>
+          <p:cNvPr id="62" name="Shape 60"/>
           <p:cNvSpPr/>
           <p:nvPr/>
         </p:nvSpPr>
@@ -5115,7 +5464,7 @@
       </p:sp>
       <p:sp>
         <p:nvSpPr>
-          <p:cNvPr id="58" name="Text 56"/>
+          <p:cNvPr id="63" name="Text 61"/>
           <p:cNvSpPr/>
           <p:nvPr/>
         </p:nvSpPr>
@@ -5138,7 +5487,7 @@
               <a:buNone/>
             </a:pPr>
             <a:r>
-              <a:rPr lang="en-US" sz="2500" b="1" dirty="0">
+              <a:rPr lang="en-US" sz="2200" b="1" dirty="0">
                 <a:solidFill>
                   <a:srgbClr val="12315B"/>
                 </a:solidFill>
@@ -5146,29 +5495,18 @@
                 <a:ea typeface="Cambria" pitchFamily="34" charset="-122"/>
                 <a:cs typeface="Cambria" pitchFamily="34" charset="-120"/>
               </a:rPr>
-              <a:t>60</a:t>
+              <a:t>+$31M</a:t>
             </a:r>
             <a:pPr algn="ctr" indent="0" marL="0">
               <a:buNone/>
             </a:pPr>
-            <a:r>
-              <a:rPr lang="en-US" sz="1300" b="1" dirty="0">
-                <a:solidFill>
-                  <a:srgbClr val="2E6FB5"/>
-                </a:solidFill>
-                <a:latin typeface="Cambria" pitchFamily="34" charset="0"/>
-                <a:ea typeface="Cambria" pitchFamily="34" charset="-122"/>
-                <a:cs typeface="Cambria" pitchFamily="34" charset="-120"/>
-              </a:rPr>
-              <a:t>%</a:t>
-            </a:r>
-            <a:endParaRPr lang="en-US" sz="2500" dirty="0"/>
-          </a:p>
-        </p:txBody>
-      </p:sp>
-      <p:sp>
-        <p:nvSpPr>
-          <p:cNvPr id="59" name="Text 57"/>
+            <a:endParaRPr lang="en-US" sz="2200" dirty="0"/>
+          </a:p>
+        </p:txBody>
+      </p:sp>
+      <p:sp>
+        <p:nvSpPr>
+          <p:cNvPr id="64" name="Text 62"/>
           <p:cNvSpPr/>
           <p:nvPr/>
         </p:nvSpPr>
@@ -5202,7 +5540,7 @@
                 <a:ea typeface="Calibri" pitchFamily="34" charset="-122"/>
                 <a:cs typeface="Calibri" pitchFamily="34" charset="-120"/>
               </a:rPr>
-              <a:t>Straight-through triage on clean submissions</a:t>
+              <a:t>Incremental Yr-1 NWP</a:t>
             </a:r>
             <a:endParaRPr lang="en-US" sz="950" dirty="0"/>
           </a:p>
@@ -5210,7 +5548,7 @@
       </p:sp>
       <p:sp>
         <p:nvSpPr>
-          <p:cNvPr id="60" name="Shape 58"/>
+          <p:cNvPr id="65" name="Shape 63"/>
           <p:cNvSpPr/>
           <p:nvPr/>
         </p:nvSpPr>
@@ -5237,7 +5575,7 @@
       </p:sp>
       <p:sp>
         <p:nvSpPr>
-          <p:cNvPr id="61" name="Text 59"/>
+          <p:cNvPr id="66" name="Text 64"/>
           <p:cNvSpPr/>
           <p:nvPr/>
         </p:nvSpPr>
@@ -5260,7 +5598,7 @@
               <a:buNone/>
             </a:pPr>
             <a:r>
-              <a:rPr lang="en-US" sz="2500" b="1" dirty="0">
+              <a:rPr lang="en-US" sz="2200" b="1" dirty="0">
                 <a:solidFill>
                   <a:srgbClr val="12315B"/>
                 </a:solidFill>
@@ -5268,29 +5606,18 @@
                 <a:ea typeface="Cambria" pitchFamily="34" charset="-122"/>
                 <a:cs typeface="Cambria" pitchFamily="34" charset="-120"/>
               </a:rPr>
-              <a:t>2–3</a:t>
+              <a:t>+0.4</a:t>
             </a:r>
             <a:pPr algn="ctr" indent="0" marL="0">
               <a:buNone/>
             </a:pPr>
-            <a:r>
-              <a:rPr lang="en-US" sz="1300" b="1" dirty="0">
-                <a:solidFill>
-                  <a:srgbClr val="2E6FB5"/>
-                </a:solidFill>
-                <a:latin typeface="Cambria" pitchFamily="34" charset="0"/>
-                <a:ea typeface="Cambria" pitchFamily="34" charset="-122"/>
-                <a:cs typeface="Cambria" pitchFamily="34" charset="-120"/>
-              </a:rPr>
-              <a:t>pts</a:t>
-            </a:r>
-            <a:endParaRPr lang="en-US" sz="2500" dirty="0"/>
-          </a:p>
-        </p:txBody>
-      </p:sp>
-      <p:sp>
-        <p:nvSpPr>
-          <p:cNvPr id="62" name="Text 60"/>
+            <a:endParaRPr lang="en-US" sz="2200" dirty="0"/>
+          </a:p>
+        </p:txBody>
+      </p:sp>
+      <p:sp>
+        <p:nvSpPr>
+          <p:cNvPr id="67" name="Text 65"/>
           <p:cNvSpPr/>
           <p:nvPr/>
         </p:nvSpPr>
@@ -5324,7 +5651,7 @@
                 <a:ea typeface="Calibri" pitchFamily="34" charset="-122"/>
                 <a:cs typeface="Calibri" pitchFamily="34" charset="-120"/>
               </a:rPr>
-              <a:t>Loss-ratio gain from sharper selection</a:t>
+              <a:t>Lines per account (cross-line)</a:t>
             </a:r>
             <a:endParaRPr lang="en-US" sz="950" dirty="0"/>
           </a:p>
@@ -5332,7 +5659,7 @@
       </p:sp>
       <p:sp>
         <p:nvSpPr>
-          <p:cNvPr id="63" name="Shape 61"/>
+          <p:cNvPr id="68" name="Shape 66"/>
           <p:cNvSpPr/>
           <p:nvPr/>
         </p:nvSpPr>
@@ -5354,7 +5681,7 @@
       </p:sp>
       <p:sp>
         <p:nvSpPr>
-          <p:cNvPr id="64" name="Text 62"/>
+          <p:cNvPr id="69" name="Text 67"/>
           <p:cNvSpPr/>
           <p:nvPr/>
         </p:nvSpPr>
@@ -5385,7 +5712,7 @@
                 <a:ea typeface="Calibri" pitchFamily="34" charset="-122"/>
                 <a:cs typeface="Calibri" pitchFamily="34" charset="-120"/>
               </a:rPr>
-              <a:t>COMPOUNDING ADVANTAGE</a:t>
+              <a:t>WHERE NOT TO ACT</a:t>
             </a:r>
             <a:endParaRPr lang="en-US" sz="1100" dirty="0"/>
           </a:p>
@@ -5393,14 +5720,14 @@
       </p:sp>
       <p:sp>
         <p:nvSpPr>
-          <p:cNvPr id="65" name="Text 63"/>
-          <p:cNvSpPr/>
-          <p:nvPr/>
-        </p:nvSpPr>
-        <p:spPr>
-          <a:xfrm>
-            <a:off x="7662672" y="5394960"/>
-            <a:ext cx="3840480" cy="777240"/>
+          <p:cNvPr id="70" name="Text 68"/>
+          <p:cNvSpPr/>
+          <p:nvPr/>
+        </p:nvSpPr>
+        <p:spPr>
+          <a:xfrm>
+            <a:off x="7662672" y="5376672"/>
+            <a:ext cx="3840480" cy="822960"/>
           </a:xfrm>
           <a:prstGeom prst="rect">
             <a:avLst/>
@@ -5414,12 +5741,12 @@
           <a:p>
             <a:pPr indent="0" marL="0">
               <a:lnSpc>
-                <a:spcPct val="100000"/>
+                <a:spcPct val="98000"/>
               </a:lnSpc>
               <a:buNone/>
             </a:pPr>
             <a:r>
-              <a:rPr lang="en-US" sz="1200" dirty="0">
+              <a:rPr lang="en-US" sz="1100" dirty="0">
                 <a:solidFill>
                   <a:srgbClr val="FFFFFF"/>
                 </a:solidFill>
@@ -5427,15 +5754,15 @@
                 <a:ea typeface="Calibri" pitchFamily="34" charset="-122"/>
                 <a:cs typeface="Calibri" pitchFamily="34" charset="-120"/>
               </a:rPr>
-              <a:t>Bound-account outcomes and emerging losses retrain the appetite and pricing models, compounding into a durable underwriting edge.</a:t>
-            </a:r>
-            <a:endParaRPr lang="en-US" sz="1200" dirty="0"/>
-          </a:p>
-        </p:txBody>
-      </p:sp>
-      <p:sp>
-        <p:nvSpPr>
-          <p:cNvPr id="66" name="Shape 64"/>
+              <a:t>The Watch / Hold segment — ~2,900 accounts with an adverse loss trend and thin rate adequacy — gets NO quote. Writing it would buy conversion below adequacy and re-open the loss-ratio problem.</a:t>
+            </a:r>
+            <a:endParaRPr lang="en-US" sz="1100" dirty="0"/>
+          </a:p>
+        </p:txBody>
+      </p:sp>
+      <p:sp>
+        <p:nvSpPr>
+          <p:cNvPr id="71" name="Shape 69"/>
           <p:cNvSpPr/>
           <p:nvPr/>
         </p:nvSpPr>
@@ -5458,7 +5785,7 @@
       </p:sp>
       <p:sp>
         <p:nvSpPr>
-          <p:cNvPr id="67" name="Text 65"/>
+          <p:cNvPr id="72" name="Text 70"/>
           <p:cNvSpPr/>
           <p:nvPr/>
         </p:nvSpPr>
@@ -5489,7 +5816,7 @@
                 <a:ea typeface="Calibri" pitchFamily="34" charset="-122"/>
                 <a:cs typeface="Calibri" pitchFamily="34" charset="-120"/>
               </a:rPr>
-              <a:t>Liberty Mutual  |  AI Signal Portfolio</a:t>
+              <a:t>Liberty Mutual · TwinX Decision Cockpit</a:t>
             </a:r>
             <a:endParaRPr lang="en-US" sz="900" dirty="0"/>
           </a:p>
@@ -5497,7 +5824,7 @@
       </p:sp>
       <p:sp>
         <p:nvSpPr>
-          <p:cNvPr id="68" name="Text 66"/>
+          <p:cNvPr id="73" name="Text 71"/>
           <p:cNvSpPr/>
           <p:nvPr/>
         </p:nvSpPr>
@@ -5536,7 +5863,7 @@
       </p:sp>
       <p:sp>
         <p:nvSpPr>
-          <p:cNvPr id="69" name="Text 67"/>
+          <p:cNvPr id="74" name="Text 72"/>
           <p:cNvSpPr/>
           <p:nvPr/>
         </p:nvSpPr>

</xml_diff>